<commit_message>
Fix Airier PPTX body logo compatibility with directly embedded transparent PNGs
</commit_message>
<xml_diff>
--- a/teacher-agent-creators-10min/downloads/UNESCO_Teacher_AI_Agents_EN_Airier.pptx
+++ b/teacher-agent-creators-10min/downloads/UNESCO_Teacher_AI_Agents_EN_Airier.pptx
@@ -2,29 +2,29 @@
 <file path=ppt/presentation.xml><?xml version="1.0" encoding="utf-8"?>
 <p:presentation xmlns:p="http://schemas.openxmlformats.org/presentationml/2006/main">
   <p:sldMasterIdLst>
-    <p:sldMasterId xmlns:r="http://schemas.openxmlformats.org/officeDocument/2006/relationships" id="2147483648" r:id="R278efd6093e041d1"/>
+    <p:sldMasterId xmlns:r="http://schemas.openxmlformats.org/officeDocument/2006/relationships" id="2147483648" r:id="R86d87ec3cb6c4ffe"/>
   </p:sldMasterIdLst>
   <p:notesMasterIdLst>
-    <p:notesMasterId xmlns:r="http://schemas.openxmlformats.org/officeDocument/2006/relationships" r:id="Rba131fb6c39e479d"/>
+    <p:notesMasterId xmlns:r="http://schemas.openxmlformats.org/officeDocument/2006/relationships" r:id="Rf617e46854aa4ebc"/>
   </p:notesMasterIdLst>
   <p:sldIdLst>
-    <p:sldId xmlns:r="http://schemas.openxmlformats.org/officeDocument/2006/relationships" id="256" r:id="Rc3f9d0fea2aa4a22"/>
-    <p:sldId xmlns:r="http://schemas.openxmlformats.org/officeDocument/2006/relationships" id="257" r:id="Rc774e5836c6044c1"/>
-    <p:sldId xmlns:r="http://schemas.openxmlformats.org/officeDocument/2006/relationships" id="258" r:id="Rb0680fbaacee4c28"/>
-    <p:sldId xmlns:r="http://schemas.openxmlformats.org/officeDocument/2006/relationships" id="259" r:id="Rcea629e0549f4b28"/>
-    <p:sldId xmlns:r="http://schemas.openxmlformats.org/officeDocument/2006/relationships" id="260" r:id="R144e60ad60c140d4"/>
-    <p:sldId xmlns:r="http://schemas.openxmlformats.org/officeDocument/2006/relationships" id="261" r:id="R7d10dbb2503a4629"/>
-    <p:sldId xmlns:r="http://schemas.openxmlformats.org/officeDocument/2006/relationships" id="262" r:id="Ra258ff5e128a4589"/>
-    <p:sldId xmlns:r="http://schemas.openxmlformats.org/officeDocument/2006/relationships" id="263" r:id="R538dd49351ba4c84"/>
-    <p:sldId xmlns:r="http://schemas.openxmlformats.org/officeDocument/2006/relationships" id="264" r:id="R6b42670c1a8e47b2"/>
-    <p:sldId xmlns:r="http://schemas.openxmlformats.org/officeDocument/2006/relationships" id="265" r:id="R261571e4de6d453f"/>
-    <p:sldId xmlns:r="http://schemas.openxmlformats.org/officeDocument/2006/relationships" id="266" r:id="R1cb3696236dd4908"/>
-    <p:sldId xmlns:r="http://schemas.openxmlformats.org/officeDocument/2006/relationships" id="267" r:id="R6ce8694751dc4634"/>
-    <p:sldId xmlns:r="http://schemas.openxmlformats.org/officeDocument/2006/relationships" id="268" r:id="R638ce1d4fbe54fde"/>
-    <p:sldId xmlns:r="http://schemas.openxmlformats.org/officeDocument/2006/relationships" id="269" r:id="Rb32b8ac1a0b64e3c"/>
-    <p:sldId xmlns:r="http://schemas.openxmlformats.org/officeDocument/2006/relationships" id="270" r:id="R8a8c0210d66f41a1"/>
-    <p:sldId xmlns:r="http://schemas.openxmlformats.org/officeDocument/2006/relationships" id="271" r:id="R0be704a08a4b45f4"/>
-    <p:sldId xmlns:r="http://schemas.openxmlformats.org/officeDocument/2006/relationships" id="272" r:id="R05f5ed7bba194945"/>
+    <p:sldId xmlns:r="http://schemas.openxmlformats.org/officeDocument/2006/relationships" id="256" r:id="R3f41c13d4ea64858"/>
+    <p:sldId xmlns:r="http://schemas.openxmlformats.org/officeDocument/2006/relationships" id="257" r:id="R86200c3291344b23"/>
+    <p:sldId xmlns:r="http://schemas.openxmlformats.org/officeDocument/2006/relationships" id="258" r:id="R240f25d14d8c4238"/>
+    <p:sldId xmlns:r="http://schemas.openxmlformats.org/officeDocument/2006/relationships" id="259" r:id="R4cf082bcffa14d05"/>
+    <p:sldId xmlns:r="http://schemas.openxmlformats.org/officeDocument/2006/relationships" id="260" r:id="Rbddf10aab8784f2e"/>
+    <p:sldId xmlns:r="http://schemas.openxmlformats.org/officeDocument/2006/relationships" id="261" r:id="Rbf2f6e1f38a441a5"/>
+    <p:sldId xmlns:r="http://schemas.openxmlformats.org/officeDocument/2006/relationships" id="262" r:id="Ra01a36d224d344a1"/>
+    <p:sldId xmlns:r="http://schemas.openxmlformats.org/officeDocument/2006/relationships" id="263" r:id="R9f10fd9fc1d34b91"/>
+    <p:sldId xmlns:r="http://schemas.openxmlformats.org/officeDocument/2006/relationships" id="264" r:id="Rcf651495192d4fcc"/>
+    <p:sldId xmlns:r="http://schemas.openxmlformats.org/officeDocument/2006/relationships" id="265" r:id="R71b739a9f0cf4336"/>
+    <p:sldId xmlns:r="http://schemas.openxmlformats.org/officeDocument/2006/relationships" id="266" r:id="Rd8f073dcec874e60"/>
+    <p:sldId xmlns:r="http://schemas.openxmlformats.org/officeDocument/2006/relationships" id="267" r:id="R867e6d4fd53a4a7e"/>
+    <p:sldId xmlns:r="http://schemas.openxmlformats.org/officeDocument/2006/relationships" id="268" r:id="Rbbbd927a62ca4394"/>
+    <p:sldId xmlns:r="http://schemas.openxmlformats.org/officeDocument/2006/relationships" id="269" r:id="Ra1417d827650414d"/>
+    <p:sldId xmlns:r="http://schemas.openxmlformats.org/officeDocument/2006/relationships" id="270" r:id="Rf8c706bd96634a94"/>
+    <p:sldId xmlns:r="http://schemas.openxmlformats.org/officeDocument/2006/relationships" id="271" r:id="R28758e5ee2424d55"/>
+    <p:sldId xmlns:r="http://schemas.openxmlformats.org/officeDocument/2006/relationships" id="272" r:id="R6f91415e71a7458f"/>
   </p:sldIdLst>
   <p:sldSz cx="12192000" cy="6858000"/>
   <p:notesSz cx="6858000" cy="9144000"/>
@@ -2416,7 +2416,7 @@
   </p:cSld>
   <p:clrMap bg1="lt1" tx1="dk1" bg2="lt2" tx2="dk2" accent1="accent1" accent2="accent2" accent3="accent3" accent4="accent4" accent5="accent5" accent6="accent6" hlink="hlink" folHlink="folHlink"/>
   <p:sldLayoutIdLst>
-    <p:sldLayoutId xmlns:r="http://schemas.openxmlformats.org/officeDocument/2006/relationships" id="2147483649" r:id="Rec6545cc1c8f48bd"/>
+    <p:sldLayoutId xmlns:r="http://schemas.openxmlformats.org/officeDocument/2006/relationships" id="2147483649" r:id="Rfd1e0d6f064741f9"/>
   </p:sldLayoutIdLst>
   <p:txStyles>
     <p:titleStyle>
@@ -2971,7 +2971,7 @@
           <p:nvPr/>
         </p:nvPicPr>
         <p:blipFill>
-          <a:blip xmlns:r="http://schemas.openxmlformats.org/officeDocument/2006/relationships" xmlns:a="http://schemas.openxmlformats.org/drawingml/2006/main" r:embed="Rbeeaf4305f564177"/>
+          <a:blip xmlns:r="http://schemas.openxmlformats.org/officeDocument/2006/relationships" xmlns:a="http://schemas.openxmlformats.org/drawingml/2006/main" r:embed="Rbc9be50d8ee94137"/>
           <a:stretch xmlns:a="http://schemas.openxmlformats.org/drawingml/2006/main"/>
         </p:blipFill>
         <p:spPr>
@@ -2993,7 +2993,7 @@
           <p:nvPr/>
         </p:nvPicPr>
         <p:blipFill>
-          <a:blip xmlns:r="http://schemas.openxmlformats.org/officeDocument/2006/relationships" xmlns:a="http://schemas.openxmlformats.org/drawingml/2006/main" r:embed="Rd8bfd636b0a34135"/>
+          <a:blip xmlns:r="http://schemas.openxmlformats.org/officeDocument/2006/relationships" xmlns:a="http://schemas.openxmlformats.org/drawingml/2006/main" r:embed="R44ac987ab427471d"/>
           <a:srcRect xmlns:a="http://schemas.openxmlformats.org/drawingml/2006/main" l="0" t="0" r="0" b="0"/>
           <a:stretch xmlns:a="http://schemas.openxmlformats.org/drawingml/2006/main"/>
         </p:blipFill>
@@ -4862,14 +4862,7 @@
           <p:nvPr/>
         </p:nvPicPr>
         <p:blipFill>
-          <a:blip xmlns:r="http://schemas.openxmlformats.org/officeDocument/2006/relationships" xmlns:a="http://schemas.openxmlformats.org/drawingml/2006/main" r:embed="R3c7a3f24af1f4998">
-            <a:extLst>
-              <a:ext uri="{96DAC541-7B7A-43D3-8B79-37D633B846F1}">
-                <asvg:svgBlip xmlns:asvg="http://schemas.microsoft.com/office/drawing/2016/SVG/main" r:embed="R8b2b384c178d437a"/>
-              </a:ext>
-            </a:extLst>
-          </a:blip>
-          <a:srcRect xmlns:a="http://schemas.openxmlformats.org/drawingml/2006/main" l="0" t="0" r="0" b="0"/>
+          <a:blip xmlns:r="http://schemas.openxmlformats.org/officeDocument/2006/relationships" xmlns:a="http://schemas.openxmlformats.org/drawingml/2006/main" r:embed="Rf2894ca9cb1745f2"/>
           <a:stretch xmlns:a="http://schemas.openxmlformats.org/drawingml/2006/main"/>
         </p:blipFill>
         <p:spPr>
@@ -5374,7 +5367,7 @@
           <p:nvPr/>
         </p:nvPicPr>
         <p:blipFill>
-          <a:blip xmlns:r="http://schemas.openxmlformats.org/officeDocument/2006/relationships" xmlns:a="http://schemas.openxmlformats.org/drawingml/2006/main" r:embed="R233c6e1617fc497c"/>
+          <a:blip xmlns:r="http://schemas.openxmlformats.org/officeDocument/2006/relationships" xmlns:a="http://schemas.openxmlformats.org/drawingml/2006/main" r:embed="Ra19e21ee3f2b4d99"/>
           <a:stretch xmlns:a="http://schemas.openxmlformats.org/drawingml/2006/main"/>
         </p:blipFill>
         <p:spPr>
@@ -5670,14 +5663,7 @@
           <p:nvPr/>
         </p:nvPicPr>
         <p:blipFill>
-          <a:blip xmlns:r="http://schemas.openxmlformats.org/officeDocument/2006/relationships" xmlns:a="http://schemas.openxmlformats.org/drawingml/2006/main" r:embed="R758e26a8cd2143a4">
-            <a:extLst>
-              <a:ext uri="{96DAC541-7B7A-43D3-8B79-37D633B846F1}">
-                <asvg:svgBlip xmlns:asvg="http://schemas.microsoft.com/office/drawing/2016/SVG/main" r:embed="R9b0d7d94685f4617"/>
-              </a:ext>
-            </a:extLst>
-          </a:blip>
-          <a:srcRect xmlns:a="http://schemas.openxmlformats.org/drawingml/2006/main" l="0" t="0" r="0" b="0"/>
+          <a:blip xmlns:r="http://schemas.openxmlformats.org/officeDocument/2006/relationships" xmlns:a="http://schemas.openxmlformats.org/drawingml/2006/main" r:embed="R5728d907d08746db"/>
           <a:stretch xmlns:a="http://schemas.openxmlformats.org/drawingml/2006/main"/>
         </p:blipFill>
         <p:spPr>
@@ -6148,7 +6134,7 @@
           <p:nvPr/>
         </p:nvPicPr>
         <p:blipFill>
-          <a:blip xmlns:r="http://schemas.openxmlformats.org/officeDocument/2006/relationships" xmlns:a="http://schemas.openxmlformats.org/drawingml/2006/main" r:embed="Ra948c1da35764072"/>
+          <a:blip xmlns:r="http://schemas.openxmlformats.org/officeDocument/2006/relationships" xmlns:a="http://schemas.openxmlformats.org/drawingml/2006/main" r:embed="Rf25aff374a0748bc"/>
           <a:srcRect xmlns:a="http://schemas.openxmlformats.org/drawingml/2006/main" l="7910" t="0" r="7910" b="0"/>
           <a:stretch xmlns:a="http://schemas.openxmlformats.org/drawingml/2006/main">
             <a:fillRect l="0" t="0" r="0" b="0"/>
@@ -6447,14 +6433,7 @@
           <p:nvPr/>
         </p:nvPicPr>
         <p:blipFill>
-          <a:blip xmlns:r="http://schemas.openxmlformats.org/officeDocument/2006/relationships" xmlns:a="http://schemas.openxmlformats.org/drawingml/2006/main" r:embed="R9c80983aa7d84006">
-            <a:extLst>
-              <a:ext uri="{96DAC541-7B7A-43D3-8B79-37D633B846F1}">
-                <asvg:svgBlip xmlns:asvg="http://schemas.microsoft.com/office/drawing/2016/SVG/main" r:embed="R489cf1af6f2149e3"/>
-              </a:ext>
-            </a:extLst>
-          </a:blip>
-          <a:srcRect xmlns:a="http://schemas.openxmlformats.org/drawingml/2006/main" l="0" t="0" r="0" b="0"/>
+          <a:blip xmlns:r="http://schemas.openxmlformats.org/officeDocument/2006/relationships" xmlns:a="http://schemas.openxmlformats.org/drawingml/2006/main" r:embed="R13e6f311f1fb489c"/>
           <a:stretch xmlns:a="http://schemas.openxmlformats.org/drawingml/2006/main"/>
         </p:blipFill>
         <p:spPr>
@@ -7748,14 +7727,7 @@
           <p:nvPr/>
         </p:nvPicPr>
         <p:blipFill>
-          <a:blip xmlns:r="http://schemas.openxmlformats.org/officeDocument/2006/relationships" xmlns:a="http://schemas.openxmlformats.org/drawingml/2006/main" r:embed="R8a3faf2a30b44fae">
-            <a:extLst>
-              <a:ext uri="{96DAC541-7B7A-43D3-8B79-37D633B846F1}">
-                <asvg:svgBlip xmlns:asvg="http://schemas.microsoft.com/office/drawing/2016/SVG/main" r:embed="Rfff351c03c714a37"/>
-              </a:ext>
-            </a:extLst>
-          </a:blip>
-          <a:srcRect xmlns:a="http://schemas.openxmlformats.org/drawingml/2006/main" l="0" t="0" r="0" b="0"/>
+          <a:blip xmlns:r="http://schemas.openxmlformats.org/officeDocument/2006/relationships" xmlns:a="http://schemas.openxmlformats.org/drawingml/2006/main" r:embed="Rceff311847f3427a"/>
           <a:stretch xmlns:a="http://schemas.openxmlformats.org/drawingml/2006/main"/>
         </p:blipFill>
         <p:spPr>
@@ -8945,14 +8917,7 @@
           <p:nvPr/>
         </p:nvPicPr>
         <p:blipFill>
-          <a:blip xmlns:r="http://schemas.openxmlformats.org/officeDocument/2006/relationships" xmlns:a="http://schemas.openxmlformats.org/drawingml/2006/main" r:embed="R63516a41f4fd418d">
-            <a:extLst>
-              <a:ext uri="{96DAC541-7B7A-43D3-8B79-37D633B846F1}">
-                <asvg:svgBlip xmlns:asvg="http://schemas.microsoft.com/office/drawing/2016/SVG/main" r:embed="R051e6de05fed42c8"/>
-              </a:ext>
-            </a:extLst>
-          </a:blip>
-          <a:srcRect xmlns:a="http://schemas.openxmlformats.org/drawingml/2006/main" l="0" t="0" r="0" b="0"/>
+          <a:blip xmlns:r="http://schemas.openxmlformats.org/officeDocument/2006/relationships" xmlns:a="http://schemas.openxmlformats.org/drawingml/2006/main" r:embed="R36974dca6a6c4f48"/>
           <a:stretch xmlns:a="http://schemas.openxmlformats.org/drawingml/2006/main"/>
         </p:blipFill>
         <p:spPr>
@@ -9975,14 +9940,7 @@
           <p:nvPr/>
         </p:nvPicPr>
         <p:blipFill>
-          <a:blip xmlns:r="http://schemas.openxmlformats.org/officeDocument/2006/relationships" xmlns:a="http://schemas.openxmlformats.org/drawingml/2006/main" r:embed="R6c92c212143e4c49">
-            <a:extLst>
-              <a:ext uri="{96DAC541-7B7A-43D3-8B79-37D633B846F1}">
-                <asvg:svgBlip xmlns:asvg="http://schemas.microsoft.com/office/drawing/2016/SVG/main" r:embed="R4a23941bc2244856"/>
-              </a:ext>
-            </a:extLst>
-          </a:blip>
-          <a:srcRect xmlns:a="http://schemas.openxmlformats.org/drawingml/2006/main" l="0" t="0" r="0" b="0"/>
+          <a:blip xmlns:r="http://schemas.openxmlformats.org/officeDocument/2006/relationships" xmlns:a="http://schemas.openxmlformats.org/drawingml/2006/main" r:embed="Re12e6aa7329b4508"/>
           <a:stretch xmlns:a="http://schemas.openxmlformats.org/drawingml/2006/main"/>
         </p:blipFill>
         <p:spPr>
@@ -10453,7 +10411,7 @@
           <p:nvPr/>
         </p:nvPicPr>
         <p:blipFill>
-          <a:blip xmlns:r="http://schemas.openxmlformats.org/officeDocument/2006/relationships" xmlns:a="http://schemas.openxmlformats.org/drawingml/2006/main" r:embed="Ra603a5de94e241a8"/>
+          <a:blip xmlns:r="http://schemas.openxmlformats.org/officeDocument/2006/relationships" xmlns:a="http://schemas.openxmlformats.org/drawingml/2006/main" r:embed="Rccf074f4a1ad49f9"/>
           <a:stretch xmlns:a="http://schemas.openxmlformats.org/drawingml/2006/main"/>
         </p:blipFill>
         <p:spPr>
@@ -10749,14 +10707,7 @@
           <p:nvPr/>
         </p:nvPicPr>
         <p:blipFill>
-          <a:blip xmlns:r="http://schemas.openxmlformats.org/officeDocument/2006/relationships" xmlns:a="http://schemas.openxmlformats.org/drawingml/2006/main" r:embed="R589c2c9728784fd3">
-            <a:extLst>
-              <a:ext uri="{96DAC541-7B7A-43D3-8B79-37D633B846F1}">
-                <asvg:svgBlip xmlns:asvg="http://schemas.microsoft.com/office/drawing/2016/SVG/main" r:embed="R05ccf75fca3e4b11"/>
-              </a:ext>
-            </a:extLst>
-          </a:blip>
-          <a:srcRect xmlns:a="http://schemas.openxmlformats.org/drawingml/2006/main" l="0" t="0" r="0" b="0"/>
+          <a:blip xmlns:r="http://schemas.openxmlformats.org/officeDocument/2006/relationships" xmlns:a="http://schemas.openxmlformats.org/drawingml/2006/main" r:embed="R0b47f8a9e1d242af"/>
           <a:stretch xmlns:a="http://schemas.openxmlformats.org/drawingml/2006/main"/>
         </p:blipFill>
         <p:spPr>
@@ -11132,7 +11083,7 @@
           <p:nvPr/>
         </p:nvPicPr>
         <p:blipFill>
-          <a:blip xmlns:r="http://schemas.openxmlformats.org/officeDocument/2006/relationships" xmlns:a="http://schemas.openxmlformats.org/drawingml/2006/main" r:embed="R16b181707e734b68"/>
+          <a:blip xmlns:r="http://schemas.openxmlformats.org/officeDocument/2006/relationships" xmlns:a="http://schemas.openxmlformats.org/drawingml/2006/main" r:embed="R278ff01c2ea54fd0"/>
           <a:srcRect xmlns:a="http://schemas.openxmlformats.org/drawingml/2006/main" l="0" t="0" r="0" b="0"/>
           <a:stretch xmlns:a="http://schemas.openxmlformats.org/drawingml/2006/main"/>
         </p:blipFill>
@@ -11201,7 +11152,7 @@
                 <a:latin typeface="Arial"/>
                 <a:ea typeface="Arial"/>
                 <a:cs typeface="Arial"/>
-                <a:hlinkClick xmlns:r="http://schemas.openxmlformats.org/officeDocument/2006/relationships" r:id="Rd45facceee6540de"/>
+                <a:hlinkClick xmlns:r="http://schemas.openxmlformats.org/officeDocument/2006/relationships" r:id="Rc1fdea49412246c6"/>
               </a:rPr>
               <a:t>Online slides ·</a:t>
             </a:r>
@@ -11229,7 +11180,7 @@
                 <a:latin typeface="Arial"/>
                 <a:ea typeface="Arial"/>
                 <a:cs typeface="Arial"/>
-                <a:hlinkClick xmlns:r="http://schemas.openxmlformats.org/officeDocument/2006/relationships" r:id="Ra67455ddb6cb4c75"/>
+                <a:hlinkClick xmlns:r="http://schemas.openxmlformats.org/officeDocument/2006/relationships" r:id="R38f6d13adc3c4d6e"/>
               </a:rPr>
               <a:t>current version</a:t>
             </a:r>
@@ -11333,7 +11284,7 @@
           <p:nvPr/>
         </p:nvPicPr>
         <p:blipFill>
-          <a:blip xmlns:r="http://schemas.openxmlformats.org/officeDocument/2006/relationships" xmlns:a="http://schemas.openxmlformats.org/drawingml/2006/main" r:embed="R440f5fee34a54074"/>
+          <a:blip xmlns:r="http://schemas.openxmlformats.org/officeDocument/2006/relationships" xmlns:a="http://schemas.openxmlformats.org/drawingml/2006/main" r:embed="Rf6ca180af64c4b33"/>
           <a:srcRect xmlns:a="http://schemas.openxmlformats.org/drawingml/2006/main" l="0" t="0" r="0" b="0"/>
           <a:stretch xmlns:a="http://schemas.openxmlformats.org/drawingml/2006/main"/>
         </p:blipFill>
@@ -11402,7 +11353,7 @@
                 <a:latin typeface="Arial"/>
                 <a:ea typeface="Arial"/>
                 <a:cs typeface="Arial"/>
-                <a:hlinkClick xmlns:r="http://schemas.openxmlformats.org/officeDocument/2006/relationships" r:id="Rb28cf035ad9a479f"/>
+                <a:hlinkClick xmlns:r="http://schemas.openxmlformats.org/officeDocument/2006/relationships" r:id="Re98b7047d68943a4"/>
               </a:rPr>
               <a:t>UNESCO submission ·</a:t>
             </a:r>
@@ -11430,7 +11381,7 @@
                 <a:latin typeface="Arial"/>
                 <a:ea typeface="Arial"/>
                 <a:cs typeface="Arial"/>
-                <a:hlinkClick xmlns:r="http://schemas.openxmlformats.org/officeDocument/2006/relationships" r:id="R91e3c67a000c4af8"/>
+                <a:hlinkClick xmlns:r="http://schemas.openxmlformats.org/officeDocument/2006/relationships" r:id="R10927b1b6e8c4c40"/>
               </a:rPr>
               <a:t>studies and evidence</a:t>
             </a:r>
@@ -11580,7 +11531,7 @@
                 <a:latin typeface="Arial"/>
                 <a:ea typeface="Arial"/>
                 <a:cs typeface="Arial"/>
-                <a:hlinkClick xmlns:r="http://schemas.openxmlformats.org/officeDocument/2006/relationships" r:id="R60b936f3c5eb4e55"/>
+                <a:hlinkClick xmlns:r="http://schemas.openxmlformats.org/officeDocument/2006/relationships" r:id="R00d74c07294f47ae"/>
               </a:rPr>
               <a:t>tony@cocorobo.cc</a:t>
             </a:r>
@@ -11657,14 +11608,7 @@
           <p:nvPr/>
         </p:nvPicPr>
         <p:blipFill>
-          <a:blip xmlns:r="http://schemas.openxmlformats.org/officeDocument/2006/relationships" xmlns:a="http://schemas.openxmlformats.org/drawingml/2006/main" r:embed="Rf0ab1da8197d438a">
-            <a:extLst>
-              <a:ext uri="{96DAC541-7B7A-43D3-8B79-37D633B846F1}">
-                <asvg:svgBlip xmlns:asvg="http://schemas.microsoft.com/office/drawing/2016/SVG/main" r:embed="R975147f40f6e4c7b"/>
-              </a:ext>
-            </a:extLst>
-          </a:blip>
-          <a:srcRect xmlns:a="http://schemas.openxmlformats.org/drawingml/2006/main" l="0" t="0" r="0" b="0"/>
+          <a:blip xmlns:r="http://schemas.openxmlformats.org/officeDocument/2006/relationships" xmlns:a="http://schemas.openxmlformats.org/drawingml/2006/main" r:embed="R9c0fa6c9714e4a5f"/>
           <a:stretch xmlns:a="http://schemas.openxmlformats.org/drawingml/2006/main"/>
         </p:blipFill>
         <p:spPr>
@@ -12325,7 +12269,7 @@
           <p:nvPr/>
         </p:nvPicPr>
         <p:blipFill>
-          <a:blip xmlns:r="http://schemas.openxmlformats.org/officeDocument/2006/relationships" xmlns:a="http://schemas.openxmlformats.org/drawingml/2006/main" r:embed="R534748e85ade47c1"/>
+          <a:blip xmlns:r="http://schemas.openxmlformats.org/officeDocument/2006/relationships" xmlns:a="http://schemas.openxmlformats.org/drawingml/2006/main" r:embed="R8ba796f190484ef6"/>
           <a:srcRect xmlns:a="http://schemas.openxmlformats.org/drawingml/2006/main" l="0" t="2370" r="0" b="2370"/>
           <a:stretch xmlns:a="http://schemas.openxmlformats.org/drawingml/2006/main"/>
         </p:blipFill>
@@ -12622,14 +12566,7 @@
           <p:nvPr/>
         </p:nvPicPr>
         <p:blipFill>
-          <a:blip xmlns:r="http://schemas.openxmlformats.org/officeDocument/2006/relationships" xmlns:a="http://schemas.openxmlformats.org/drawingml/2006/main" r:embed="R685796d04ab94057">
-            <a:extLst>
-              <a:ext uri="{96DAC541-7B7A-43D3-8B79-37D633B846F1}">
-                <asvg:svgBlip xmlns:asvg="http://schemas.microsoft.com/office/drawing/2016/SVG/main" r:embed="Rc29ae9449082479c"/>
-              </a:ext>
-            </a:extLst>
-          </a:blip>
-          <a:srcRect xmlns:a="http://schemas.openxmlformats.org/drawingml/2006/main" l="0" t="0" r="0" b="0"/>
+          <a:blip xmlns:r="http://schemas.openxmlformats.org/officeDocument/2006/relationships" xmlns:a="http://schemas.openxmlformats.org/drawingml/2006/main" r:embed="Ra380f29c6f1e4825"/>
           <a:stretch xmlns:a="http://schemas.openxmlformats.org/drawingml/2006/main"/>
         </p:blipFill>
         <p:spPr>
@@ -13499,14 +13436,7 @@
           <p:nvPr/>
         </p:nvPicPr>
         <p:blipFill>
-          <a:blip xmlns:r="http://schemas.openxmlformats.org/officeDocument/2006/relationships" xmlns:a="http://schemas.openxmlformats.org/drawingml/2006/main" r:embed="Ra0c46a7697b040e7">
-            <a:extLst>
-              <a:ext uri="{96DAC541-7B7A-43D3-8B79-37D633B846F1}">
-                <asvg:svgBlip xmlns:asvg="http://schemas.microsoft.com/office/drawing/2016/SVG/main" r:embed="R4efe50d6d3374c08"/>
-              </a:ext>
-            </a:extLst>
-          </a:blip>
-          <a:srcRect xmlns:a="http://schemas.openxmlformats.org/drawingml/2006/main" l="0" t="0" r="0" b="0"/>
+          <a:blip xmlns:r="http://schemas.openxmlformats.org/officeDocument/2006/relationships" xmlns:a="http://schemas.openxmlformats.org/drawingml/2006/main" r:embed="R2b7d03e96c53402b"/>
           <a:stretch xmlns:a="http://schemas.openxmlformats.org/drawingml/2006/main"/>
         </p:blipFill>
         <p:spPr>
@@ -13874,7 +13804,7 @@
                 <a:latin typeface="Arial"/>
                 <a:ea typeface="Arial"/>
                 <a:cs typeface="Arial"/>
-                <a:hlinkClick xmlns:r="http://schemas.openxmlformats.org/officeDocument/2006/relationships" r:id="Rc2f0ed0659c84c3b"/>
+                <a:hlinkClick xmlns:r="http://schemas.openxmlformats.org/officeDocument/2006/relationships" r:id="R318dfc68399a499d"/>
               </a:rPr>
               <a:t>Guangdong Department of Education</a:t>
             </a:r>
@@ -13902,7 +13832,7 @@
                 <a:latin typeface="Arial"/>
                 <a:ea typeface="Arial"/>
                 <a:cs typeface="Arial"/>
-                <a:hlinkClick xmlns:r="http://schemas.openxmlformats.org/officeDocument/2006/relationships" r:id="R351976031eea4cd7"/>
+                <a:hlinkClick xmlns:r="http://schemas.openxmlformats.org/officeDocument/2006/relationships" r:id="R0ee660f15c5e48b6"/>
               </a:rPr>
               <a:t>9 April 2025 · Trial documents</a:t>
             </a:r>
@@ -14497,7 +14427,7 @@
           <p:nvPr/>
         </p:nvPicPr>
         <p:blipFill>
-          <a:blip xmlns:r="http://schemas.openxmlformats.org/officeDocument/2006/relationships" xmlns:a="http://schemas.openxmlformats.org/drawingml/2006/main" r:embed="R4530ed06c74146e2"/>
+          <a:blip xmlns:r="http://schemas.openxmlformats.org/officeDocument/2006/relationships" xmlns:a="http://schemas.openxmlformats.org/drawingml/2006/main" r:embed="R1dbf12a8639349fd"/>
           <a:stretch xmlns:a="http://schemas.openxmlformats.org/drawingml/2006/main"/>
         </p:blipFill>
         <p:spPr>
@@ -14519,14 +14449,7 @@
           <p:nvPr/>
         </p:nvPicPr>
         <p:blipFill>
-          <a:blip xmlns:r="http://schemas.openxmlformats.org/officeDocument/2006/relationships" xmlns:a="http://schemas.openxmlformats.org/drawingml/2006/main" r:embed="R7ff967063e0346e0">
-            <a:extLst>
-              <a:ext uri="{96DAC541-7B7A-43D3-8B79-37D633B846F1}">
-                <asvg:svgBlip xmlns:asvg="http://schemas.microsoft.com/office/drawing/2016/SVG/main" r:embed="R8c6ddec369e24fcf"/>
-              </a:ext>
-            </a:extLst>
-          </a:blip>
-          <a:srcRect xmlns:a="http://schemas.openxmlformats.org/drawingml/2006/main" l="0" t="0" r="0" b="0"/>
+          <a:blip xmlns:r="http://schemas.openxmlformats.org/officeDocument/2006/relationships" xmlns:a="http://schemas.openxmlformats.org/drawingml/2006/main" r:embed="Rd02dbb0ab5724c40"/>
           <a:stretch xmlns:a="http://schemas.openxmlformats.org/drawingml/2006/main"/>
         </p:blipFill>
         <p:spPr>
@@ -14970,7 +14893,7 @@
           <p:nvPr/>
         </p:nvPicPr>
         <p:blipFill>
-          <a:blip xmlns:r="http://schemas.openxmlformats.org/officeDocument/2006/relationships" xmlns:a="http://schemas.openxmlformats.org/drawingml/2006/main" r:embed="R708993c3a11148fb"/>
+          <a:blip xmlns:r="http://schemas.openxmlformats.org/officeDocument/2006/relationships" xmlns:a="http://schemas.openxmlformats.org/drawingml/2006/main" r:embed="R79309960691d479a"/>
           <a:stretch xmlns:a="http://schemas.openxmlformats.org/drawingml/2006/main"/>
         </p:blipFill>
         <p:spPr>
@@ -14992,7 +14915,7 @@
           <p:nvPr/>
         </p:nvPicPr>
         <p:blipFill>
-          <a:blip xmlns:r="http://schemas.openxmlformats.org/officeDocument/2006/relationships" xmlns:a="http://schemas.openxmlformats.org/drawingml/2006/main" r:embed="Rae1e8fbdbdf045a6"/>
+          <a:blip xmlns:r="http://schemas.openxmlformats.org/officeDocument/2006/relationships" xmlns:a="http://schemas.openxmlformats.org/drawingml/2006/main" r:embed="R0980b9293adc4128"/>
           <a:srcRect xmlns:a="http://schemas.openxmlformats.org/drawingml/2006/main" l="0" t="21741" r="0" b="21741"/>
           <a:stretch xmlns:a="http://schemas.openxmlformats.org/drawingml/2006/main">
             <a:fillRect l="0" t="0" r="0" b="0"/>
@@ -15291,14 +15214,7 @@
           <p:nvPr/>
         </p:nvPicPr>
         <p:blipFill>
-          <a:blip xmlns:r="http://schemas.openxmlformats.org/officeDocument/2006/relationships" xmlns:a="http://schemas.openxmlformats.org/drawingml/2006/main" r:embed="Rae1e8fbdbdf045a6">
-            <a:extLst>
-              <a:ext uri="{96DAC541-7B7A-43D3-8B79-37D633B846F1}">
-                <asvg:svgBlip xmlns:asvg="http://schemas.microsoft.com/office/drawing/2016/SVG/main" r:embed="R033ac4bff100405e"/>
-              </a:ext>
-            </a:extLst>
-          </a:blip>
-          <a:srcRect xmlns:a="http://schemas.openxmlformats.org/drawingml/2006/main" l="0" t="0" r="0" b="0"/>
+          <a:blip xmlns:r="http://schemas.openxmlformats.org/officeDocument/2006/relationships" xmlns:a="http://schemas.openxmlformats.org/drawingml/2006/main" r:embed="R63d48ce6c97a4fde"/>
           <a:stretch xmlns:a="http://schemas.openxmlformats.org/drawingml/2006/main"/>
         </p:blipFill>
         <p:spPr>
@@ -15715,7 +15631,7 @@
           <p:nvPr/>
         </p:nvPicPr>
         <p:blipFill>
-          <a:blip xmlns:r="http://schemas.openxmlformats.org/officeDocument/2006/relationships" xmlns:a="http://schemas.openxmlformats.org/drawingml/2006/main" r:embed="R496ee3d7f6054eaa"/>
+          <a:blip xmlns:r="http://schemas.openxmlformats.org/officeDocument/2006/relationships" xmlns:a="http://schemas.openxmlformats.org/drawingml/2006/main" r:embed="R625b11aac7374608"/>
           <a:srcRect xmlns:a="http://schemas.openxmlformats.org/drawingml/2006/main" l="0" t="7532" r="0" b="7532"/>
           <a:stretch xmlns:a="http://schemas.openxmlformats.org/drawingml/2006/main">
             <a:fillRect l="0" t="0" r="0" b="0"/>
@@ -16075,14 +15991,7 @@
           <p:nvPr/>
         </p:nvPicPr>
         <p:blipFill>
-          <a:blip xmlns:r="http://schemas.openxmlformats.org/officeDocument/2006/relationships" xmlns:a="http://schemas.openxmlformats.org/drawingml/2006/main" r:embed="R496ee3d7f6054eaa">
-            <a:extLst>
-              <a:ext uri="{96DAC541-7B7A-43D3-8B79-37D633B846F1}">
-                <asvg:svgBlip xmlns:asvg="http://schemas.microsoft.com/office/drawing/2016/SVG/main" r:embed="R10c52097965f4d02"/>
-              </a:ext>
-            </a:extLst>
-          </a:blip>
-          <a:srcRect xmlns:a="http://schemas.openxmlformats.org/drawingml/2006/main" l="0" t="0" r="0" b="0"/>
+          <a:blip xmlns:r="http://schemas.openxmlformats.org/officeDocument/2006/relationships" xmlns:a="http://schemas.openxmlformats.org/drawingml/2006/main" r:embed="R649afde289df4ddc"/>
           <a:stretch xmlns:a="http://schemas.openxmlformats.org/drawingml/2006/main"/>
         </p:blipFill>
         <p:spPr>
@@ -16499,7 +16408,7 @@
           <p:nvPr/>
         </p:nvPicPr>
         <p:blipFill>
-          <a:blip xmlns:r="http://schemas.openxmlformats.org/officeDocument/2006/relationships" xmlns:a="http://schemas.openxmlformats.org/drawingml/2006/main" r:embed="Re9e2d67db6344569"/>
+          <a:blip xmlns:r="http://schemas.openxmlformats.org/officeDocument/2006/relationships" xmlns:a="http://schemas.openxmlformats.org/drawingml/2006/main" r:embed="Ra718cb101e9943dc"/>
           <a:srcRect xmlns:a="http://schemas.openxmlformats.org/drawingml/2006/main" l="4136" t="0" r="4136" b="0"/>
           <a:stretch xmlns:a="http://schemas.openxmlformats.org/drawingml/2006/main">
             <a:fillRect l="0" t="0" r="0" b="0"/>
@@ -16798,14 +16707,7 @@
           <p:nvPr/>
         </p:nvPicPr>
         <p:blipFill>
-          <a:blip xmlns:r="http://schemas.openxmlformats.org/officeDocument/2006/relationships" xmlns:a="http://schemas.openxmlformats.org/drawingml/2006/main" r:embed="Re9e2d67db6344569">
-            <a:extLst>
-              <a:ext uri="{96DAC541-7B7A-43D3-8B79-37D633B846F1}">
-                <asvg:svgBlip xmlns:asvg="http://schemas.microsoft.com/office/drawing/2016/SVG/main" r:embed="Rc02058cce9344d64"/>
-              </a:ext>
-            </a:extLst>
-          </a:blip>
-          <a:srcRect xmlns:a="http://schemas.openxmlformats.org/drawingml/2006/main" l="0" t="0" r="0" b="0"/>
+          <a:blip xmlns:r="http://schemas.openxmlformats.org/officeDocument/2006/relationships" xmlns:a="http://schemas.openxmlformats.org/drawingml/2006/main" r:embed="Rf351460c0a564e73"/>
           <a:stretch xmlns:a="http://schemas.openxmlformats.org/drawingml/2006/main"/>
         </p:blipFill>
         <p:spPr>
@@ -17466,7 +17368,7 @@
           <p:nvPr/>
         </p:nvPicPr>
         <p:blipFill>
-          <a:blip xmlns:r="http://schemas.openxmlformats.org/officeDocument/2006/relationships" xmlns:a="http://schemas.openxmlformats.org/drawingml/2006/main" r:embed="R64532847af1c4573"/>
+          <a:blip xmlns:r="http://schemas.openxmlformats.org/officeDocument/2006/relationships" xmlns:a="http://schemas.openxmlformats.org/drawingml/2006/main" r:embed="Rf8e600daf3274b62"/>
           <a:srcRect xmlns:a="http://schemas.openxmlformats.org/drawingml/2006/main" l="0" t="0" r="0" b="0"/>
           <a:stretch xmlns:a="http://schemas.openxmlformats.org/drawingml/2006/main"/>
         </p:blipFill>
@@ -17824,14 +17726,7 @@
           <p:nvPr/>
         </p:nvPicPr>
         <p:blipFill>
-          <a:blip xmlns:r="http://schemas.openxmlformats.org/officeDocument/2006/relationships" xmlns:a="http://schemas.openxmlformats.org/drawingml/2006/main" r:embed="R64532847af1c4573">
-            <a:extLst>
-              <a:ext uri="{96DAC541-7B7A-43D3-8B79-37D633B846F1}">
-                <asvg:svgBlip xmlns:asvg="http://schemas.microsoft.com/office/drawing/2016/SVG/main" r:embed="R6397e686439b487d"/>
-              </a:ext>
-            </a:extLst>
-          </a:blip>
-          <a:srcRect xmlns:a="http://schemas.openxmlformats.org/drawingml/2006/main" l="0" t="0" r="0" b="0"/>
+          <a:blip xmlns:r="http://schemas.openxmlformats.org/officeDocument/2006/relationships" xmlns:a="http://schemas.openxmlformats.org/drawingml/2006/main" r:embed="Rd97468d7c6884a1e"/>
           <a:stretch xmlns:a="http://schemas.openxmlformats.org/drawingml/2006/main"/>
         </p:blipFill>
         <p:spPr>
@@ -18092,7 +17987,7 @@
           <p:nvPr/>
         </p:nvPicPr>
         <p:blipFill>
-          <a:blip xmlns:r="http://schemas.openxmlformats.org/officeDocument/2006/relationships" xmlns:a="http://schemas.openxmlformats.org/drawingml/2006/main" r:embed="R61698ab0f1ec4199"/>
+          <a:blip xmlns:r="http://schemas.openxmlformats.org/officeDocument/2006/relationships" xmlns:a="http://schemas.openxmlformats.org/drawingml/2006/main" r:embed="Rea8908c9f29440cd"/>
           <a:srcRect xmlns:a="http://schemas.openxmlformats.org/drawingml/2006/main" l="0" t="15816" r="0" b="15816"/>
           <a:stretch xmlns:a="http://schemas.openxmlformats.org/drawingml/2006/main">
             <a:fillRect l="0" t="0" r="0" b="0"/>
@@ -18757,14 +18652,7 @@
           <p:nvPr/>
         </p:nvPicPr>
         <p:blipFill>
-          <a:blip xmlns:r="http://schemas.openxmlformats.org/officeDocument/2006/relationships" xmlns:a="http://schemas.openxmlformats.org/drawingml/2006/main" r:embed="R61698ab0f1ec4199">
-            <a:extLst>
-              <a:ext uri="{96DAC541-7B7A-43D3-8B79-37D633B846F1}">
-                <asvg:svgBlip xmlns:asvg="http://schemas.microsoft.com/office/drawing/2016/SVG/main" r:embed="R2d13c77de0cf4af9"/>
-              </a:ext>
-            </a:extLst>
-          </a:blip>
-          <a:srcRect xmlns:a="http://schemas.openxmlformats.org/drawingml/2006/main" l="0" t="0" r="0" b="0"/>
+          <a:blip xmlns:r="http://schemas.openxmlformats.org/officeDocument/2006/relationships" xmlns:a="http://schemas.openxmlformats.org/drawingml/2006/main" r:embed="Rcd4556399fbe4999"/>
           <a:stretch xmlns:a="http://schemas.openxmlformats.org/drawingml/2006/main"/>
         </p:blipFill>
         <p:spPr>

</xml_diff>

<commit_message>
Restore shaded photographic UNESCO cover and official CocoRobo logo; use Airier layout online
</commit_message>
<xml_diff>
--- a/teacher-agent-creators-10min/downloads/UNESCO_Teacher_AI_Agents_EN_Airier.pptx
+++ b/teacher-agent-creators-10min/downloads/UNESCO_Teacher_AI_Agents_EN_Airier.pptx
@@ -2,29 +2,29 @@
 <file path=ppt/presentation.xml><?xml version="1.0" encoding="utf-8"?>
 <p:presentation xmlns:p="http://schemas.openxmlformats.org/presentationml/2006/main">
   <p:sldMasterIdLst>
-    <p:sldMasterId xmlns:r="http://schemas.openxmlformats.org/officeDocument/2006/relationships" id="2147483648" r:id="R86d87ec3cb6c4ffe"/>
+    <p:sldMasterId xmlns:r="http://schemas.openxmlformats.org/officeDocument/2006/relationships" id="2147483648" r:id="Rf27fb3b960af4785"/>
   </p:sldMasterIdLst>
   <p:notesMasterIdLst>
-    <p:notesMasterId xmlns:r="http://schemas.openxmlformats.org/officeDocument/2006/relationships" r:id="Rf617e46854aa4ebc"/>
+    <p:notesMasterId xmlns:r="http://schemas.openxmlformats.org/officeDocument/2006/relationships" r:id="Rfb982303b5464c88"/>
   </p:notesMasterIdLst>
   <p:sldIdLst>
-    <p:sldId xmlns:r="http://schemas.openxmlformats.org/officeDocument/2006/relationships" id="256" r:id="R3f41c13d4ea64858"/>
-    <p:sldId xmlns:r="http://schemas.openxmlformats.org/officeDocument/2006/relationships" id="257" r:id="R86200c3291344b23"/>
-    <p:sldId xmlns:r="http://schemas.openxmlformats.org/officeDocument/2006/relationships" id="258" r:id="R240f25d14d8c4238"/>
-    <p:sldId xmlns:r="http://schemas.openxmlformats.org/officeDocument/2006/relationships" id="259" r:id="R4cf082bcffa14d05"/>
-    <p:sldId xmlns:r="http://schemas.openxmlformats.org/officeDocument/2006/relationships" id="260" r:id="Rbddf10aab8784f2e"/>
-    <p:sldId xmlns:r="http://schemas.openxmlformats.org/officeDocument/2006/relationships" id="261" r:id="Rbf2f6e1f38a441a5"/>
-    <p:sldId xmlns:r="http://schemas.openxmlformats.org/officeDocument/2006/relationships" id="262" r:id="Ra01a36d224d344a1"/>
-    <p:sldId xmlns:r="http://schemas.openxmlformats.org/officeDocument/2006/relationships" id="263" r:id="R9f10fd9fc1d34b91"/>
-    <p:sldId xmlns:r="http://schemas.openxmlformats.org/officeDocument/2006/relationships" id="264" r:id="Rcf651495192d4fcc"/>
-    <p:sldId xmlns:r="http://schemas.openxmlformats.org/officeDocument/2006/relationships" id="265" r:id="R71b739a9f0cf4336"/>
-    <p:sldId xmlns:r="http://schemas.openxmlformats.org/officeDocument/2006/relationships" id="266" r:id="Rd8f073dcec874e60"/>
-    <p:sldId xmlns:r="http://schemas.openxmlformats.org/officeDocument/2006/relationships" id="267" r:id="R867e6d4fd53a4a7e"/>
-    <p:sldId xmlns:r="http://schemas.openxmlformats.org/officeDocument/2006/relationships" id="268" r:id="Rbbbd927a62ca4394"/>
-    <p:sldId xmlns:r="http://schemas.openxmlformats.org/officeDocument/2006/relationships" id="269" r:id="Ra1417d827650414d"/>
-    <p:sldId xmlns:r="http://schemas.openxmlformats.org/officeDocument/2006/relationships" id="270" r:id="Rf8c706bd96634a94"/>
-    <p:sldId xmlns:r="http://schemas.openxmlformats.org/officeDocument/2006/relationships" id="271" r:id="R28758e5ee2424d55"/>
-    <p:sldId xmlns:r="http://schemas.openxmlformats.org/officeDocument/2006/relationships" id="272" r:id="R6f91415e71a7458f"/>
+    <p:sldId xmlns:r="http://schemas.openxmlformats.org/officeDocument/2006/relationships" id="256" r:id="R982c1a016c7d49d4"/>
+    <p:sldId xmlns:r="http://schemas.openxmlformats.org/officeDocument/2006/relationships" id="257" r:id="R1a3d370f929f4d01"/>
+    <p:sldId xmlns:r="http://schemas.openxmlformats.org/officeDocument/2006/relationships" id="258" r:id="R54564f3563f94adc"/>
+    <p:sldId xmlns:r="http://schemas.openxmlformats.org/officeDocument/2006/relationships" id="259" r:id="Rae185e5574ed4660"/>
+    <p:sldId xmlns:r="http://schemas.openxmlformats.org/officeDocument/2006/relationships" id="260" r:id="Rffeb972d1df34995"/>
+    <p:sldId xmlns:r="http://schemas.openxmlformats.org/officeDocument/2006/relationships" id="261" r:id="Raeafafb920c34599"/>
+    <p:sldId xmlns:r="http://schemas.openxmlformats.org/officeDocument/2006/relationships" id="262" r:id="Ra053bb202be0418f"/>
+    <p:sldId xmlns:r="http://schemas.openxmlformats.org/officeDocument/2006/relationships" id="263" r:id="Redb5ce3c88d04b16"/>
+    <p:sldId xmlns:r="http://schemas.openxmlformats.org/officeDocument/2006/relationships" id="264" r:id="R8c14815f30e64b72"/>
+    <p:sldId xmlns:r="http://schemas.openxmlformats.org/officeDocument/2006/relationships" id="265" r:id="R22fcb20b5e6e48d8"/>
+    <p:sldId xmlns:r="http://schemas.openxmlformats.org/officeDocument/2006/relationships" id="266" r:id="R60b3c49517194e64"/>
+    <p:sldId xmlns:r="http://schemas.openxmlformats.org/officeDocument/2006/relationships" id="267" r:id="Rb438a17b2ed146f5"/>
+    <p:sldId xmlns:r="http://schemas.openxmlformats.org/officeDocument/2006/relationships" id="268" r:id="Ref74f5207a42486a"/>
+    <p:sldId xmlns:r="http://schemas.openxmlformats.org/officeDocument/2006/relationships" id="269" r:id="Rc73ca1155e204b73"/>
+    <p:sldId xmlns:r="http://schemas.openxmlformats.org/officeDocument/2006/relationships" id="270" r:id="Rbc80d17d201a4b44"/>
+    <p:sldId xmlns:r="http://schemas.openxmlformats.org/officeDocument/2006/relationships" id="271" r:id="R1e4cdfe1af604127"/>
+    <p:sldId xmlns:r="http://schemas.openxmlformats.org/officeDocument/2006/relationships" id="272" r:id="R4d7116132b9c4317"/>
   </p:sldIdLst>
   <p:sldSz cx="12192000" cy="6858000"/>
   <p:notesSz cx="6858000" cy="9144000"/>
@@ -2416,7 +2416,7 @@
   </p:cSld>
   <p:clrMap bg1="lt1" tx1="dk1" bg2="lt2" tx2="dk2" accent1="accent1" accent2="accent2" accent3="accent3" accent4="accent4" accent5="accent5" accent6="accent6" hlink="hlink" folHlink="folHlink"/>
   <p:sldLayoutIdLst>
-    <p:sldLayoutId xmlns:r="http://schemas.openxmlformats.org/officeDocument/2006/relationships" id="2147483649" r:id="Rfd1e0d6f064741f9"/>
+    <p:sldLayoutId xmlns:r="http://schemas.openxmlformats.org/officeDocument/2006/relationships" id="2147483649" r:id="Rf401ceb16b73466e"/>
   </p:sldLayoutIdLst>
   <p:txStyles>
     <p:titleStyle>
@@ -2949,7 +2949,7 @@
     <p:bg>
       <p:bgPr>
         <a:solidFill xmlns:a="http://schemas.openxmlformats.org/drawingml/2006/main">
-          <a:srgbClr val="10283F"/>
+          <a:srgbClr val="071428"/>
         </a:solidFill>
       </p:bgPr>
     </p:bg>
@@ -2971,13 +2971,16 @@
           <p:nvPr/>
         </p:nvPicPr>
         <p:blipFill>
-          <a:blip xmlns:r="http://schemas.openxmlformats.org/officeDocument/2006/relationships" xmlns:a="http://schemas.openxmlformats.org/drawingml/2006/main" r:embed="Rbc9be50d8ee94137"/>
-          <a:stretch xmlns:a="http://schemas.openxmlformats.org/drawingml/2006/main"/>
+          <a:blip xmlns:r="http://schemas.openxmlformats.org/officeDocument/2006/relationships" xmlns:a="http://schemas.openxmlformats.org/drawingml/2006/main" r:embed="R61620a921dd840fb"/>
+          <a:srcRect xmlns:a="http://schemas.openxmlformats.org/drawingml/2006/main" l="0" t="0" r="0" b="0"/>
+          <a:stretch xmlns:a="http://schemas.openxmlformats.org/drawingml/2006/main">
+            <a:fillRect l="0" t="0" r="0" b="0"/>
+          </a:stretch>
         </p:blipFill>
         <p:spPr>
           <a:xfrm xmlns:a="http://schemas.openxmlformats.org/drawingml/2006/main">
-            <a:off x="6667500" y="2047875"/>
-            <a:ext cx="5524500" cy="3680698"/>
+            <a:off x="5943600" y="0"/>
+            <a:ext cx="6248400" cy="6858000"/>
           </a:xfrm>
           <a:prstGeom xmlns:a="http://schemas.openxmlformats.org/drawingml/2006/main" prst="rect">
             <a:avLst/>
@@ -2993,14 +2996,13 @@
           <p:nvPr/>
         </p:nvPicPr>
         <p:blipFill>
-          <a:blip xmlns:r="http://schemas.openxmlformats.org/officeDocument/2006/relationships" xmlns:a="http://schemas.openxmlformats.org/drawingml/2006/main" r:embed="R44ac987ab427471d"/>
-          <a:srcRect xmlns:a="http://schemas.openxmlformats.org/drawingml/2006/main" l="0" t="0" r="0" b="0"/>
+          <a:blip xmlns:r="http://schemas.openxmlformats.org/officeDocument/2006/relationships" xmlns:a="http://schemas.openxmlformats.org/drawingml/2006/main" r:embed="R3198dcabab554cca"/>
           <a:stretch xmlns:a="http://schemas.openxmlformats.org/drawingml/2006/main"/>
         </p:blipFill>
         <p:spPr>
           <a:xfrm xmlns:a="http://schemas.openxmlformats.org/drawingml/2006/main">
-            <a:off x="533400" y="495300"/>
-            <a:ext cx="409575" cy="409575"/>
+            <a:off x="533400" y="876300"/>
+            <a:ext cx="2362200" cy="542925"/>
           </a:xfrm>
           <a:prstGeom xmlns:a="http://schemas.openxmlformats.org/drawingml/2006/main" prst="rect">
             <a:avLst/>
@@ -3023,15 +3025,33 @@
         </p:nvSpPr>
         <p:spPr>
           <a:xfrm xmlns:a="http://schemas.openxmlformats.org/drawingml/2006/main">
-            <a:off x="1066800" y="552450"/>
-            <a:ext cx="2286000" cy="381000"/>
-          </a:xfrm>
-          <a:prstGeom xmlns:a="http://schemas.openxmlformats.org/drawingml/2006/main" prst="rect">
-            <a:avLst/>
-          </a:prstGeom>
-          <a:noFill xmlns:a="http://schemas.openxmlformats.org/drawingml/2006/main"/>
-          <a:ln xmlns:a="http://schemas.openxmlformats.org/drawingml/2006/main" w="0">
-            <a:noFill/>
+            <a:off x="5715000" y="0"/>
+            <a:ext cx="6477000" cy="6858000"/>
+          </a:xfrm>
+          <a:prstGeom xmlns:a="http://schemas.openxmlformats.org/drawingml/2006/main" prst="rect">
+            <a:avLst/>
+          </a:prstGeom>
+          <a:gradFill xmlns:a="http://schemas.openxmlformats.org/drawingml/2006/main">
+            <a:gsLst>
+              <a:gs pos="0">
+                <a:srgbClr val="071428"/>
+              </a:gs>
+              <a:gs pos="22000">
+                <a:srgbClr val="071428">
+                  <a:alpha val="88000"/>
+                </a:srgbClr>
+              </a:gs>
+              <a:gs pos="100000">
+                <a:srgbClr val="071428">
+                  <a:alpha val="38000"/>
+                </a:srgbClr>
+              </a:gs>
+            </a:gsLst>
+            <a:lin ang="0"/>
+          </a:gradFill>
+          <a:ln xmlns:a="http://schemas.openxmlformats.org/drawingml/2006/main" w="0">
+            <a:noFill/>
+            <a:prstDash val="solid"/>
           </a:ln>
         </p:spPr>
         <p:txBody>
@@ -3063,7 +3083,7 @@
                 <a:ea typeface="Arial"/>
                 <a:cs typeface="Arial"/>
               </a:rPr>
-              <a:t>CocoRobo</a:t>
+              <a:t/>
             </a:r>
           </a:p>
         </p:txBody>
@@ -3084,8 +3104,8 @@
         </p:nvSpPr>
         <p:spPr>
           <a:xfrm xmlns:a="http://schemas.openxmlformats.org/drawingml/2006/main">
-            <a:off x="8905875" y="457200"/>
-            <a:ext cx="2752725" cy="209550"/>
+            <a:off x="9029700" y="895350"/>
+            <a:ext cx="2628900" cy="209550"/>
           </a:xfrm>
           <a:prstGeom xmlns:a="http://schemas.openxmlformats.org/drawingml/2006/main" prst="rect">
             <a:avLst/>
@@ -3106,6 +3126,128 @@
                 <a:spcPct val="120000"/>
               </a:lnSpc>
               <a:buNone/>
+              <a:defRPr sz="900" b="1">
+                <a:solidFill>
+                  <a:srgbClr val="BED0DD"/>
+                </a:solidFill>
+                <a:latin typeface="Arial"/>
+                <a:ea typeface="Arial"/>
+                <a:cs typeface="Arial"/>
+              </a:defRPr>
+            </a:pPr>
+            <a:r>
+              <a:rPr sz="900" b="1">
+                <a:solidFill>
+                  <a:srgbClr val="BED0DD"/>
+                </a:solidFill>
+                <a:latin typeface="Arial"/>
+                <a:ea typeface="Arial"/>
+                <a:cs typeface="Arial"/>
+              </a:rPr>
+              <a:t>PREPARED FOR</a:t>
+            </a:r>
+          </a:p>
+        </p:txBody>
+      </p:sp>
+      <p:sp>
+        <p:nvSpPr>
+          <p:cNvPr id="5" name="s1-subheading-5">
+            <a:extLst xmlns:a="http://schemas.openxmlformats.org/drawingml/2006/main">
+              <a:ext uri="{FF2B5EF4-FFF2-40B4-BE49-F238E27FC236}">
+                <a16:creationId xmlns:a16="http://schemas.microsoft.com/office/drawing/2014/main" id="{D7956C00-6378-4E92-8C2B-3EA4AFC9AE82}"/>
+              </a:ext>
+            </a:extLst>
+          </p:cNvPr>
+          <p:cNvSpPr>
+            <a:spLocks xmlns:a="http://schemas.openxmlformats.org/drawingml/2006/main" noGrp="1"/>
+          </p:cNvSpPr>
+          <p:nvPr/>
+        </p:nvSpPr>
+        <p:spPr>
+          <a:xfrm xmlns:a="http://schemas.openxmlformats.org/drawingml/2006/main">
+            <a:off x="9029700" y="1123950"/>
+            <a:ext cx="2628900" cy="361950"/>
+          </a:xfrm>
+          <a:prstGeom xmlns:a="http://schemas.openxmlformats.org/drawingml/2006/main" prst="rect">
+            <a:avLst/>
+          </a:prstGeom>
+          <a:noFill xmlns:a="http://schemas.openxmlformats.org/drawingml/2006/main"/>
+          <a:ln xmlns:a="http://schemas.openxmlformats.org/drawingml/2006/main" w="0">
+            <a:noFill/>
+          </a:ln>
+        </p:spPr>
+        <p:txBody>
+          <a:bodyPr xmlns:a="http://schemas.openxmlformats.org/drawingml/2006/main" wrap="square" lIns="0" tIns="0" rIns="0" bIns="0" anchor="t">
+            <a:noAutofit/>
+          </a:bodyPr>
+          <a:lstStyle xmlns:a="http://schemas.openxmlformats.org/drawingml/2006/main"/>
+          <a:p xmlns:a="http://schemas.openxmlformats.org/drawingml/2006/main">
+            <a:pPr algn="l">
+              <a:lnSpc>
+                <a:spcPct val="120000"/>
+              </a:lnSpc>
+              <a:buNone/>
+              <a:defRPr sz="2250" b="1">
+                <a:solidFill>
+                  <a:srgbClr val="FFFFFF"/>
+                </a:solidFill>
+                <a:latin typeface="Arial"/>
+                <a:ea typeface="Arial"/>
+                <a:cs typeface="Arial"/>
+              </a:defRPr>
+            </a:pPr>
+            <a:r>
+              <a:rPr sz="2250" b="1">
+                <a:solidFill>
+                  <a:srgbClr val="FFFFFF"/>
+                </a:solidFill>
+                <a:latin typeface="Arial"/>
+                <a:ea typeface="Arial"/>
+                <a:cs typeface="Arial"/>
+              </a:rPr>
+              <a:t>UNESCO</a:t>
+            </a:r>
+          </a:p>
+        </p:txBody>
+      </p:sp>
+      <p:sp>
+        <p:nvSpPr>
+          <p:cNvPr id="6" name="s1-kicker-6">
+            <a:extLst xmlns:a="http://schemas.openxmlformats.org/drawingml/2006/main">
+              <a:ext uri="{FF2B5EF4-FFF2-40B4-BE49-F238E27FC236}">
+                <a16:creationId xmlns:a16="http://schemas.microsoft.com/office/drawing/2014/main" id="{AF2D5AC2-571D-4BC0-9D7F-3CEBE52EDF55}"/>
+              </a:ext>
+            </a:extLst>
+          </p:cNvPr>
+          <p:cNvSpPr>
+            <a:spLocks xmlns:a="http://schemas.openxmlformats.org/drawingml/2006/main" noGrp="1"/>
+          </p:cNvSpPr>
+          <p:nvPr/>
+        </p:nvSpPr>
+        <p:spPr>
+          <a:xfrm xmlns:a="http://schemas.openxmlformats.org/drawingml/2006/main">
+            <a:off x="9029700" y="1495425"/>
+            <a:ext cx="2628900" cy="238125"/>
+          </a:xfrm>
+          <a:prstGeom xmlns:a="http://schemas.openxmlformats.org/drawingml/2006/main" prst="rect">
+            <a:avLst/>
+          </a:prstGeom>
+          <a:noFill xmlns:a="http://schemas.openxmlformats.org/drawingml/2006/main"/>
+          <a:ln xmlns:a="http://schemas.openxmlformats.org/drawingml/2006/main" w="0">
+            <a:noFill/>
+          </a:ln>
+        </p:spPr>
+        <p:txBody>
+          <a:bodyPr xmlns:a="http://schemas.openxmlformats.org/drawingml/2006/main" wrap="square" lIns="0" tIns="0" rIns="0" bIns="0" anchor="t">
+            <a:noAutofit/>
+          </a:bodyPr>
+          <a:lstStyle xmlns:a="http://schemas.openxmlformats.org/drawingml/2006/main"/>
+          <a:p xmlns:a="http://schemas.openxmlformats.org/drawingml/2006/main">
+            <a:pPr algn="l">
+              <a:lnSpc>
+                <a:spcPct val="120000"/>
+              </a:lnSpc>
+              <a:buNone/>
               <a:defRPr sz="975" b="1">
                 <a:solidFill>
                   <a:srgbClr val="BED0DD"/>
@@ -3124,29 +3266,29 @@
                 <a:ea typeface="Arial"/>
                 <a:cs typeface="Arial"/>
               </a:rPr>
-              <a:t>PREPARED FOR</a:t>
-            </a:r>
-          </a:p>
-        </p:txBody>
-      </p:sp>
-      <p:sp>
-        <p:nvSpPr>
-          <p:cNvPr id="5" name="s1-subheading-5">
-            <a:extLst xmlns:a="http://schemas.openxmlformats.org/drawingml/2006/main">
-              <a:ext uri="{FF2B5EF4-FFF2-40B4-BE49-F238E27FC236}">
-                <a16:creationId xmlns:a16="http://schemas.microsoft.com/office/drawing/2014/main" id="{D7956C00-6378-4E92-8C2B-3EA4AFC9AE82}"/>
-              </a:ext>
-            </a:extLst>
-          </p:cNvPr>
-          <p:cNvSpPr>
-            <a:spLocks xmlns:a="http://schemas.openxmlformats.org/drawingml/2006/main" noGrp="1"/>
-          </p:cNvSpPr>
-          <p:nvPr/>
-        </p:nvSpPr>
-        <p:spPr>
-          <a:xfrm xmlns:a="http://schemas.openxmlformats.org/drawingml/2006/main">
-            <a:off x="8905875" y="733425"/>
-            <a:ext cx="2752725" cy="381000"/>
+              <a:t>DIGITAL LEARNING WEEK 2026</a:t>
+            </a:r>
+          </a:p>
+        </p:txBody>
+      </p:sp>
+      <p:sp>
+        <p:nvSpPr>
+          <p:cNvPr id="7" name="s1-kicker-7">
+            <a:extLst xmlns:a="http://schemas.openxmlformats.org/drawingml/2006/main">
+              <a:ext uri="{FF2B5EF4-FFF2-40B4-BE49-F238E27FC236}">
+                <a16:creationId xmlns:a16="http://schemas.microsoft.com/office/drawing/2014/main" id="{F452D0AB-293F-4E5A-B3A7-59D4F79817C2}"/>
+              </a:ext>
+            </a:extLst>
+          </p:cNvPr>
+          <p:cNvSpPr>
+            <a:spLocks xmlns:a="http://schemas.openxmlformats.org/drawingml/2006/main" noGrp="1"/>
+          </p:cNvSpPr>
+          <p:nvPr/>
+        </p:nvSpPr>
+        <p:spPr>
+          <a:xfrm xmlns:a="http://schemas.openxmlformats.org/drawingml/2006/main">
+            <a:off x="533400" y="2638425"/>
+            <a:ext cx="10953750" cy="266700"/>
           </a:xfrm>
           <a:prstGeom xmlns:a="http://schemas.openxmlformats.org/drawingml/2006/main" prst="rect">
             <a:avLst/>
@@ -3167,7 +3309,68 @@
                 <a:spcPct val="120000"/>
               </a:lnSpc>
               <a:buNone/>
-              <a:defRPr sz="2250" b="1">
+              <a:defRPr sz="1200" b="1">
+                <a:solidFill>
+                  <a:srgbClr val="64D2C4"/>
+                </a:solidFill>
+                <a:latin typeface="Arial"/>
+                <a:ea typeface="Arial"/>
+                <a:cs typeface="Arial"/>
+              </a:defRPr>
+            </a:pPr>
+            <a:r>
+              <a:rPr sz="1200" b="1">
+                <a:solidFill>
+                  <a:srgbClr val="64D2C4"/>
+                </a:solidFill>
+                <a:latin typeface="Arial"/>
+                <a:ea typeface="Arial"/>
+                <a:cs typeface="Arial"/>
+              </a:rPr>
+              <a:t>TEACHER AGENCY · PRACTICE &amp; RESEARCH</a:t>
+            </a:r>
+          </a:p>
+        </p:txBody>
+      </p:sp>
+      <p:sp>
+        <p:nvSpPr>
+          <p:cNvPr id="8" name="s1-title-8">
+            <a:extLst xmlns:a="http://schemas.openxmlformats.org/drawingml/2006/main">
+              <a:ext uri="{FF2B5EF4-FFF2-40B4-BE49-F238E27FC236}">
+                <a16:creationId xmlns:a16="http://schemas.microsoft.com/office/drawing/2014/main" id="{BFADBDC1-4F23-4661-93FA-AC825E0EC945}"/>
+              </a:ext>
+            </a:extLst>
+          </p:cNvPr>
+          <p:cNvSpPr>
+            <a:spLocks xmlns:a="http://schemas.openxmlformats.org/drawingml/2006/main" noGrp="1"/>
+          </p:cNvSpPr>
+          <p:nvPr/>
+        </p:nvSpPr>
+        <p:spPr>
+          <a:xfrm xmlns:a="http://schemas.openxmlformats.org/drawingml/2006/main">
+            <a:off x="533400" y="3009900"/>
+            <a:ext cx="11125200" cy="1552575"/>
+          </a:xfrm>
+          <a:prstGeom xmlns:a="http://schemas.openxmlformats.org/drawingml/2006/main" prst="rect">
+            <a:avLst/>
+          </a:prstGeom>
+          <a:noFill xmlns:a="http://schemas.openxmlformats.org/drawingml/2006/main"/>
+          <a:ln xmlns:a="http://schemas.openxmlformats.org/drawingml/2006/main" w="0">
+            <a:noFill/>
+          </a:ln>
+        </p:spPr>
+        <p:txBody>
+          <a:bodyPr xmlns:a="http://schemas.openxmlformats.org/drawingml/2006/main" wrap="square" lIns="0" tIns="0" rIns="0" bIns="0" anchor="t">
+            <a:noAutofit/>
+          </a:bodyPr>
+          <a:lstStyle xmlns:a="http://schemas.openxmlformats.org/drawingml/2006/main"/>
+          <a:p xmlns:a="http://schemas.openxmlformats.org/drawingml/2006/main">
+            <a:pPr algn="l">
+              <a:lnSpc>
+                <a:spcPct val="106000"/>
+              </a:lnSpc>
+              <a:buNone/>
+              <a:defRPr sz="4950" b="1">
                 <a:solidFill>
                   <a:srgbClr val="FFFFFF"/>
                 </a:solidFill>
@@ -3177,7 +3380,7 @@
               </a:defRPr>
             </a:pPr>
             <a:r>
-              <a:rPr sz="2250" b="1">
+              <a:rPr sz="4950" b="1">
                 <a:solidFill>
                   <a:srgbClr val="FFFFFF"/>
                 </a:solidFill>
@@ -3185,29 +3388,128 @@
                 <a:ea typeface="Arial"/>
                 <a:cs typeface="Arial"/>
               </a:rPr>
-              <a:t>UNESCO</a:t>
-            </a:r>
-          </a:p>
-        </p:txBody>
-      </p:sp>
-      <p:sp>
-        <p:nvSpPr>
-          <p:cNvPr id="6" name="s1-kicker-6">
-            <a:extLst xmlns:a="http://schemas.openxmlformats.org/drawingml/2006/main">
-              <a:ext uri="{FF2B5EF4-FFF2-40B4-BE49-F238E27FC236}">
-                <a16:creationId xmlns:a16="http://schemas.microsoft.com/office/drawing/2014/main" id="{AF2D5AC2-571D-4BC0-9D7F-3CEBE52EDF55}"/>
-              </a:ext>
-            </a:extLst>
-          </p:cNvPr>
-          <p:cNvSpPr>
-            <a:spLocks xmlns:a="http://schemas.openxmlformats.org/drawingml/2006/main" noGrp="1"/>
-          </p:cNvSpPr>
-          <p:nvPr/>
-        </p:nvSpPr>
-        <p:spPr>
-          <a:xfrm xmlns:a="http://schemas.openxmlformats.org/drawingml/2006/main">
-            <a:off x="8905875" y="1133475"/>
-            <a:ext cx="2752725" cy="247650"/>
+              <a:t>From AI Tool Users</a:t>
+            </a:r>
+          </a:p>
+          <a:p xmlns:a="http://schemas.openxmlformats.org/drawingml/2006/main">
+            <a:pPr algn="l">
+              <a:lnSpc>
+                <a:spcPct val="106000"/>
+              </a:lnSpc>
+              <a:buNone/>
+              <a:defRPr sz="4950" b="1">
+                <a:solidFill>
+                  <a:srgbClr val="FFFFFF"/>
+                </a:solidFill>
+                <a:latin typeface="Arial"/>
+                <a:ea typeface="Arial"/>
+                <a:cs typeface="Arial"/>
+              </a:defRPr>
+            </a:pPr>
+            <a:r>
+              <a:rPr sz="4950" b="1">
+                <a:solidFill>
+                  <a:srgbClr val="FFFFFF"/>
+                </a:solidFill>
+                <a:latin typeface="Arial"/>
+                <a:ea typeface="Arial"/>
+                <a:cs typeface="Arial"/>
+              </a:rPr>
+              <a:t>to </a:t>
+            </a:r>
+            <a:r>
+              <a:rPr sz="4950" b="1">
+                <a:solidFill>
+                  <a:srgbClr val="64D2C4"/>
+                </a:solidFill>
+                <a:latin typeface="Arial"/>
+                <a:ea typeface="Arial"/>
+                <a:cs typeface="Arial"/>
+              </a:rPr>
+              <a:t>AI Agent Creators</a:t>
+            </a:r>
+          </a:p>
+        </p:txBody>
+      </p:sp>
+      <p:sp>
+        <p:nvSpPr>
+          <p:cNvPr id="9" name="s1-body-9">
+            <a:extLst xmlns:a="http://schemas.openxmlformats.org/drawingml/2006/main">
+              <a:ext uri="{FF2B5EF4-FFF2-40B4-BE49-F238E27FC236}">
+                <a16:creationId xmlns:a16="http://schemas.microsoft.com/office/drawing/2014/main" id="{564A07CD-9856-4D11-AD90-9670358840C4}"/>
+              </a:ext>
+            </a:extLst>
+          </p:cNvPr>
+          <p:cNvSpPr>
+            <a:spLocks xmlns:a="http://schemas.openxmlformats.org/drawingml/2006/main" noGrp="1"/>
+          </p:cNvSpPr>
+          <p:nvPr/>
+        </p:nvSpPr>
+        <p:spPr>
+          <a:xfrm xmlns:a="http://schemas.openxmlformats.org/drawingml/2006/main">
+            <a:off x="533400" y="4762500"/>
+            <a:ext cx="10839450" cy="781050"/>
+          </a:xfrm>
+          <a:prstGeom xmlns:a="http://schemas.openxmlformats.org/drawingml/2006/main" prst="rect">
+            <a:avLst/>
+          </a:prstGeom>
+          <a:noFill xmlns:a="http://schemas.openxmlformats.org/drawingml/2006/main"/>
+          <a:ln xmlns:a="http://schemas.openxmlformats.org/drawingml/2006/main" w="0">
+            <a:noFill/>
+          </a:ln>
+        </p:spPr>
+        <p:txBody>
+          <a:bodyPr xmlns:a="http://schemas.openxmlformats.org/drawingml/2006/main" wrap="square" lIns="0" tIns="0" rIns="0" bIns="0" anchor="t">
+            <a:noAutofit/>
+          </a:bodyPr>
+          <a:lstStyle xmlns:a="http://schemas.openxmlformats.org/drawingml/2006/main"/>
+          <a:p xmlns:a="http://schemas.openxmlformats.org/drawingml/2006/main">
+            <a:pPr algn="l">
+              <a:lnSpc>
+                <a:spcPct val="122000"/>
+              </a:lnSpc>
+              <a:buNone/>
+              <a:defRPr sz="1950" b="0">
+                <a:solidFill>
+                  <a:srgbClr val="BED0DD"/>
+                </a:solidFill>
+                <a:latin typeface="Arial"/>
+                <a:ea typeface="Arial"/>
+                <a:cs typeface="Arial"/>
+              </a:defRPr>
+            </a:pPr>
+            <a:r>
+              <a:rPr sz="1950" b="0">
+                <a:solidFill>
+                  <a:srgbClr val="BED0DD"/>
+                </a:solidFill>
+                <a:latin typeface="Arial"/>
+                <a:ea typeface="Arial"/>
+                <a:cs typeface="Arial"/>
+              </a:rPr>
+              <a:t>Helping teachers shape AI support for learning.</a:t>
+            </a:r>
+          </a:p>
+        </p:txBody>
+      </p:sp>
+      <p:sp>
+        <p:nvSpPr>
+          <p:cNvPr id="10" name="s1-body-10">
+            <a:extLst xmlns:a="http://schemas.openxmlformats.org/drawingml/2006/main">
+              <a:ext uri="{FF2B5EF4-FFF2-40B4-BE49-F238E27FC236}">
+                <a16:creationId xmlns:a16="http://schemas.microsoft.com/office/drawing/2014/main" id="{595FF1DF-ACE7-44A4-9210-81D9594B4731}"/>
+              </a:ext>
+            </a:extLst>
+          </p:cNvPr>
+          <p:cNvSpPr>
+            <a:spLocks xmlns:a="http://schemas.openxmlformats.org/drawingml/2006/main" noGrp="1"/>
+          </p:cNvSpPr>
+          <p:nvPr/>
+        </p:nvSpPr>
+        <p:spPr>
+          <a:xfrm xmlns:a="http://schemas.openxmlformats.org/drawingml/2006/main">
+            <a:off x="533400" y="6200775"/>
+            <a:ext cx="7239000" cy="257175"/>
           </a:xfrm>
           <a:prstGeom xmlns:a="http://schemas.openxmlformats.org/drawingml/2006/main" prst="rect">
             <a:avLst/>
@@ -3228,7 +3530,7 @@
                 <a:spcPct val="120000"/>
               </a:lnSpc>
               <a:buNone/>
-              <a:defRPr sz="1050" b="1">
+              <a:defRPr sz="1200" b="0">
                 <a:solidFill>
                   <a:srgbClr val="BED0DD"/>
                 </a:solidFill>
@@ -3238,7 +3540,7 @@
               </a:defRPr>
             </a:pPr>
             <a:r>
-              <a:rPr sz="1050" b="1">
+              <a:rPr sz="1200" b="0">
                 <a:solidFill>
                   <a:srgbClr val="BED0DD"/>
                 </a:solidFill>
@@ -3246,226 +3548,50 @@
                 <a:ea typeface="Arial"/>
                 <a:cs typeface="Arial"/>
               </a:rPr>
-              <a:t>DIGITAL LEARNING WEEK 2026</a:t>
-            </a:r>
-          </a:p>
-        </p:txBody>
-      </p:sp>
-      <p:sp>
-        <p:nvSpPr>
-          <p:cNvPr id="7" name="s1-kicker-7">
-            <a:extLst xmlns:a="http://schemas.openxmlformats.org/drawingml/2006/main">
-              <a:ext uri="{FF2B5EF4-FFF2-40B4-BE49-F238E27FC236}">
-                <a16:creationId xmlns:a16="http://schemas.microsoft.com/office/drawing/2014/main" id="{F452D0AB-293F-4E5A-B3A7-59D4F79817C2}"/>
-              </a:ext>
-            </a:extLst>
-          </p:cNvPr>
-          <p:cNvSpPr>
-            <a:spLocks xmlns:a="http://schemas.openxmlformats.org/drawingml/2006/main" noGrp="1"/>
-          </p:cNvSpPr>
-          <p:nvPr/>
-        </p:nvSpPr>
-        <p:spPr>
-          <a:xfrm xmlns:a="http://schemas.openxmlformats.org/drawingml/2006/main">
-            <a:off x="533400" y="1714500"/>
-            <a:ext cx="5981700" cy="285750"/>
-          </a:xfrm>
-          <a:prstGeom xmlns:a="http://schemas.openxmlformats.org/drawingml/2006/main" prst="rect">
-            <a:avLst/>
-          </a:prstGeom>
-          <a:noFill xmlns:a="http://schemas.openxmlformats.org/drawingml/2006/main"/>
-          <a:ln xmlns:a="http://schemas.openxmlformats.org/drawingml/2006/main" w="0">
-            <a:noFill/>
-          </a:ln>
-        </p:spPr>
-        <p:txBody>
-          <a:bodyPr xmlns:a="http://schemas.openxmlformats.org/drawingml/2006/main" wrap="square" lIns="0" tIns="0" rIns="0" bIns="0" anchor="t">
-            <a:noAutofit/>
-          </a:bodyPr>
-          <a:lstStyle xmlns:a="http://schemas.openxmlformats.org/drawingml/2006/main"/>
-          <a:p xmlns:a="http://schemas.openxmlformats.org/drawingml/2006/main">
-            <a:pPr algn="l">
+              <a:t>Haiyang Xin · CocoRobo Ltd.</a:t>
+            </a:r>
+          </a:p>
+        </p:txBody>
+      </p:sp>
+      <p:sp>
+        <p:nvSpPr>
+          <p:cNvPr id="11" name="s1-body-11">
+            <a:extLst xmlns:a="http://schemas.openxmlformats.org/drawingml/2006/main">
+              <a:ext uri="{FF2B5EF4-FFF2-40B4-BE49-F238E27FC236}">
+                <a16:creationId xmlns:a16="http://schemas.microsoft.com/office/drawing/2014/main" id="{6E509953-537B-4275-A609-B554ECD0CF57}"/>
+              </a:ext>
+            </a:extLst>
+          </p:cNvPr>
+          <p:cNvSpPr>
+            <a:spLocks xmlns:a="http://schemas.openxmlformats.org/drawingml/2006/main" noGrp="1"/>
+          </p:cNvSpPr>
+          <p:nvPr/>
+        </p:nvSpPr>
+        <p:spPr>
+          <a:xfrm xmlns:a="http://schemas.openxmlformats.org/drawingml/2006/main">
+            <a:off x="9906000" y="6200775"/>
+            <a:ext cx="1752600" cy="257175"/>
+          </a:xfrm>
+          <a:prstGeom xmlns:a="http://schemas.openxmlformats.org/drawingml/2006/main" prst="rect">
+            <a:avLst/>
+          </a:prstGeom>
+          <a:noFill xmlns:a="http://schemas.openxmlformats.org/drawingml/2006/main"/>
+          <a:ln xmlns:a="http://schemas.openxmlformats.org/drawingml/2006/main" w="0">
+            <a:noFill/>
+          </a:ln>
+        </p:spPr>
+        <p:txBody>
+          <a:bodyPr xmlns:a="http://schemas.openxmlformats.org/drawingml/2006/main" wrap="square" lIns="0" tIns="0" rIns="0" bIns="0" anchor="t">
+            <a:noAutofit/>
+          </a:bodyPr>
+          <a:lstStyle xmlns:a="http://schemas.openxmlformats.org/drawingml/2006/main"/>
+          <a:p xmlns:a="http://schemas.openxmlformats.org/drawingml/2006/main">
+            <a:pPr algn="r">
               <a:lnSpc>
                 <a:spcPct val="120000"/>
               </a:lnSpc>
               <a:buNone/>
-              <a:defRPr sz="1200" b="1">
-                <a:solidFill>
-                  <a:srgbClr val="64D2C4"/>
-                </a:solidFill>
-                <a:latin typeface="Arial"/>
-                <a:ea typeface="Arial"/>
-                <a:cs typeface="Arial"/>
-              </a:defRPr>
-            </a:pPr>
-            <a:r>
-              <a:rPr sz="1200" b="1">
-                <a:solidFill>
-                  <a:srgbClr val="64D2C4"/>
-                </a:solidFill>
-                <a:latin typeface="Arial"/>
-                <a:ea typeface="Arial"/>
-                <a:cs typeface="Arial"/>
-              </a:rPr>
-              <a:t>TEACHER AGENCY · PRACTICE &amp; RESEARCH</a:t>
-            </a:r>
-          </a:p>
-        </p:txBody>
-      </p:sp>
-      <p:sp>
-        <p:nvSpPr>
-          <p:cNvPr id="8" name="s1-title-8">
-            <a:extLst xmlns:a="http://schemas.openxmlformats.org/drawingml/2006/main">
-              <a:ext uri="{FF2B5EF4-FFF2-40B4-BE49-F238E27FC236}">
-                <a16:creationId xmlns:a16="http://schemas.microsoft.com/office/drawing/2014/main" id="{BFADBDC1-4F23-4661-93FA-AC825E0EC945}"/>
-              </a:ext>
-            </a:extLst>
-          </p:cNvPr>
-          <p:cNvSpPr>
-            <a:spLocks xmlns:a="http://schemas.openxmlformats.org/drawingml/2006/main" noGrp="1"/>
-          </p:cNvSpPr>
-          <p:nvPr/>
-        </p:nvSpPr>
-        <p:spPr>
-          <a:xfrm xmlns:a="http://schemas.openxmlformats.org/drawingml/2006/main">
-            <a:off x="533400" y="2266950"/>
-            <a:ext cx="5981700" cy="2324100"/>
-          </a:xfrm>
-          <a:prstGeom xmlns:a="http://schemas.openxmlformats.org/drawingml/2006/main" prst="rect">
-            <a:avLst/>
-          </a:prstGeom>
-          <a:noFill xmlns:a="http://schemas.openxmlformats.org/drawingml/2006/main"/>
-          <a:ln xmlns:a="http://schemas.openxmlformats.org/drawingml/2006/main" w="0">
-            <a:noFill/>
-          </a:ln>
-        </p:spPr>
-        <p:txBody>
-          <a:bodyPr xmlns:a="http://schemas.openxmlformats.org/drawingml/2006/main" wrap="square" lIns="0" tIns="0" rIns="0" bIns="0" anchor="t">
-            <a:noAutofit/>
-          </a:bodyPr>
-          <a:lstStyle xmlns:a="http://schemas.openxmlformats.org/drawingml/2006/main"/>
-          <a:p xmlns:a="http://schemas.openxmlformats.org/drawingml/2006/main">
-            <a:pPr algn="l">
-              <a:lnSpc>
-                <a:spcPct val="102000"/>
-              </a:lnSpc>
-              <a:buNone/>
-              <a:defRPr sz="4500" b="1">
-                <a:solidFill>
-                  <a:srgbClr val="FFFFFF"/>
-                </a:solidFill>
-                <a:latin typeface="Arial"/>
-                <a:ea typeface="Arial"/>
-                <a:cs typeface="Arial"/>
-              </a:defRPr>
-            </a:pPr>
-            <a:r>
-              <a:rPr sz="4500" b="1">
-                <a:solidFill>
-                  <a:srgbClr val="FFFFFF"/>
-                </a:solidFill>
-                <a:latin typeface="Arial"/>
-                <a:ea typeface="Arial"/>
-                <a:cs typeface="Arial"/>
-              </a:rPr>
-              <a:t>From AI Tool Users</a:t>
-            </a:r>
-          </a:p>
-          <a:p xmlns:a="http://schemas.openxmlformats.org/drawingml/2006/main">
-            <a:pPr algn="l">
-              <a:lnSpc>
-                <a:spcPct val="102000"/>
-              </a:lnSpc>
-              <a:buNone/>
-              <a:defRPr sz="4500" b="1">
-                <a:solidFill>
-                  <a:srgbClr val="FFFFFF"/>
-                </a:solidFill>
-                <a:latin typeface="Arial"/>
-                <a:ea typeface="Arial"/>
-                <a:cs typeface="Arial"/>
-              </a:defRPr>
-            </a:pPr>
-            <a:r>
-              <a:rPr sz="4500" b="1">
-                <a:solidFill>
-                  <a:srgbClr val="FFFFFF"/>
-                </a:solidFill>
-                <a:latin typeface="Arial"/>
-                <a:ea typeface="Arial"/>
-                <a:cs typeface="Arial"/>
-              </a:rPr>
-              <a:t>to AI Agent</a:t>
-            </a:r>
-          </a:p>
-          <a:p xmlns:a="http://schemas.openxmlformats.org/drawingml/2006/main">
-            <a:pPr algn="l">
-              <a:lnSpc>
-                <a:spcPct val="102000"/>
-              </a:lnSpc>
-              <a:buNone/>
-              <a:defRPr sz="4500" b="1">
-                <a:solidFill>
-                  <a:srgbClr val="FFFFFF"/>
-                </a:solidFill>
-                <a:latin typeface="Arial"/>
-                <a:ea typeface="Arial"/>
-                <a:cs typeface="Arial"/>
-              </a:defRPr>
-            </a:pPr>
-            <a:r>
-              <a:rPr sz="4500" b="1">
-                <a:solidFill>
-                  <a:srgbClr val="FFFFFF"/>
-                </a:solidFill>
-                <a:latin typeface="Arial"/>
-                <a:ea typeface="Arial"/>
-                <a:cs typeface="Arial"/>
-              </a:rPr>
-              <a:t>Creators</a:t>
-            </a:r>
-          </a:p>
-        </p:txBody>
-      </p:sp>
-      <p:sp>
-        <p:nvSpPr>
-          <p:cNvPr id="9" name="s1-body-9">
-            <a:extLst xmlns:a="http://schemas.openxmlformats.org/drawingml/2006/main">
-              <a:ext uri="{FF2B5EF4-FFF2-40B4-BE49-F238E27FC236}">
-                <a16:creationId xmlns:a16="http://schemas.microsoft.com/office/drawing/2014/main" id="{564A07CD-9856-4D11-AD90-9670358840C4}"/>
-              </a:ext>
-            </a:extLst>
-          </p:cNvPr>
-          <p:cNvSpPr>
-            <a:spLocks xmlns:a="http://schemas.openxmlformats.org/drawingml/2006/main" noGrp="1"/>
-          </p:cNvSpPr>
-          <p:nvPr/>
-        </p:nvSpPr>
-        <p:spPr>
-          <a:xfrm xmlns:a="http://schemas.openxmlformats.org/drawingml/2006/main">
-            <a:off x="533400" y="4895850"/>
-            <a:ext cx="5591175" cy="981075"/>
-          </a:xfrm>
-          <a:prstGeom xmlns:a="http://schemas.openxmlformats.org/drawingml/2006/main" prst="rect">
-            <a:avLst/>
-          </a:prstGeom>
-          <a:noFill xmlns:a="http://schemas.openxmlformats.org/drawingml/2006/main"/>
-          <a:ln xmlns:a="http://schemas.openxmlformats.org/drawingml/2006/main" w="0">
-            <a:noFill/>
-          </a:ln>
-        </p:spPr>
-        <p:txBody>
-          <a:bodyPr xmlns:a="http://schemas.openxmlformats.org/drawingml/2006/main" wrap="square" lIns="0" tIns="0" rIns="0" bIns="0" anchor="t">
-            <a:noAutofit/>
-          </a:bodyPr>
-          <a:lstStyle xmlns:a="http://schemas.openxmlformats.org/drawingml/2006/main"/>
-          <a:p xmlns:a="http://schemas.openxmlformats.org/drawingml/2006/main">
-            <a:pPr algn="l">
-              <a:lnSpc>
-                <a:spcPct val="120000"/>
-              </a:lnSpc>
-              <a:buNone/>
-              <a:defRPr sz="2250" b="0">
+              <a:defRPr sz="1200" b="0">
                 <a:solidFill>
                   <a:srgbClr val="BED0DD"/>
                 </a:solidFill>
@@ -3475,129 +3601,7 @@
               </a:defRPr>
             </a:pPr>
             <a:r>
-              <a:rPr sz="2250" b="0">
-                <a:solidFill>
-                  <a:srgbClr val="BED0DD"/>
-                </a:solidFill>
-                <a:latin typeface="Arial"/>
-                <a:ea typeface="Arial"/>
-                <a:cs typeface="Arial"/>
-              </a:rPr>
-              <a:t>Helping teachers shape AI support for learning.</a:t>
-            </a:r>
-          </a:p>
-        </p:txBody>
-      </p:sp>
-      <p:sp>
-        <p:nvSpPr>
-          <p:cNvPr id="10" name="s1-body-10">
-            <a:extLst xmlns:a="http://schemas.openxmlformats.org/drawingml/2006/main">
-              <a:ext uri="{FF2B5EF4-FFF2-40B4-BE49-F238E27FC236}">
-                <a16:creationId xmlns:a16="http://schemas.microsoft.com/office/drawing/2014/main" id="{595FF1DF-ACE7-44A4-9210-81D9594B4731}"/>
-              </a:ext>
-            </a:extLst>
-          </p:cNvPr>
-          <p:cNvSpPr>
-            <a:spLocks xmlns:a="http://schemas.openxmlformats.org/drawingml/2006/main" noGrp="1"/>
-          </p:cNvSpPr>
-          <p:nvPr/>
-        </p:nvSpPr>
-        <p:spPr>
-          <a:xfrm xmlns:a="http://schemas.openxmlformats.org/drawingml/2006/main">
-            <a:off x="533400" y="6076950"/>
-            <a:ext cx="5981700" cy="333375"/>
-          </a:xfrm>
-          <a:prstGeom xmlns:a="http://schemas.openxmlformats.org/drawingml/2006/main" prst="rect">
-            <a:avLst/>
-          </a:prstGeom>
-          <a:noFill xmlns:a="http://schemas.openxmlformats.org/drawingml/2006/main"/>
-          <a:ln xmlns:a="http://schemas.openxmlformats.org/drawingml/2006/main" w="0">
-            <a:noFill/>
-          </a:ln>
-        </p:spPr>
-        <p:txBody>
-          <a:bodyPr xmlns:a="http://schemas.openxmlformats.org/drawingml/2006/main" wrap="square" lIns="0" tIns="0" rIns="0" bIns="0" anchor="t">
-            <a:noAutofit/>
-          </a:bodyPr>
-          <a:lstStyle xmlns:a="http://schemas.openxmlformats.org/drawingml/2006/main"/>
-          <a:p xmlns:a="http://schemas.openxmlformats.org/drawingml/2006/main">
-            <a:pPr algn="l">
-              <a:lnSpc>
-                <a:spcPct val="120000"/>
-              </a:lnSpc>
-              <a:buNone/>
-              <a:defRPr sz="1800" b="1">
-                <a:solidFill>
-                  <a:srgbClr val="FFFFFF"/>
-                </a:solidFill>
-                <a:latin typeface="Arial"/>
-                <a:ea typeface="Arial"/>
-                <a:cs typeface="Arial"/>
-              </a:defRPr>
-            </a:pPr>
-            <a:r>
-              <a:rPr sz="1800" b="1">
-                <a:solidFill>
-                  <a:srgbClr val="FFFFFF"/>
-                </a:solidFill>
-                <a:latin typeface="Arial"/>
-                <a:ea typeface="Arial"/>
-                <a:cs typeface="Arial"/>
-              </a:rPr>
-              <a:t>Haiyang Xin · CocoRobo Ltd.</a:t>
-            </a:r>
-          </a:p>
-        </p:txBody>
-      </p:sp>
-      <p:sp>
-        <p:nvSpPr>
-          <p:cNvPr id="11" name="s1-body-11">
-            <a:extLst xmlns:a="http://schemas.openxmlformats.org/drawingml/2006/main">
-              <a:ext uri="{FF2B5EF4-FFF2-40B4-BE49-F238E27FC236}">
-                <a16:creationId xmlns:a16="http://schemas.microsoft.com/office/drawing/2014/main" id="{6E509953-537B-4275-A609-B554ECD0CF57}"/>
-              </a:ext>
-            </a:extLst>
-          </p:cNvPr>
-          <p:cNvSpPr>
-            <a:spLocks xmlns:a="http://schemas.openxmlformats.org/drawingml/2006/main" noGrp="1"/>
-          </p:cNvSpPr>
-          <p:nvPr/>
-        </p:nvSpPr>
-        <p:spPr>
-          <a:xfrm xmlns:a="http://schemas.openxmlformats.org/drawingml/2006/main">
-            <a:off x="9906000" y="6438900"/>
-            <a:ext cx="1752600" cy="247650"/>
-          </a:xfrm>
-          <a:prstGeom xmlns:a="http://schemas.openxmlformats.org/drawingml/2006/main" prst="rect">
-            <a:avLst/>
-          </a:prstGeom>
-          <a:noFill xmlns:a="http://schemas.openxmlformats.org/drawingml/2006/main"/>
-          <a:ln xmlns:a="http://schemas.openxmlformats.org/drawingml/2006/main" w="0">
-            <a:noFill/>
-          </a:ln>
-        </p:spPr>
-        <p:txBody>
-          <a:bodyPr xmlns:a="http://schemas.openxmlformats.org/drawingml/2006/main" wrap="square" lIns="0" tIns="0" rIns="0" bIns="0" anchor="t">
-            <a:noAutofit/>
-          </a:bodyPr>
-          <a:lstStyle xmlns:a="http://schemas.openxmlformats.org/drawingml/2006/main"/>
-          <a:p xmlns:a="http://schemas.openxmlformats.org/drawingml/2006/main">
-            <a:pPr algn="r">
-              <a:lnSpc>
-                <a:spcPct val="120000"/>
-              </a:lnSpc>
-              <a:buNone/>
-              <a:defRPr sz="1350" b="0">
-                <a:solidFill>
-                  <a:srgbClr val="BED0DD"/>
-                </a:solidFill>
-                <a:latin typeface="Arial"/>
-                <a:ea typeface="Arial"/>
-                <a:cs typeface="Arial"/>
-              </a:defRPr>
-            </a:pPr>
-            <a:r>
-              <a:rPr sz="1350" b="0">
+              <a:rPr sz="1200" b="0">
                 <a:solidFill>
                   <a:srgbClr val="BED0DD"/>
                 </a:solidFill>
@@ -4862,7 +4866,7 @@
           <p:nvPr/>
         </p:nvPicPr>
         <p:blipFill>
-          <a:blip xmlns:r="http://schemas.openxmlformats.org/officeDocument/2006/relationships" xmlns:a="http://schemas.openxmlformats.org/drawingml/2006/main" r:embed="Rf2894ca9cb1745f2"/>
+          <a:blip xmlns:r="http://schemas.openxmlformats.org/officeDocument/2006/relationships" xmlns:a="http://schemas.openxmlformats.org/drawingml/2006/main" r:embed="R085610fc62f740db"/>
           <a:stretch xmlns:a="http://schemas.openxmlformats.org/drawingml/2006/main"/>
         </p:blipFill>
         <p:spPr>
@@ -5367,7 +5371,7 @@
           <p:nvPr/>
         </p:nvPicPr>
         <p:blipFill>
-          <a:blip xmlns:r="http://schemas.openxmlformats.org/officeDocument/2006/relationships" xmlns:a="http://schemas.openxmlformats.org/drawingml/2006/main" r:embed="Ra19e21ee3f2b4d99"/>
+          <a:blip xmlns:r="http://schemas.openxmlformats.org/officeDocument/2006/relationships" xmlns:a="http://schemas.openxmlformats.org/drawingml/2006/main" r:embed="Rd8522e16d11f4a6a"/>
           <a:stretch xmlns:a="http://schemas.openxmlformats.org/drawingml/2006/main"/>
         </p:blipFill>
         <p:spPr>
@@ -5663,7 +5667,7 @@
           <p:nvPr/>
         </p:nvPicPr>
         <p:blipFill>
-          <a:blip xmlns:r="http://schemas.openxmlformats.org/officeDocument/2006/relationships" xmlns:a="http://schemas.openxmlformats.org/drawingml/2006/main" r:embed="R5728d907d08746db"/>
+          <a:blip xmlns:r="http://schemas.openxmlformats.org/officeDocument/2006/relationships" xmlns:a="http://schemas.openxmlformats.org/drawingml/2006/main" r:embed="R8bd7452a8b4a4868"/>
           <a:stretch xmlns:a="http://schemas.openxmlformats.org/drawingml/2006/main"/>
         </p:blipFill>
         <p:spPr>
@@ -6134,7 +6138,7 @@
           <p:nvPr/>
         </p:nvPicPr>
         <p:blipFill>
-          <a:blip xmlns:r="http://schemas.openxmlformats.org/officeDocument/2006/relationships" xmlns:a="http://schemas.openxmlformats.org/drawingml/2006/main" r:embed="Rf25aff374a0748bc"/>
+          <a:blip xmlns:r="http://schemas.openxmlformats.org/officeDocument/2006/relationships" xmlns:a="http://schemas.openxmlformats.org/drawingml/2006/main" r:embed="Rc3eaff21f9be430b"/>
           <a:srcRect xmlns:a="http://schemas.openxmlformats.org/drawingml/2006/main" l="7910" t="0" r="7910" b="0"/>
           <a:stretch xmlns:a="http://schemas.openxmlformats.org/drawingml/2006/main">
             <a:fillRect l="0" t="0" r="0" b="0"/>
@@ -6433,7 +6437,7 @@
           <p:nvPr/>
         </p:nvPicPr>
         <p:blipFill>
-          <a:blip xmlns:r="http://schemas.openxmlformats.org/officeDocument/2006/relationships" xmlns:a="http://schemas.openxmlformats.org/drawingml/2006/main" r:embed="R13e6f311f1fb489c"/>
+          <a:blip xmlns:r="http://schemas.openxmlformats.org/officeDocument/2006/relationships" xmlns:a="http://schemas.openxmlformats.org/drawingml/2006/main" r:embed="Rbe85e3fd1bf44dee"/>
           <a:stretch xmlns:a="http://schemas.openxmlformats.org/drawingml/2006/main"/>
         </p:blipFill>
         <p:spPr>
@@ -7727,7 +7731,7 @@
           <p:nvPr/>
         </p:nvPicPr>
         <p:blipFill>
-          <a:blip xmlns:r="http://schemas.openxmlformats.org/officeDocument/2006/relationships" xmlns:a="http://schemas.openxmlformats.org/drawingml/2006/main" r:embed="Rceff311847f3427a"/>
+          <a:blip xmlns:r="http://schemas.openxmlformats.org/officeDocument/2006/relationships" xmlns:a="http://schemas.openxmlformats.org/drawingml/2006/main" r:embed="Rf081ae423c2740f5"/>
           <a:stretch xmlns:a="http://schemas.openxmlformats.org/drawingml/2006/main"/>
         </p:blipFill>
         <p:spPr>
@@ -8917,7 +8921,7 @@
           <p:nvPr/>
         </p:nvPicPr>
         <p:blipFill>
-          <a:blip xmlns:r="http://schemas.openxmlformats.org/officeDocument/2006/relationships" xmlns:a="http://schemas.openxmlformats.org/drawingml/2006/main" r:embed="R36974dca6a6c4f48"/>
+          <a:blip xmlns:r="http://schemas.openxmlformats.org/officeDocument/2006/relationships" xmlns:a="http://schemas.openxmlformats.org/drawingml/2006/main" r:embed="R3ae13646906042b9"/>
           <a:stretch xmlns:a="http://schemas.openxmlformats.org/drawingml/2006/main"/>
         </p:blipFill>
         <p:spPr>
@@ -9940,7 +9944,7 @@
           <p:nvPr/>
         </p:nvPicPr>
         <p:blipFill>
-          <a:blip xmlns:r="http://schemas.openxmlformats.org/officeDocument/2006/relationships" xmlns:a="http://schemas.openxmlformats.org/drawingml/2006/main" r:embed="Re12e6aa7329b4508"/>
+          <a:blip xmlns:r="http://schemas.openxmlformats.org/officeDocument/2006/relationships" xmlns:a="http://schemas.openxmlformats.org/drawingml/2006/main" r:embed="R4f200888b3544ca6"/>
           <a:stretch xmlns:a="http://schemas.openxmlformats.org/drawingml/2006/main"/>
         </p:blipFill>
         <p:spPr>
@@ -10411,7 +10415,7 @@
           <p:nvPr/>
         </p:nvPicPr>
         <p:blipFill>
-          <a:blip xmlns:r="http://schemas.openxmlformats.org/officeDocument/2006/relationships" xmlns:a="http://schemas.openxmlformats.org/drawingml/2006/main" r:embed="Rccf074f4a1ad49f9"/>
+          <a:blip xmlns:r="http://schemas.openxmlformats.org/officeDocument/2006/relationships" xmlns:a="http://schemas.openxmlformats.org/drawingml/2006/main" r:embed="Re2efbea6cd2f4388"/>
           <a:stretch xmlns:a="http://schemas.openxmlformats.org/drawingml/2006/main"/>
         </p:blipFill>
         <p:spPr>
@@ -10707,7 +10711,7 @@
           <p:nvPr/>
         </p:nvPicPr>
         <p:blipFill>
-          <a:blip xmlns:r="http://schemas.openxmlformats.org/officeDocument/2006/relationships" xmlns:a="http://schemas.openxmlformats.org/drawingml/2006/main" r:embed="R0b47f8a9e1d242af"/>
+          <a:blip xmlns:r="http://schemas.openxmlformats.org/officeDocument/2006/relationships" xmlns:a="http://schemas.openxmlformats.org/drawingml/2006/main" r:embed="Ra13c32c66f9d4727"/>
           <a:stretch xmlns:a="http://schemas.openxmlformats.org/drawingml/2006/main"/>
         </p:blipFill>
         <p:spPr>
@@ -11083,7 +11087,7 @@
           <p:nvPr/>
         </p:nvPicPr>
         <p:blipFill>
-          <a:blip xmlns:r="http://schemas.openxmlformats.org/officeDocument/2006/relationships" xmlns:a="http://schemas.openxmlformats.org/drawingml/2006/main" r:embed="R278ff01c2ea54fd0"/>
+          <a:blip xmlns:r="http://schemas.openxmlformats.org/officeDocument/2006/relationships" xmlns:a="http://schemas.openxmlformats.org/drawingml/2006/main" r:embed="R19da18e30bb947d6"/>
           <a:srcRect xmlns:a="http://schemas.openxmlformats.org/drawingml/2006/main" l="0" t="0" r="0" b="0"/>
           <a:stretch xmlns:a="http://schemas.openxmlformats.org/drawingml/2006/main"/>
         </p:blipFill>
@@ -11152,7 +11156,7 @@
                 <a:latin typeface="Arial"/>
                 <a:ea typeface="Arial"/>
                 <a:cs typeface="Arial"/>
-                <a:hlinkClick xmlns:r="http://schemas.openxmlformats.org/officeDocument/2006/relationships" r:id="Rc1fdea49412246c6"/>
+                <a:hlinkClick xmlns:r="http://schemas.openxmlformats.org/officeDocument/2006/relationships" r:id="R2167a69a8026485f"/>
               </a:rPr>
               <a:t>Online slides ·</a:t>
             </a:r>
@@ -11180,7 +11184,7 @@
                 <a:latin typeface="Arial"/>
                 <a:ea typeface="Arial"/>
                 <a:cs typeface="Arial"/>
-                <a:hlinkClick xmlns:r="http://schemas.openxmlformats.org/officeDocument/2006/relationships" r:id="R38f6d13adc3c4d6e"/>
+                <a:hlinkClick xmlns:r="http://schemas.openxmlformats.org/officeDocument/2006/relationships" r:id="Rd3713aa74cfb4e6a"/>
               </a:rPr>
               <a:t>current version</a:t>
             </a:r>
@@ -11284,7 +11288,7 @@
           <p:nvPr/>
         </p:nvPicPr>
         <p:blipFill>
-          <a:blip xmlns:r="http://schemas.openxmlformats.org/officeDocument/2006/relationships" xmlns:a="http://schemas.openxmlformats.org/drawingml/2006/main" r:embed="Rf6ca180af64c4b33"/>
+          <a:blip xmlns:r="http://schemas.openxmlformats.org/officeDocument/2006/relationships" xmlns:a="http://schemas.openxmlformats.org/drawingml/2006/main" r:embed="Rad79f1b2ad0145d9"/>
           <a:srcRect xmlns:a="http://schemas.openxmlformats.org/drawingml/2006/main" l="0" t="0" r="0" b="0"/>
           <a:stretch xmlns:a="http://schemas.openxmlformats.org/drawingml/2006/main"/>
         </p:blipFill>
@@ -11353,7 +11357,7 @@
                 <a:latin typeface="Arial"/>
                 <a:ea typeface="Arial"/>
                 <a:cs typeface="Arial"/>
-                <a:hlinkClick xmlns:r="http://schemas.openxmlformats.org/officeDocument/2006/relationships" r:id="Re98b7047d68943a4"/>
+                <a:hlinkClick xmlns:r="http://schemas.openxmlformats.org/officeDocument/2006/relationships" r:id="R82627b9deffa40b6"/>
               </a:rPr>
               <a:t>UNESCO submission ·</a:t>
             </a:r>
@@ -11381,7 +11385,7 @@
                 <a:latin typeface="Arial"/>
                 <a:ea typeface="Arial"/>
                 <a:cs typeface="Arial"/>
-                <a:hlinkClick xmlns:r="http://schemas.openxmlformats.org/officeDocument/2006/relationships" r:id="R10927b1b6e8c4c40"/>
+                <a:hlinkClick xmlns:r="http://schemas.openxmlformats.org/officeDocument/2006/relationships" r:id="R620ae00bc0f949b6"/>
               </a:rPr>
               <a:t>studies and evidence</a:t>
             </a:r>
@@ -11531,7 +11535,7 @@
                 <a:latin typeface="Arial"/>
                 <a:ea typeface="Arial"/>
                 <a:cs typeface="Arial"/>
-                <a:hlinkClick xmlns:r="http://schemas.openxmlformats.org/officeDocument/2006/relationships" r:id="R00d74c07294f47ae"/>
+                <a:hlinkClick xmlns:r="http://schemas.openxmlformats.org/officeDocument/2006/relationships" r:id="R5feee081b5594d70"/>
               </a:rPr>
               <a:t>tony@cocorobo.cc</a:t>
             </a:r>
@@ -11608,7 +11612,7 @@
           <p:nvPr/>
         </p:nvPicPr>
         <p:blipFill>
-          <a:blip xmlns:r="http://schemas.openxmlformats.org/officeDocument/2006/relationships" xmlns:a="http://schemas.openxmlformats.org/drawingml/2006/main" r:embed="R9c0fa6c9714e4a5f"/>
+          <a:blip xmlns:r="http://schemas.openxmlformats.org/officeDocument/2006/relationships" xmlns:a="http://schemas.openxmlformats.org/drawingml/2006/main" r:embed="R1aadeb96c00b41f2"/>
           <a:stretch xmlns:a="http://schemas.openxmlformats.org/drawingml/2006/main"/>
         </p:blipFill>
         <p:spPr>
@@ -12269,7 +12273,7 @@
           <p:nvPr/>
         </p:nvPicPr>
         <p:blipFill>
-          <a:blip xmlns:r="http://schemas.openxmlformats.org/officeDocument/2006/relationships" xmlns:a="http://schemas.openxmlformats.org/drawingml/2006/main" r:embed="R8ba796f190484ef6"/>
+          <a:blip xmlns:r="http://schemas.openxmlformats.org/officeDocument/2006/relationships" xmlns:a="http://schemas.openxmlformats.org/drawingml/2006/main" r:embed="R65ce07bab6374768"/>
           <a:srcRect xmlns:a="http://schemas.openxmlformats.org/drawingml/2006/main" l="0" t="2370" r="0" b="2370"/>
           <a:stretch xmlns:a="http://schemas.openxmlformats.org/drawingml/2006/main"/>
         </p:blipFill>
@@ -12566,7 +12570,7 @@
           <p:nvPr/>
         </p:nvPicPr>
         <p:blipFill>
-          <a:blip xmlns:r="http://schemas.openxmlformats.org/officeDocument/2006/relationships" xmlns:a="http://schemas.openxmlformats.org/drawingml/2006/main" r:embed="Ra380f29c6f1e4825"/>
+          <a:blip xmlns:r="http://schemas.openxmlformats.org/officeDocument/2006/relationships" xmlns:a="http://schemas.openxmlformats.org/drawingml/2006/main" r:embed="R020ff23c09694faf"/>
           <a:stretch xmlns:a="http://schemas.openxmlformats.org/drawingml/2006/main"/>
         </p:blipFill>
         <p:spPr>
@@ -13436,7 +13440,7 @@
           <p:nvPr/>
         </p:nvPicPr>
         <p:blipFill>
-          <a:blip xmlns:r="http://schemas.openxmlformats.org/officeDocument/2006/relationships" xmlns:a="http://schemas.openxmlformats.org/drawingml/2006/main" r:embed="R2b7d03e96c53402b"/>
+          <a:blip xmlns:r="http://schemas.openxmlformats.org/officeDocument/2006/relationships" xmlns:a="http://schemas.openxmlformats.org/drawingml/2006/main" r:embed="R87e10597b03946dc"/>
           <a:stretch xmlns:a="http://schemas.openxmlformats.org/drawingml/2006/main"/>
         </p:blipFill>
         <p:spPr>
@@ -13804,7 +13808,7 @@
                 <a:latin typeface="Arial"/>
                 <a:ea typeface="Arial"/>
                 <a:cs typeface="Arial"/>
-                <a:hlinkClick xmlns:r="http://schemas.openxmlformats.org/officeDocument/2006/relationships" r:id="R318dfc68399a499d"/>
+                <a:hlinkClick xmlns:r="http://schemas.openxmlformats.org/officeDocument/2006/relationships" r:id="R906e47a8de8a433c"/>
               </a:rPr>
               <a:t>Guangdong Department of Education</a:t>
             </a:r>
@@ -13832,7 +13836,7 @@
                 <a:latin typeface="Arial"/>
                 <a:ea typeface="Arial"/>
                 <a:cs typeface="Arial"/>
-                <a:hlinkClick xmlns:r="http://schemas.openxmlformats.org/officeDocument/2006/relationships" r:id="R0ee660f15c5e48b6"/>
+                <a:hlinkClick xmlns:r="http://schemas.openxmlformats.org/officeDocument/2006/relationships" r:id="Rf11f1b21d6db43f9"/>
               </a:rPr>
               <a:t>9 April 2025 · Trial documents</a:t>
             </a:r>
@@ -14427,7 +14431,7 @@
           <p:nvPr/>
         </p:nvPicPr>
         <p:blipFill>
-          <a:blip xmlns:r="http://schemas.openxmlformats.org/officeDocument/2006/relationships" xmlns:a="http://schemas.openxmlformats.org/drawingml/2006/main" r:embed="R1dbf12a8639349fd"/>
+          <a:blip xmlns:r="http://schemas.openxmlformats.org/officeDocument/2006/relationships" xmlns:a="http://schemas.openxmlformats.org/drawingml/2006/main" r:embed="R4d95481098864f29"/>
           <a:stretch xmlns:a="http://schemas.openxmlformats.org/drawingml/2006/main"/>
         </p:blipFill>
         <p:spPr>
@@ -14449,7 +14453,7 @@
           <p:nvPr/>
         </p:nvPicPr>
         <p:blipFill>
-          <a:blip xmlns:r="http://schemas.openxmlformats.org/officeDocument/2006/relationships" xmlns:a="http://schemas.openxmlformats.org/drawingml/2006/main" r:embed="Rd02dbb0ab5724c40"/>
+          <a:blip xmlns:r="http://schemas.openxmlformats.org/officeDocument/2006/relationships" xmlns:a="http://schemas.openxmlformats.org/drawingml/2006/main" r:embed="R7b55d202c019425d"/>
           <a:stretch xmlns:a="http://schemas.openxmlformats.org/drawingml/2006/main"/>
         </p:blipFill>
         <p:spPr>
@@ -14893,7 +14897,7 @@
           <p:nvPr/>
         </p:nvPicPr>
         <p:blipFill>
-          <a:blip xmlns:r="http://schemas.openxmlformats.org/officeDocument/2006/relationships" xmlns:a="http://schemas.openxmlformats.org/drawingml/2006/main" r:embed="R79309960691d479a"/>
+          <a:blip xmlns:r="http://schemas.openxmlformats.org/officeDocument/2006/relationships" xmlns:a="http://schemas.openxmlformats.org/drawingml/2006/main" r:embed="R26c62129d2644e23"/>
           <a:stretch xmlns:a="http://schemas.openxmlformats.org/drawingml/2006/main"/>
         </p:blipFill>
         <p:spPr>
@@ -14915,7 +14919,7 @@
           <p:nvPr/>
         </p:nvPicPr>
         <p:blipFill>
-          <a:blip xmlns:r="http://schemas.openxmlformats.org/officeDocument/2006/relationships" xmlns:a="http://schemas.openxmlformats.org/drawingml/2006/main" r:embed="R0980b9293adc4128"/>
+          <a:blip xmlns:r="http://schemas.openxmlformats.org/officeDocument/2006/relationships" xmlns:a="http://schemas.openxmlformats.org/drawingml/2006/main" r:embed="Rb1ec88c31eea41f6"/>
           <a:srcRect xmlns:a="http://schemas.openxmlformats.org/drawingml/2006/main" l="0" t="21741" r="0" b="21741"/>
           <a:stretch xmlns:a="http://schemas.openxmlformats.org/drawingml/2006/main">
             <a:fillRect l="0" t="0" r="0" b="0"/>
@@ -15214,7 +15218,7 @@
           <p:nvPr/>
         </p:nvPicPr>
         <p:blipFill>
-          <a:blip xmlns:r="http://schemas.openxmlformats.org/officeDocument/2006/relationships" xmlns:a="http://schemas.openxmlformats.org/drawingml/2006/main" r:embed="R63d48ce6c97a4fde"/>
+          <a:blip xmlns:r="http://schemas.openxmlformats.org/officeDocument/2006/relationships" xmlns:a="http://schemas.openxmlformats.org/drawingml/2006/main" r:embed="R9b21d00f4e694956"/>
           <a:stretch xmlns:a="http://schemas.openxmlformats.org/drawingml/2006/main"/>
         </p:blipFill>
         <p:spPr>
@@ -15631,7 +15635,7 @@
           <p:nvPr/>
         </p:nvPicPr>
         <p:blipFill>
-          <a:blip xmlns:r="http://schemas.openxmlformats.org/officeDocument/2006/relationships" xmlns:a="http://schemas.openxmlformats.org/drawingml/2006/main" r:embed="R625b11aac7374608"/>
+          <a:blip xmlns:r="http://schemas.openxmlformats.org/officeDocument/2006/relationships" xmlns:a="http://schemas.openxmlformats.org/drawingml/2006/main" r:embed="R032bc2a3b73948ef"/>
           <a:srcRect xmlns:a="http://schemas.openxmlformats.org/drawingml/2006/main" l="0" t="7532" r="0" b="7532"/>
           <a:stretch xmlns:a="http://schemas.openxmlformats.org/drawingml/2006/main">
             <a:fillRect l="0" t="0" r="0" b="0"/>
@@ -15991,7 +15995,7 @@
           <p:nvPr/>
         </p:nvPicPr>
         <p:blipFill>
-          <a:blip xmlns:r="http://schemas.openxmlformats.org/officeDocument/2006/relationships" xmlns:a="http://schemas.openxmlformats.org/drawingml/2006/main" r:embed="R649afde289df4ddc"/>
+          <a:blip xmlns:r="http://schemas.openxmlformats.org/officeDocument/2006/relationships" xmlns:a="http://schemas.openxmlformats.org/drawingml/2006/main" r:embed="R86d01d910f5c4a14"/>
           <a:stretch xmlns:a="http://schemas.openxmlformats.org/drawingml/2006/main"/>
         </p:blipFill>
         <p:spPr>
@@ -16408,7 +16412,7 @@
           <p:nvPr/>
         </p:nvPicPr>
         <p:blipFill>
-          <a:blip xmlns:r="http://schemas.openxmlformats.org/officeDocument/2006/relationships" xmlns:a="http://schemas.openxmlformats.org/drawingml/2006/main" r:embed="Ra718cb101e9943dc"/>
+          <a:blip xmlns:r="http://schemas.openxmlformats.org/officeDocument/2006/relationships" xmlns:a="http://schemas.openxmlformats.org/drawingml/2006/main" r:embed="R2452421f80bf4328"/>
           <a:srcRect xmlns:a="http://schemas.openxmlformats.org/drawingml/2006/main" l="4136" t="0" r="4136" b="0"/>
           <a:stretch xmlns:a="http://schemas.openxmlformats.org/drawingml/2006/main">
             <a:fillRect l="0" t="0" r="0" b="0"/>
@@ -16707,7 +16711,7 @@
           <p:nvPr/>
         </p:nvPicPr>
         <p:blipFill>
-          <a:blip xmlns:r="http://schemas.openxmlformats.org/officeDocument/2006/relationships" xmlns:a="http://schemas.openxmlformats.org/drawingml/2006/main" r:embed="Rf351460c0a564e73"/>
+          <a:blip xmlns:r="http://schemas.openxmlformats.org/officeDocument/2006/relationships" xmlns:a="http://schemas.openxmlformats.org/drawingml/2006/main" r:embed="Rea1059d26e9f4ecc"/>
           <a:stretch xmlns:a="http://schemas.openxmlformats.org/drawingml/2006/main"/>
         </p:blipFill>
         <p:spPr>
@@ -17368,7 +17372,7 @@
           <p:nvPr/>
         </p:nvPicPr>
         <p:blipFill>
-          <a:blip xmlns:r="http://schemas.openxmlformats.org/officeDocument/2006/relationships" xmlns:a="http://schemas.openxmlformats.org/drawingml/2006/main" r:embed="Rf8e600daf3274b62"/>
+          <a:blip xmlns:r="http://schemas.openxmlformats.org/officeDocument/2006/relationships" xmlns:a="http://schemas.openxmlformats.org/drawingml/2006/main" r:embed="Rd8c4762881ee458e"/>
           <a:srcRect xmlns:a="http://schemas.openxmlformats.org/drawingml/2006/main" l="0" t="0" r="0" b="0"/>
           <a:stretch xmlns:a="http://schemas.openxmlformats.org/drawingml/2006/main"/>
         </p:blipFill>
@@ -17726,7 +17730,7 @@
           <p:nvPr/>
         </p:nvPicPr>
         <p:blipFill>
-          <a:blip xmlns:r="http://schemas.openxmlformats.org/officeDocument/2006/relationships" xmlns:a="http://schemas.openxmlformats.org/drawingml/2006/main" r:embed="Rd97468d7c6884a1e"/>
+          <a:blip xmlns:r="http://schemas.openxmlformats.org/officeDocument/2006/relationships" xmlns:a="http://schemas.openxmlformats.org/drawingml/2006/main" r:embed="Rb6aef2ea135b4fd0"/>
           <a:stretch xmlns:a="http://schemas.openxmlformats.org/drawingml/2006/main"/>
         </p:blipFill>
         <p:spPr>
@@ -17987,7 +17991,7 @@
           <p:nvPr/>
         </p:nvPicPr>
         <p:blipFill>
-          <a:blip xmlns:r="http://schemas.openxmlformats.org/officeDocument/2006/relationships" xmlns:a="http://schemas.openxmlformats.org/drawingml/2006/main" r:embed="Rea8908c9f29440cd"/>
+          <a:blip xmlns:r="http://schemas.openxmlformats.org/officeDocument/2006/relationships" xmlns:a="http://schemas.openxmlformats.org/drawingml/2006/main" r:embed="R328de2adb8ba4d4e"/>
           <a:srcRect xmlns:a="http://schemas.openxmlformats.org/drawingml/2006/main" l="0" t="15816" r="0" b="15816"/>
           <a:stretch xmlns:a="http://schemas.openxmlformats.org/drawingml/2006/main">
             <a:fillRect l="0" t="0" r="0" b="0"/>
@@ -18652,7 +18656,7 @@
           <p:nvPr/>
         </p:nvPicPr>
         <p:blipFill>
-          <a:blip xmlns:r="http://schemas.openxmlformats.org/officeDocument/2006/relationships" xmlns:a="http://schemas.openxmlformats.org/drawingml/2006/main" r:embed="Rcd4556399fbe4999"/>
+          <a:blip xmlns:r="http://schemas.openxmlformats.org/officeDocument/2006/relationships" xmlns:a="http://schemas.openxmlformats.org/drawingml/2006/main" r:embed="Rca3dd967b837468c"/>
           <a:stretch xmlns:a="http://schemas.openxmlformats.org/drawingml/2006/main"/>
         </p:blipFill>
         <p:spPr>

</xml_diff>

<commit_message>
Refine whitespace in the UNESCO Airier deck and synchronized downloads
</commit_message>
<xml_diff>
--- a/teacher-agent-creators-10min/downloads/UNESCO_Teacher_AI_Agents_EN_Airier.pptx
+++ b/teacher-agent-creators-10min/downloads/UNESCO_Teacher_AI_Agents_EN_Airier.pptx
@@ -2,29 +2,29 @@
 <file path=ppt/presentation.xml><?xml version="1.0" encoding="utf-8"?>
 <p:presentation xmlns:p="http://schemas.openxmlformats.org/presentationml/2006/main">
   <p:sldMasterIdLst>
-    <p:sldMasterId xmlns:r="http://schemas.openxmlformats.org/officeDocument/2006/relationships" id="2147483648" r:id="Rf27fb3b960af4785"/>
+    <p:sldMasterId xmlns:r="http://schemas.openxmlformats.org/officeDocument/2006/relationships" id="2147483648" r:id="R31c47143c90c4b27"/>
   </p:sldMasterIdLst>
   <p:notesMasterIdLst>
-    <p:notesMasterId xmlns:r="http://schemas.openxmlformats.org/officeDocument/2006/relationships" r:id="Rfb982303b5464c88"/>
+    <p:notesMasterId xmlns:r="http://schemas.openxmlformats.org/officeDocument/2006/relationships" r:id="Rbbaf16a0fb314c06"/>
   </p:notesMasterIdLst>
   <p:sldIdLst>
-    <p:sldId xmlns:r="http://schemas.openxmlformats.org/officeDocument/2006/relationships" id="256" r:id="R982c1a016c7d49d4"/>
-    <p:sldId xmlns:r="http://schemas.openxmlformats.org/officeDocument/2006/relationships" id="257" r:id="R1a3d370f929f4d01"/>
-    <p:sldId xmlns:r="http://schemas.openxmlformats.org/officeDocument/2006/relationships" id="258" r:id="R54564f3563f94adc"/>
-    <p:sldId xmlns:r="http://schemas.openxmlformats.org/officeDocument/2006/relationships" id="259" r:id="Rae185e5574ed4660"/>
-    <p:sldId xmlns:r="http://schemas.openxmlformats.org/officeDocument/2006/relationships" id="260" r:id="Rffeb972d1df34995"/>
-    <p:sldId xmlns:r="http://schemas.openxmlformats.org/officeDocument/2006/relationships" id="261" r:id="Raeafafb920c34599"/>
-    <p:sldId xmlns:r="http://schemas.openxmlformats.org/officeDocument/2006/relationships" id="262" r:id="Ra053bb202be0418f"/>
-    <p:sldId xmlns:r="http://schemas.openxmlformats.org/officeDocument/2006/relationships" id="263" r:id="Redb5ce3c88d04b16"/>
-    <p:sldId xmlns:r="http://schemas.openxmlformats.org/officeDocument/2006/relationships" id="264" r:id="R8c14815f30e64b72"/>
-    <p:sldId xmlns:r="http://schemas.openxmlformats.org/officeDocument/2006/relationships" id="265" r:id="R22fcb20b5e6e48d8"/>
-    <p:sldId xmlns:r="http://schemas.openxmlformats.org/officeDocument/2006/relationships" id="266" r:id="R60b3c49517194e64"/>
-    <p:sldId xmlns:r="http://schemas.openxmlformats.org/officeDocument/2006/relationships" id="267" r:id="Rb438a17b2ed146f5"/>
-    <p:sldId xmlns:r="http://schemas.openxmlformats.org/officeDocument/2006/relationships" id="268" r:id="Ref74f5207a42486a"/>
-    <p:sldId xmlns:r="http://schemas.openxmlformats.org/officeDocument/2006/relationships" id="269" r:id="Rc73ca1155e204b73"/>
-    <p:sldId xmlns:r="http://schemas.openxmlformats.org/officeDocument/2006/relationships" id="270" r:id="Rbc80d17d201a4b44"/>
-    <p:sldId xmlns:r="http://schemas.openxmlformats.org/officeDocument/2006/relationships" id="271" r:id="R1e4cdfe1af604127"/>
-    <p:sldId xmlns:r="http://schemas.openxmlformats.org/officeDocument/2006/relationships" id="272" r:id="R4d7116132b9c4317"/>
+    <p:sldId xmlns:r="http://schemas.openxmlformats.org/officeDocument/2006/relationships" id="256" r:id="Re65d7835aa454fb0"/>
+    <p:sldId xmlns:r="http://schemas.openxmlformats.org/officeDocument/2006/relationships" id="257" r:id="R78c9ca22cd9746bf"/>
+    <p:sldId xmlns:r="http://schemas.openxmlformats.org/officeDocument/2006/relationships" id="258" r:id="R6f2be0dc71d84f95"/>
+    <p:sldId xmlns:r="http://schemas.openxmlformats.org/officeDocument/2006/relationships" id="259" r:id="R7725075250fe4baf"/>
+    <p:sldId xmlns:r="http://schemas.openxmlformats.org/officeDocument/2006/relationships" id="260" r:id="R60c4b5d8d8ab4f7b"/>
+    <p:sldId xmlns:r="http://schemas.openxmlformats.org/officeDocument/2006/relationships" id="261" r:id="R2f8286dfebe24efe"/>
+    <p:sldId xmlns:r="http://schemas.openxmlformats.org/officeDocument/2006/relationships" id="262" r:id="R5488d1aecf81460c"/>
+    <p:sldId xmlns:r="http://schemas.openxmlformats.org/officeDocument/2006/relationships" id="263" r:id="Re8d587e880a24ef6"/>
+    <p:sldId xmlns:r="http://schemas.openxmlformats.org/officeDocument/2006/relationships" id="264" r:id="R3f0890464dae42ba"/>
+    <p:sldId xmlns:r="http://schemas.openxmlformats.org/officeDocument/2006/relationships" id="265" r:id="R78148363c03946f9"/>
+    <p:sldId xmlns:r="http://schemas.openxmlformats.org/officeDocument/2006/relationships" id="266" r:id="Ra9327c95fe734e6c"/>
+    <p:sldId xmlns:r="http://schemas.openxmlformats.org/officeDocument/2006/relationships" id="267" r:id="R86d329673ef04858"/>
+    <p:sldId xmlns:r="http://schemas.openxmlformats.org/officeDocument/2006/relationships" id="268" r:id="R9abeb5dae2514156"/>
+    <p:sldId xmlns:r="http://schemas.openxmlformats.org/officeDocument/2006/relationships" id="269" r:id="Rd7a1c5818d3d4f18"/>
+    <p:sldId xmlns:r="http://schemas.openxmlformats.org/officeDocument/2006/relationships" id="270" r:id="R3f2c64deefd5454f"/>
+    <p:sldId xmlns:r="http://schemas.openxmlformats.org/officeDocument/2006/relationships" id="271" r:id="R0ece0fe4e0f14859"/>
+    <p:sldId xmlns:r="http://schemas.openxmlformats.org/officeDocument/2006/relationships" id="272" r:id="R128f0c6245184181"/>
   </p:sldIdLst>
   <p:sldSz cx="12192000" cy="6858000"/>
   <p:notesSz cx="6858000" cy="9144000"/>
@@ -2416,7 +2416,7 @@
   </p:cSld>
   <p:clrMap bg1="lt1" tx1="dk1" bg2="lt2" tx2="dk2" accent1="accent1" accent2="accent2" accent3="accent3" accent4="accent4" accent5="accent5" accent6="accent6" hlink="hlink" folHlink="folHlink"/>
   <p:sldLayoutIdLst>
-    <p:sldLayoutId xmlns:r="http://schemas.openxmlformats.org/officeDocument/2006/relationships" id="2147483649" r:id="Rf401ceb16b73466e"/>
+    <p:sldLayoutId xmlns:r="http://schemas.openxmlformats.org/officeDocument/2006/relationships" id="2147483649" r:id="R2e40f724ad4a4e84"/>
   </p:sldLayoutIdLst>
   <p:txStyles>
     <p:titleStyle>
@@ -2971,7 +2971,7 @@
           <p:nvPr/>
         </p:nvPicPr>
         <p:blipFill>
-          <a:blip xmlns:r="http://schemas.openxmlformats.org/officeDocument/2006/relationships" xmlns:a="http://schemas.openxmlformats.org/drawingml/2006/main" r:embed="R61620a921dd840fb"/>
+          <a:blip xmlns:r="http://schemas.openxmlformats.org/officeDocument/2006/relationships" xmlns:a="http://schemas.openxmlformats.org/drawingml/2006/main" r:embed="R829f88f4753a4e86"/>
           <a:srcRect xmlns:a="http://schemas.openxmlformats.org/drawingml/2006/main" l="0" t="0" r="0" b="0"/>
           <a:stretch xmlns:a="http://schemas.openxmlformats.org/drawingml/2006/main">
             <a:fillRect l="0" t="0" r="0" b="0"/>
@@ -2996,7 +2996,7 @@
           <p:nvPr/>
         </p:nvPicPr>
         <p:blipFill>
-          <a:blip xmlns:r="http://schemas.openxmlformats.org/officeDocument/2006/relationships" xmlns:a="http://schemas.openxmlformats.org/drawingml/2006/main" r:embed="R3198dcabab554cca"/>
+          <a:blip xmlns:r="http://schemas.openxmlformats.org/officeDocument/2006/relationships" xmlns:a="http://schemas.openxmlformats.org/drawingml/2006/main" r:embed="R6ffeeb1306a34988"/>
           <a:stretch xmlns:a="http://schemas.openxmlformats.org/drawingml/2006/main"/>
         </p:blipFill>
         <p:spPr>
@@ -3659,8 +3659,8 @@
         </p:nvSpPr>
         <p:spPr>
           <a:xfrm xmlns:a="http://schemas.openxmlformats.org/drawingml/2006/main">
-            <a:off x="533400" y="409575"/>
-            <a:ext cx="9334500" cy="238125"/>
+            <a:off x="723900" y="447675"/>
+            <a:ext cx="9014841" cy="238125"/>
           </a:xfrm>
           <a:prstGeom xmlns:a="http://schemas.openxmlformats.org/drawingml/2006/main" prst="rect">
             <a:avLst/>
@@ -3720,8 +3720,8 @@
         </p:nvSpPr>
         <p:spPr>
           <a:xfrm xmlns:a="http://schemas.openxmlformats.org/drawingml/2006/main">
-            <a:off x="533400" y="828675"/>
-            <a:ext cx="9525000" cy="1047750"/>
+            <a:off x="723900" y="904875"/>
+            <a:ext cx="9198769" cy="1047750"/>
           </a:xfrm>
           <a:prstGeom xmlns:a="http://schemas.openxmlformats.org/drawingml/2006/main" prst="rect">
             <a:avLst/>
@@ -3808,8 +3808,8 @@
         </p:nvSpPr>
         <p:spPr>
           <a:xfrm xmlns:a="http://schemas.openxmlformats.org/drawingml/2006/main">
-            <a:off x="533400" y="2019300"/>
-            <a:ext cx="11125200" cy="409575"/>
+            <a:off x="723900" y="2114550"/>
+            <a:ext cx="10744200" cy="409575"/>
           </a:xfrm>
           <a:prstGeom xmlns:a="http://schemas.openxmlformats.org/drawingml/2006/main" prst="rect">
             <a:avLst/>
@@ -3869,8 +3869,8 @@
         </p:nvSpPr>
         <p:spPr>
           <a:xfrm xmlns:a="http://schemas.openxmlformats.org/drawingml/2006/main">
-            <a:off x="533400" y="3086100"/>
-            <a:ext cx="10925175" cy="19050"/>
+            <a:off x="723900" y="3162300"/>
+            <a:ext cx="10551033" cy="19050"/>
           </a:xfrm>
           <a:prstGeom xmlns:a="http://schemas.openxmlformats.org/drawingml/2006/main" prst="rect">
             <a:avLst/>
@@ -3899,8 +3899,8 @@
         </p:nvSpPr>
         <p:spPr>
           <a:xfrm xmlns:a="http://schemas.openxmlformats.org/drawingml/2006/main">
-            <a:off x="533400" y="2638425"/>
-            <a:ext cx="3390900" cy="400050"/>
+            <a:off x="723900" y="2714625"/>
+            <a:ext cx="3274790" cy="400050"/>
           </a:xfrm>
           <a:prstGeom xmlns:a="http://schemas.openxmlformats.org/drawingml/2006/main" prst="rect">
             <a:avLst/>
@@ -3960,8 +3960,8 @@
         </p:nvSpPr>
         <p:spPr>
           <a:xfrm xmlns:a="http://schemas.openxmlformats.org/drawingml/2006/main">
-            <a:off x="533400" y="3038475"/>
-            <a:ext cx="114300" cy="114300"/>
+            <a:off x="723900" y="3114675"/>
+            <a:ext cx="110395" cy="114300"/>
           </a:xfrm>
           <a:prstGeom xmlns:a="http://schemas.openxmlformats.org/drawingml/2006/main" prst="rect">
             <a:avLst/>
@@ -3990,8 +3990,8 @@
         </p:nvSpPr>
         <p:spPr>
           <a:xfrm xmlns:a="http://schemas.openxmlformats.org/drawingml/2006/main">
-            <a:off x="533400" y="3305175"/>
-            <a:ext cx="3362325" cy="809625"/>
+            <a:off x="723900" y="3381375"/>
+            <a:ext cx="3247168" cy="809625"/>
           </a:xfrm>
           <a:prstGeom xmlns:a="http://schemas.openxmlformats.org/drawingml/2006/main" prst="rect">
             <a:avLst/>
@@ -4051,8 +4051,8 @@
         </p:nvSpPr>
         <p:spPr>
           <a:xfrm xmlns:a="http://schemas.openxmlformats.org/drawingml/2006/main">
-            <a:off x="4343400" y="2638425"/>
-            <a:ext cx="3390900" cy="400050"/>
+            <a:off x="4403408" y="2714625"/>
+            <a:ext cx="3274790" cy="400050"/>
           </a:xfrm>
           <a:prstGeom xmlns:a="http://schemas.openxmlformats.org/drawingml/2006/main" prst="rect">
             <a:avLst/>
@@ -4112,8 +4112,8 @@
         </p:nvSpPr>
         <p:spPr>
           <a:xfrm xmlns:a="http://schemas.openxmlformats.org/drawingml/2006/main">
-            <a:off x="4343400" y="3038475"/>
-            <a:ext cx="114300" cy="114300"/>
+            <a:off x="4403408" y="3114675"/>
+            <a:ext cx="110395" cy="114300"/>
           </a:xfrm>
           <a:prstGeom xmlns:a="http://schemas.openxmlformats.org/drawingml/2006/main" prst="rect">
             <a:avLst/>
@@ -4142,8 +4142,8 @@
         </p:nvSpPr>
         <p:spPr>
           <a:xfrm xmlns:a="http://schemas.openxmlformats.org/drawingml/2006/main">
-            <a:off x="4343400" y="3305175"/>
-            <a:ext cx="3362325" cy="809625"/>
+            <a:off x="4403408" y="3381375"/>
+            <a:ext cx="3247168" cy="809625"/>
           </a:xfrm>
           <a:prstGeom xmlns:a="http://schemas.openxmlformats.org/drawingml/2006/main" prst="rect">
             <a:avLst/>
@@ -4203,8 +4203,8 @@
         </p:nvSpPr>
         <p:spPr>
           <a:xfrm xmlns:a="http://schemas.openxmlformats.org/drawingml/2006/main">
-            <a:off x="8153400" y="2638425"/>
-            <a:ext cx="3390900" cy="400050"/>
+            <a:off x="8082915" y="2714625"/>
+            <a:ext cx="3274790" cy="400050"/>
           </a:xfrm>
           <a:prstGeom xmlns:a="http://schemas.openxmlformats.org/drawingml/2006/main" prst="rect">
             <a:avLst/>
@@ -4264,8 +4264,8 @@
         </p:nvSpPr>
         <p:spPr>
           <a:xfrm xmlns:a="http://schemas.openxmlformats.org/drawingml/2006/main">
-            <a:off x="8153400" y="3038475"/>
-            <a:ext cx="114300" cy="114300"/>
+            <a:off x="8082915" y="3114675"/>
+            <a:ext cx="110395" cy="114300"/>
           </a:xfrm>
           <a:prstGeom xmlns:a="http://schemas.openxmlformats.org/drawingml/2006/main" prst="rect">
             <a:avLst/>
@@ -4294,8 +4294,8 @@
         </p:nvSpPr>
         <p:spPr>
           <a:xfrm xmlns:a="http://schemas.openxmlformats.org/drawingml/2006/main">
-            <a:off x="8153400" y="3305175"/>
-            <a:ext cx="3362325" cy="809625"/>
+            <a:off x="8082915" y="3381375"/>
+            <a:ext cx="3247168" cy="809625"/>
           </a:xfrm>
           <a:prstGeom xmlns:a="http://schemas.openxmlformats.org/drawingml/2006/main" prst="rect">
             <a:avLst/>
@@ -4355,8 +4355,8 @@
         </p:nvSpPr>
         <p:spPr>
           <a:xfrm xmlns:a="http://schemas.openxmlformats.org/drawingml/2006/main">
-            <a:off x="533400" y="4191000"/>
-            <a:ext cx="11125200" cy="619125"/>
+            <a:off x="723900" y="4276725"/>
+            <a:ext cx="10744200" cy="619125"/>
           </a:xfrm>
           <a:prstGeom xmlns:a="http://schemas.openxmlformats.org/drawingml/2006/main" prst="rect">
             <a:avLst/>
@@ -4416,8 +4416,8 @@
         </p:nvSpPr>
         <p:spPr>
           <a:xfrm xmlns:a="http://schemas.openxmlformats.org/drawingml/2006/main">
-            <a:off x="533400" y="4962525"/>
-            <a:ext cx="6257925" cy="419100"/>
+            <a:off x="723900" y="4914900"/>
+            <a:ext cx="6043613" cy="419100"/>
           </a:xfrm>
           <a:prstGeom xmlns:a="http://schemas.openxmlformats.org/drawingml/2006/main" prst="rect">
             <a:avLst/>
@@ -4477,8 +4477,8 @@
         </p:nvSpPr>
         <p:spPr>
           <a:xfrm xmlns:a="http://schemas.openxmlformats.org/drawingml/2006/main">
-            <a:off x="533400" y="5410200"/>
-            <a:ext cx="6257925" cy="409575"/>
+            <a:off x="723900" y="5362575"/>
+            <a:ext cx="6043613" cy="409575"/>
           </a:xfrm>
           <a:prstGeom xmlns:a="http://schemas.openxmlformats.org/drawingml/2006/main" prst="rect">
             <a:avLst/>
@@ -4538,8 +4538,8 @@
         </p:nvSpPr>
         <p:spPr>
           <a:xfrm xmlns:a="http://schemas.openxmlformats.org/drawingml/2006/main">
-            <a:off x="7115175" y="4962525"/>
-            <a:ext cx="4543425" cy="419100"/>
+            <a:off x="7080314" y="4914900"/>
+            <a:ext cx="4387787" cy="419100"/>
           </a:xfrm>
           <a:prstGeom xmlns:a="http://schemas.openxmlformats.org/drawingml/2006/main" prst="rect">
             <a:avLst/>
@@ -4599,8 +4599,8 @@
         </p:nvSpPr>
         <p:spPr>
           <a:xfrm xmlns:a="http://schemas.openxmlformats.org/drawingml/2006/main">
-            <a:off x="7115175" y="5410200"/>
-            <a:ext cx="4543425" cy="409575"/>
+            <a:off x="7080314" y="5362575"/>
+            <a:ext cx="4387787" cy="409575"/>
           </a:xfrm>
           <a:prstGeom xmlns:a="http://schemas.openxmlformats.org/drawingml/2006/main" prst="rect">
             <a:avLst/>
@@ -4660,8 +4660,8 @@
         </p:nvSpPr>
         <p:spPr>
           <a:xfrm xmlns:a="http://schemas.openxmlformats.org/drawingml/2006/main">
-            <a:off x="533400" y="6105525"/>
-            <a:ext cx="38100" cy="304800"/>
+            <a:off x="723900" y="6105525"/>
+            <a:ext cx="36767" cy="304800"/>
           </a:xfrm>
           <a:prstGeom xmlns:a="http://schemas.openxmlformats.org/drawingml/2006/main" prst="rect">
             <a:avLst/>
@@ -4690,8 +4690,8 @@
         </p:nvSpPr>
         <p:spPr>
           <a:xfrm xmlns:a="http://schemas.openxmlformats.org/drawingml/2006/main">
-            <a:off x="733425" y="6076950"/>
-            <a:ext cx="10858500" cy="428625"/>
+            <a:off x="917067" y="6076950"/>
+            <a:ext cx="10486644" cy="428625"/>
           </a:xfrm>
           <a:prstGeom xmlns:a="http://schemas.openxmlformats.org/drawingml/2006/main" prst="rect">
             <a:avLst/>
@@ -4751,8 +4751,8 @@
         </p:nvSpPr>
         <p:spPr>
           <a:xfrm xmlns:a="http://schemas.openxmlformats.org/drawingml/2006/main">
-            <a:off x="533400" y="6562725"/>
-            <a:ext cx="9429750" cy="190500"/>
+            <a:off x="723900" y="6562725"/>
+            <a:ext cx="9106853" cy="190500"/>
           </a:xfrm>
           <a:prstGeom xmlns:a="http://schemas.openxmlformats.org/drawingml/2006/main" prst="rect">
             <a:avLst/>
@@ -4812,8 +4812,8 @@
         </p:nvSpPr>
         <p:spPr>
           <a:xfrm xmlns:a="http://schemas.openxmlformats.org/drawingml/2006/main">
-            <a:off x="10706100" y="6562725"/>
-            <a:ext cx="952500" cy="190500"/>
+            <a:off x="10548176" y="6562725"/>
+            <a:ext cx="919925" cy="190500"/>
           </a:xfrm>
           <a:prstGeom xmlns:a="http://schemas.openxmlformats.org/drawingml/2006/main" prst="rect">
             <a:avLst/>
@@ -4866,12 +4866,12 @@
           <p:nvPr/>
         </p:nvPicPr>
         <p:blipFill>
-          <a:blip xmlns:r="http://schemas.openxmlformats.org/officeDocument/2006/relationships" xmlns:a="http://schemas.openxmlformats.org/drawingml/2006/main" r:embed="R085610fc62f740db"/>
+          <a:blip xmlns:r="http://schemas.openxmlformats.org/officeDocument/2006/relationships" xmlns:a="http://schemas.openxmlformats.org/drawingml/2006/main" r:embed="Rd5943ee789ac456a"/>
           <a:stretch xmlns:a="http://schemas.openxmlformats.org/drawingml/2006/main"/>
         </p:blipFill>
         <p:spPr>
           <a:xfrm xmlns:a="http://schemas.openxmlformats.org/drawingml/2006/main">
-            <a:off x="10248900" y="361950"/>
+            <a:off x="10058400" y="400050"/>
             <a:ext cx="1409700" cy="323850"/>
           </a:xfrm>
           <a:prstGeom xmlns:a="http://schemas.openxmlformats.org/drawingml/2006/main" prst="rect">
@@ -4924,8 +4924,8 @@
         </p:nvSpPr>
         <p:spPr>
           <a:xfrm xmlns:a="http://schemas.openxmlformats.org/drawingml/2006/main">
-            <a:off x="533400" y="409575"/>
-            <a:ext cx="9334500" cy="238125"/>
+            <a:off x="723900" y="447675"/>
+            <a:ext cx="9014841" cy="238125"/>
           </a:xfrm>
           <a:prstGeom xmlns:a="http://schemas.openxmlformats.org/drawingml/2006/main" prst="rect">
             <a:avLst/>
@@ -4985,8 +4985,8 @@
         </p:nvSpPr>
         <p:spPr>
           <a:xfrm xmlns:a="http://schemas.openxmlformats.org/drawingml/2006/main">
-            <a:off x="533400" y="828675"/>
-            <a:ext cx="10668000" cy="1047750"/>
+            <a:off x="723900" y="904875"/>
+            <a:ext cx="10302621" cy="1047750"/>
           </a:xfrm>
           <a:prstGeom xmlns:a="http://schemas.openxmlformats.org/drawingml/2006/main" prst="rect">
             <a:avLst/>
@@ -5073,8 +5073,8 @@
         </p:nvSpPr>
         <p:spPr>
           <a:xfrm xmlns:a="http://schemas.openxmlformats.org/drawingml/2006/main">
-            <a:off x="533400" y="2028825"/>
-            <a:ext cx="11125200" cy="657225"/>
+            <a:off x="723900" y="2124075"/>
+            <a:ext cx="10744200" cy="657225"/>
           </a:xfrm>
           <a:prstGeom xmlns:a="http://schemas.openxmlformats.org/drawingml/2006/main" prst="rect">
             <a:avLst/>
@@ -5134,8 +5134,8 @@
         </p:nvSpPr>
         <p:spPr>
           <a:xfrm xmlns:a="http://schemas.openxmlformats.org/drawingml/2006/main">
-            <a:off x="533400" y="3038475"/>
-            <a:ext cx="4981575" cy="428625"/>
+            <a:off x="723900" y="3038475"/>
+            <a:ext cx="4810982" cy="428625"/>
           </a:xfrm>
           <a:prstGeom xmlns:a="http://schemas.openxmlformats.org/drawingml/2006/main" prst="rect">
             <a:avLst/>
@@ -5195,8 +5195,8 @@
         </p:nvSpPr>
         <p:spPr>
           <a:xfrm xmlns:a="http://schemas.openxmlformats.org/drawingml/2006/main">
-            <a:off x="533400" y="3467100"/>
-            <a:ext cx="4981575" cy="866775"/>
+            <a:off x="723900" y="3467100"/>
+            <a:ext cx="4810982" cy="866775"/>
           </a:xfrm>
           <a:prstGeom xmlns:a="http://schemas.openxmlformats.org/drawingml/2006/main" prst="rect">
             <a:avLst/>
@@ -5256,8 +5256,8 @@
         </p:nvSpPr>
         <p:spPr>
           <a:xfrm xmlns:a="http://schemas.openxmlformats.org/drawingml/2006/main">
-            <a:off x="533400" y="4572000"/>
-            <a:ext cx="4981575" cy="419100"/>
+            <a:off x="723900" y="4524375"/>
+            <a:ext cx="4810982" cy="419100"/>
           </a:xfrm>
           <a:prstGeom xmlns:a="http://schemas.openxmlformats.org/drawingml/2006/main" prst="rect">
             <a:avLst/>
@@ -5317,8 +5317,8 @@
         </p:nvSpPr>
         <p:spPr>
           <a:xfrm xmlns:a="http://schemas.openxmlformats.org/drawingml/2006/main">
-            <a:off x="533400" y="4991100"/>
-            <a:ext cx="4981575" cy="790575"/>
+            <a:off x="723900" y="4943475"/>
+            <a:ext cx="4810982" cy="790575"/>
           </a:xfrm>
           <a:prstGeom xmlns:a="http://schemas.openxmlformats.org/drawingml/2006/main" prst="rect">
             <a:avLst/>
@@ -5371,13 +5371,13 @@
           <p:nvPr/>
         </p:nvPicPr>
         <p:blipFill>
-          <a:blip xmlns:r="http://schemas.openxmlformats.org/officeDocument/2006/relationships" xmlns:a="http://schemas.openxmlformats.org/drawingml/2006/main" r:embed="Rd8522e16d11f4a6a"/>
+          <a:blip xmlns:r="http://schemas.openxmlformats.org/officeDocument/2006/relationships" xmlns:a="http://schemas.openxmlformats.org/drawingml/2006/main" r:embed="R9e976775dd1941ec"/>
           <a:stretch xmlns:a="http://schemas.openxmlformats.org/drawingml/2006/main"/>
         </p:blipFill>
         <p:spPr>
           <a:xfrm xmlns:a="http://schemas.openxmlformats.org/drawingml/2006/main">
-            <a:off x="6029325" y="2838450"/>
-            <a:ext cx="5629275" cy="2693017"/>
+            <a:off x="6031611" y="2952750"/>
+            <a:ext cx="5291519" cy="2531459"/>
           </a:xfrm>
           <a:prstGeom xmlns:a="http://schemas.openxmlformats.org/drawingml/2006/main" prst="rect">
             <a:avLst/>
@@ -5400,8 +5400,8 @@
         </p:nvSpPr>
         <p:spPr>
           <a:xfrm xmlns:a="http://schemas.openxmlformats.org/drawingml/2006/main">
-            <a:off x="6029325" y="5657850"/>
-            <a:ext cx="5629275" cy="285750"/>
+            <a:off x="6031611" y="5598509"/>
+            <a:ext cx="5436489" cy="285750"/>
           </a:xfrm>
           <a:prstGeom xmlns:a="http://schemas.openxmlformats.org/drawingml/2006/main" prst="rect">
             <a:avLst/>
@@ -5461,8 +5461,8 @@
         </p:nvSpPr>
         <p:spPr>
           <a:xfrm xmlns:a="http://schemas.openxmlformats.org/drawingml/2006/main">
-            <a:off x="533400" y="6105525"/>
-            <a:ext cx="38100" cy="304800"/>
+            <a:off x="723900" y="6105525"/>
+            <a:ext cx="36767" cy="304800"/>
           </a:xfrm>
           <a:prstGeom xmlns:a="http://schemas.openxmlformats.org/drawingml/2006/main" prst="rect">
             <a:avLst/>
@@ -5491,8 +5491,8 @@
         </p:nvSpPr>
         <p:spPr>
           <a:xfrm xmlns:a="http://schemas.openxmlformats.org/drawingml/2006/main">
-            <a:off x="733425" y="6076950"/>
-            <a:ext cx="10858500" cy="428625"/>
+            <a:off x="917067" y="6076950"/>
+            <a:ext cx="10486644" cy="428625"/>
           </a:xfrm>
           <a:prstGeom xmlns:a="http://schemas.openxmlformats.org/drawingml/2006/main" prst="rect">
             <a:avLst/>
@@ -5552,8 +5552,8 @@
         </p:nvSpPr>
         <p:spPr>
           <a:xfrm xmlns:a="http://schemas.openxmlformats.org/drawingml/2006/main">
-            <a:off x="533400" y="6562725"/>
-            <a:ext cx="9429750" cy="190500"/>
+            <a:off x="723900" y="6562725"/>
+            <a:ext cx="9106853" cy="190500"/>
           </a:xfrm>
           <a:prstGeom xmlns:a="http://schemas.openxmlformats.org/drawingml/2006/main" prst="rect">
             <a:avLst/>
@@ -5613,8 +5613,8 @@
         </p:nvSpPr>
         <p:spPr>
           <a:xfrm xmlns:a="http://schemas.openxmlformats.org/drawingml/2006/main">
-            <a:off x="10706100" y="6562725"/>
-            <a:ext cx="952500" cy="190500"/>
+            <a:off x="10548176" y="6562725"/>
+            <a:ext cx="919925" cy="190500"/>
           </a:xfrm>
           <a:prstGeom xmlns:a="http://schemas.openxmlformats.org/drawingml/2006/main" prst="rect">
             <a:avLst/>
@@ -5667,12 +5667,12 @@
           <p:nvPr/>
         </p:nvPicPr>
         <p:blipFill>
-          <a:blip xmlns:r="http://schemas.openxmlformats.org/officeDocument/2006/relationships" xmlns:a="http://schemas.openxmlformats.org/drawingml/2006/main" r:embed="R8bd7452a8b4a4868"/>
+          <a:blip xmlns:r="http://schemas.openxmlformats.org/officeDocument/2006/relationships" xmlns:a="http://schemas.openxmlformats.org/drawingml/2006/main" r:embed="Rdb7720f546cd4d2f"/>
           <a:stretch xmlns:a="http://schemas.openxmlformats.org/drawingml/2006/main"/>
         </p:blipFill>
         <p:spPr>
           <a:xfrm xmlns:a="http://schemas.openxmlformats.org/drawingml/2006/main">
-            <a:off x="10248900" y="361950"/>
+            <a:off x="10058400" y="400050"/>
             <a:ext cx="1409700" cy="323850"/>
           </a:xfrm>
           <a:prstGeom xmlns:a="http://schemas.openxmlformats.org/drawingml/2006/main" prst="rect">
@@ -5725,8 +5725,8 @@
         </p:nvSpPr>
         <p:spPr>
           <a:xfrm xmlns:a="http://schemas.openxmlformats.org/drawingml/2006/main">
-            <a:off x="533400" y="409575"/>
-            <a:ext cx="9334500" cy="238125"/>
+            <a:off x="723900" y="447675"/>
+            <a:ext cx="9014841" cy="238125"/>
           </a:xfrm>
           <a:prstGeom xmlns:a="http://schemas.openxmlformats.org/drawingml/2006/main" prst="rect">
             <a:avLst/>
@@ -5786,8 +5786,8 @@
         </p:nvSpPr>
         <p:spPr>
           <a:xfrm xmlns:a="http://schemas.openxmlformats.org/drawingml/2006/main">
-            <a:off x="533400" y="828675"/>
-            <a:ext cx="10191750" cy="1047750"/>
+            <a:off x="723900" y="904875"/>
+            <a:ext cx="9842754" cy="1047750"/>
           </a:xfrm>
           <a:prstGeom xmlns:a="http://schemas.openxmlformats.org/drawingml/2006/main" prst="rect">
             <a:avLst/>
@@ -5874,8 +5874,8 @@
         </p:nvSpPr>
         <p:spPr>
           <a:xfrm xmlns:a="http://schemas.openxmlformats.org/drawingml/2006/main">
-            <a:off x="6715125" y="2428875"/>
-            <a:ext cx="4943475" cy="476250"/>
+            <a:off x="6693884" y="2428875"/>
+            <a:ext cx="4774216" cy="476250"/>
           </a:xfrm>
           <a:prstGeom xmlns:a="http://schemas.openxmlformats.org/drawingml/2006/main" prst="rect">
             <a:avLst/>
@@ -5935,8 +5935,8 @@
         </p:nvSpPr>
         <p:spPr>
           <a:xfrm xmlns:a="http://schemas.openxmlformats.org/drawingml/2006/main">
-            <a:off x="6715125" y="2905125"/>
-            <a:ext cx="4943475" cy="962025"/>
+            <a:off x="6693884" y="2905125"/>
+            <a:ext cx="4774216" cy="962025"/>
           </a:xfrm>
           <a:prstGeom xmlns:a="http://schemas.openxmlformats.org/drawingml/2006/main" prst="rect">
             <a:avLst/>
@@ -5996,8 +5996,8 @@
         </p:nvSpPr>
         <p:spPr>
           <a:xfrm xmlns:a="http://schemas.openxmlformats.org/drawingml/2006/main">
-            <a:off x="6715125" y="4114800"/>
-            <a:ext cx="4943475" cy="466725"/>
+            <a:off x="6693884" y="4114800"/>
+            <a:ext cx="4774216" cy="466725"/>
           </a:xfrm>
           <a:prstGeom xmlns:a="http://schemas.openxmlformats.org/drawingml/2006/main" prst="rect">
             <a:avLst/>
@@ -6057,8 +6057,8 @@
         </p:nvSpPr>
         <p:spPr>
           <a:xfrm xmlns:a="http://schemas.openxmlformats.org/drawingml/2006/main">
-            <a:off x="6715125" y="4581525"/>
-            <a:ext cx="4943475" cy="1095375"/>
+            <a:off x="6693884" y="4581525"/>
+            <a:ext cx="4774216" cy="1095375"/>
           </a:xfrm>
           <a:prstGeom xmlns:a="http://schemas.openxmlformats.org/drawingml/2006/main" prst="rect">
             <a:avLst/>
@@ -6138,7 +6138,7 @@
           <p:nvPr/>
         </p:nvPicPr>
         <p:blipFill>
-          <a:blip xmlns:r="http://schemas.openxmlformats.org/officeDocument/2006/relationships" xmlns:a="http://schemas.openxmlformats.org/drawingml/2006/main" r:embed="Rc3eaff21f9be430b"/>
+          <a:blip xmlns:r="http://schemas.openxmlformats.org/officeDocument/2006/relationships" xmlns:a="http://schemas.openxmlformats.org/drawingml/2006/main" r:embed="R488cca34385c45c0"/>
           <a:srcRect xmlns:a="http://schemas.openxmlformats.org/drawingml/2006/main" l="7910" t="0" r="7910" b="0"/>
           <a:stretch xmlns:a="http://schemas.openxmlformats.org/drawingml/2006/main">
             <a:fillRect l="0" t="0" r="0" b="0"/>
@@ -6146,8 +6146,8 @@
         </p:blipFill>
         <p:spPr>
           <a:xfrm xmlns:a="http://schemas.openxmlformats.org/drawingml/2006/main">
-            <a:off x="533400" y="2295525"/>
-            <a:ext cx="5676900" cy="3371850"/>
+            <a:off x="723900" y="2371725"/>
+            <a:ext cx="5262467" cy="3125724"/>
           </a:xfrm>
           <a:prstGeom xmlns:a="http://schemas.openxmlformats.org/drawingml/2006/main" prst="rect">
             <a:avLst/>
@@ -6170,8 +6170,8 @@
         </p:nvSpPr>
         <p:spPr>
           <a:xfrm xmlns:a="http://schemas.openxmlformats.org/drawingml/2006/main">
-            <a:off x="533400" y="5715000"/>
-            <a:ext cx="5676900" cy="276225"/>
+            <a:off x="723900" y="5611749"/>
+            <a:ext cx="6000750" cy="276225"/>
           </a:xfrm>
           <a:prstGeom xmlns:a="http://schemas.openxmlformats.org/drawingml/2006/main" prst="rect">
             <a:avLst/>
@@ -6231,8 +6231,8 @@
         </p:nvSpPr>
         <p:spPr>
           <a:xfrm xmlns:a="http://schemas.openxmlformats.org/drawingml/2006/main">
-            <a:off x="533400" y="6105525"/>
-            <a:ext cx="38100" cy="304800"/>
+            <a:off x="723900" y="6105525"/>
+            <a:ext cx="36767" cy="304800"/>
           </a:xfrm>
           <a:prstGeom xmlns:a="http://schemas.openxmlformats.org/drawingml/2006/main" prst="rect">
             <a:avLst/>
@@ -6261,8 +6261,8 @@
         </p:nvSpPr>
         <p:spPr>
           <a:xfrm xmlns:a="http://schemas.openxmlformats.org/drawingml/2006/main">
-            <a:off x="733425" y="6076950"/>
-            <a:ext cx="10858500" cy="428625"/>
+            <a:off x="917067" y="6076950"/>
+            <a:ext cx="10486644" cy="428625"/>
           </a:xfrm>
           <a:prstGeom xmlns:a="http://schemas.openxmlformats.org/drawingml/2006/main" prst="rect">
             <a:avLst/>
@@ -6322,8 +6322,8 @@
         </p:nvSpPr>
         <p:spPr>
           <a:xfrm xmlns:a="http://schemas.openxmlformats.org/drawingml/2006/main">
-            <a:off x="533400" y="6562725"/>
-            <a:ext cx="9429750" cy="190500"/>
+            <a:off x="723900" y="6562725"/>
+            <a:ext cx="9106853" cy="190500"/>
           </a:xfrm>
           <a:prstGeom xmlns:a="http://schemas.openxmlformats.org/drawingml/2006/main" prst="rect">
             <a:avLst/>
@@ -6383,8 +6383,8 @@
         </p:nvSpPr>
         <p:spPr>
           <a:xfrm xmlns:a="http://schemas.openxmlformats.org/drawingml/2006/main">
-            <a:off x="10706100" y="6562725"/>
-            <a:ext cx="952500" cy="190500"/>
+            <a:off x="10548176" y="6562725"/>
+            <a:ext cx="919925" cy="190500"/>
           </a:xfrm>
           <a:prstGeom xmlns:a="http://schemas.openxmlformats.org/drawingml/2006/main" prst="rect">
             <a:avLst/>
@@ -6437,12 +6437,12 @@
           <p:nvPr/>
         </p:nvPicPr>
         <p:blipFill>
-          <a:blip xmlns:r="http://schemas.openxmlformats.org/officeDocument/2006/relationships" xmlns:a="http://schemas.openxmlformats.org/drawingml/2006/main" r:embed="Rbe85e3fd1bf44dee"/>
+          <a:blip xmlns:r="http://schemas.openxmlformats.org/officeDocument/2006/relationships" xmlns:a="http://schemas.openxmlformats.org/drawingml/2006/main" r:embed="R766e7ab690a746e7"/>
           <a:stretch xmlns:a="http://schemas.openxmlformats.org/drawingml/2006/main"/>
         </p:blipFill>
         <p:spPr>
           <a:xfrm xmlns:a="http://schemas.openxmlformats.org/drawingml/2006/main">
-            <a:off x="10248900" y="361950"/>
+            <a:off x="10058400" y="400050"/>
             <a:ext cx="1409700" cy="323850"/>
           </a:xfrm>
           <a:prstGeom xmlns:a="http://schemas.openxmlformats.org/drawingml/2006/main" prst="rect">
@@ -6495,8 +6495,8 @@
         </p:nvSpPr>
         <p:spPr>
           <a:xfrm xmlns:a="http://schemas.openxmlformats.org/drawingml/2006/main">
-            <a:off x="533400" y="409575"/>
-            <a:ext cx="9334500" cy="238125"/>
+            <a:off x="723900" y="447675"/>
+            <a:ext cx="9014841" cy="238125"/>
           </a:xfrm>
           <a:prstGeom xmlns:a="http://schemas.openxmlformats.org/drawingml/2006/main" prst="rect">
             <a:avLst/>
@@ -6556,8 +6556,8 @@
         </p:nvSpPr>
         <p:spPr>
           <a:xfrm xmlns:a="http://schemas.openxmlformats.org/drawingml/2006/main">
-            <a:off x="533400" y="828675"/>
-            <a:ext cx="10572750" cy="1047750"/>
+            <a:off x="723900" y="904875"/>
+            <a:ext cx="10210705" cy="1047750"/>
           </a:xfrm>
           <a:prstGeom xmlns:a="http://schemas.openxmlformats.org/drawingml/2006/main" prst="rect">
             <a:avLst/>
@@ -6644,8 +6644,8 @@
         </p:nvSpPr>
         <p:spPr>
           <a:xfrm xmlns:a="http://schemas.openxmlformats.org/drawingml/2006/main">
-            <a:off x="533400" y="2057400"/>
-            <a:ext cx="10953750" cy="704850"/>
+            <a:off x="723900" y="2143125"/>
+            <a:ext cx="10578655" cy="704850"/>
           </a:xfrm>
           <a:prstGeom xmlns:a="http://schemas.openxmlformats.org/drawingml/2006/main" prst="rect">
             <a:avLst/>
@@ -6705,8 +6705,8 @@
         </p:nvSpPr>
         <p:spPr>
           <a:xfrm xmlns:a="http://schemas.openxmlformats.org/drawingml/2006/main">
-            <a:off x="533400" y="3152775"/>
-            <a:ext cx="609600" cy="523875"/>
+            <a:off x="723900" y="3114675"/>
+            <a:ext cx="588740" cy="523875"/>
           </a:xfrm>
           <a:prstGeom xmlns:a="http://schemas.openxmlformats.org/drawingml/2006/main" prst="rect">
             <a:avLst/>
@@ -6766,8 +6766,8 @@
         </p:nvSpPr>
         <p:spPr>
           <a:xfrm xmlns:a="http://schemas.openxmlformats.org/drawingml/2006/main">
-            <a:off x="1352550" y="3152775"/>
-            <a:ext cx="4476750" cy="409575"/>
+            <a:off x="1514951" y="3114675"/>
+            <a:ext cx="4323398" cy="409575"/>
           </a:xfrm>
           <a:prstGeom xmlns:a="http://schemas.openxmlformats.org/drawingml/2006/main" prst="rect">
             <a:avLst/>
@@ -6827,8 +6827,8 @@
         </p:nvSpPr>
         <p:spPr>
           <a:xfrm xmlns:a="http://schemas.openxmlformats.org/drawingml/2006/main">
-            <a:off x="1352550" y="3571875"/>
-            <a:ext cx="4429125" cy="742950"/>
+            <a:off x="1514951" y="3533775"/>
+            <a:ext cx="4277487" cy="742950"/>
           </a:xfrm>
           <a:prstGeom xmlns:a="http://schemas.openxmlformats.org/drawingml/2006/main" prst="rect">
             <a:avLst/>
@@ -6888,8 +6888,8 @@
         </p:nvSpPr>
         <p:spPr>
           <a:xfrm xmlns:a="http://schemas.openxmlformats.org/drawingml/2006/main">
-            <a:off x="6315075" y="3152775"/>
-            <a:ext cx="609600" cy="523875"/>
+            <a:off x="6307550" y="3114675"/>
+            <a:ext cx="588740" cy="523875"/>
           </a:xfrm>
           <a:prstGeom xmlns:a="http://schemas.openxmlformats.org/drawingml/2006/main" prst="rect">
             <a:avLst/>
@@ -6949,8 +6949,8 @@
         </p:nvSpPr>
         <p:spPr>
           <a:xfrm xmlns:a="http://schemas.openxmlformats.org/drawingml/2006/main">
-            <a:off x="7134225" y="3152775"/>
-            <a:ext cx="4476750" cy="409575"/>
+            <a:off x="7098697" y="3114675"/>
+            <a:ext cx="4323398" cy="409575"/>
           </a:xfrm>
           <a:prstGeom xmlns:a="http://schemas.openxmlformats.org/drawingml/2006/main" prst="rect">
             <a:avLst/>
@@ -7010,8 +7010,8 @@
         </p:nvSpPr>
         <p:spPr>
           <a:xfrm xmlns:a="http://schemas.openxmlformats.org/drawingml/2006/main">
-            <a:off x="7134225" y="3571875"/>
-            <a:ext cx="4429125" cy="742950"/>
+            <a:off x="7098697" y="3533775"/>
+            <a:ext cx="4277487" cy="742950"/>
           </a:xfrm>
           <a:prstGeom xmlns:a="http://schemas.openxmlformats.org/drawingml/2006/main" prst="rect">
             <a:avLst/>
@@ -7071,8 +7071,8 @@
         </p:nvSpPr>
         <p:spPr>
           <a:xfrm xmlns:a="http://schemas.openxmlformats.org/drawingml/2006/main">
-            <a:off x="533400" y="4391025"/>
-            <a:ext cx="609600" cy="523875"/>
+            <a:off x="723900" y="4448175"/>
+            <a:ext cx="588740" cy="523875"/>
           </a:xfrm>
           <a:prstGeom xmlns:a="http://schemas.openxmlformats.org/drawingml/2006/main" prst="rect">
             <a:avLst/>
@@ -7132,8 +7132,8 @@
         </p:nvSpPr>
         <p:spPr>
           <a:xfrm xmlns:a="http://schemas.openxmlformats.org/drawingml/2006/main">
-            <a:off x="1352550" y="4391025"/>
-            <a:ext cx="4476750" cy="409575"/>
+            <a:off x="1514951" y="4448175"/>
+            <a:ext cx="4323398" cy="409575"/>
           </a:xfrm>
           <a:prstGeom xmlns:a="http://schemas.openxmlformats.org/drawingml/2006/main" prst="rect">
             <a:avLst/>
@@ -7193,8 +7193,8 @@
         </p:nvSpPr>
         <p:spPr>
           <a:xfrm xmlns:a="http://schemas.openxmlformats.org/drawingml/2006/main">
-            <a:off x="1352550" y="4810125"/>
-            <a:ext cx="4429125" cy="742950"/>
+            <a:off x="1514951" y="4867275"/>
+            <a:ext cx="4277487" cy="742950"/>
           </a:xfrm>
           <a:prstGeom xmlns:a="http://schemas.openxmlformats.org/drawingml/2006/main" prst="rect">
             <a:avLst/>
@@ -7254,8 +7254,8 @@
         </p:nvSpPr>
         <p:spPr>
           <a:xfrm xmlns:a="http://schemas.openxmlformats.org/drawingml/2006/main">
-            <a:off x="6315075" y="4391025"/>
-            <a:ext cx="609600" cy="523875"/>
+            <a:off x="6307550" y="4448175"/>
+            <a:ext cx="588740" cy="523875"/>
           </a:xfrm>
           <a:prstGeom xmlns:a="http://schemas.openxmlformats.org/drawingml/2006/main" prst="rect">
             <a:avLst/>
@@ -7315,8 +7315,8 @@
         </p:nvSpPr>
         <p:spPr>
           <a:xfrm xmlns:a="http://schemas.openxmlformats.org/drawingml/2006/main">
-            <a:off x="7134225" y="4391025"/>
-            <a:ext cx="4476750" cy="409575"/>
+            <a:off x="7098697" y="4448175"/>
+            <a:ext cx="4323398" cy="409575"/>
           </a:xfrm>
           <a:prstGeom xmlns:a="http://schemas.openxmlformats.org/drawingml/2006/main" prst="rect">
             <a:avLst/>
@@ -7376,8 +7376,8 @@
         </p:nvSpPr>
         <p:spPr>
           <a:xfrm xmlns:a="http://schemas.openxmlformats.org/drawingml/2006/main">
-            <a:off x="7134225" y="4810125"/>
-            <a:ext cx="4429125" cy="742950"/>
+            <a:off x="7098697" y="4867275"/>
+            <a:ext cx="4277487" cy="742950"/>
           </a:xfrm>
           <a:prstGeom xmlns:a="http://schemas.openxmlformats.org/drawingml/2006/main" prst="rect">
             <a:avLst/>
@@ -7464,8 +7464,8 @@
         </p:nvSpPr>
         <p:spPr>
           <a:xfrm xmlns:a="http://schemas.openxmlformats.org/drawingml/2006/main">
-            <a:off x="533400" y="5676900"/>
-            <a:ext cx="11125200" cy="257175"/>
+            <a:off x="723900" y="5676900"/>
+            <a:ext cx="10744200" cy="257175"/>
           </a:xfrm>
           <a:prstGeom xmlns:a="http://schemas.openxmlformats.org/drawingml/2006/main" prst="rect">
             <a:avLst/>
@@ -7525,8 +7525,8 @@
         </p:nvSpPr>
         <p:spPr>
           <a:xfrm xmlns:a="http://schemas.openxmlformats.org/drawingml/2006/main">
-            <a:off x="533400" y="6105525"/>
-            <a:ext cx="38100" cy="304800"/>
+            <a:off x="723900" y="6105525"/>
+            <a:ext cx="36767" cy="304800"/>
           </a:xfrm>
           <a:prstGeom xmlns:a="http://schemas.openxmlformats.org/drawingml/2006/main" prst="rect">
             <a:avLst/>
@@ -7555,8 +7555,8 @@
         </p:nvSpPr>
         <p:spPr>
           <a:xfrm xmlns:a="http://schemas.openxmlformats.org/drawingml/2006/main">
-            <a:off x="733425" y="6076950"/>
-            <a:ext cx="10858500" cy="428625"/>
+            <a:off x="917067" y="6076950"/>
+            <a:ext cx="10486644" cy="428625"/>
           </a:xfrm>
           <a:prstGeom xmlns:a="http://schemas.openxmlformats.org/drawingml/2006/main" prst="rect">
             <a:avLst/>
@@ -7616,8 +7616,8 @@
         </p:nvSpPr>
         <p:spPr>
           <a:xfrm xmlns:a="http://schemas.openxmlformats.org/drawingml/2006/main">
-            <a:off x="533400" y="6562725"/>
-            <a:ext cx="9429750" cy="190500"/>
+            <a:off x="723900" y="6562725"/>
+            <a:ext cx="9106853" cy="190500"/>
           </a:xfrm>
           <a:prstGeom xmlns:a="http://schemas.openxmlformats.org/drawingml/2006/main" prst="rect">
             <a:avLst/>
@@ -7677,8 +7677,8 @@
         </p:nvSpPr>
         <p:spPr>
           <a:xfrm xmlns:a="http://schemas.openxmlformats.org/drawingml/2006/main">
-            <a:off x="10706100" y="6562725"/>
-            <a:ext cx="952500" cy="190500"/>
+            <a:off x="10548176" y="6562725"/>
+            <a:ext cx="919925" cy="190500"/>
           </a:xfrm>
           <a:prstGeom xmlns:a="http://schemas.openxmlformats.org/drawingml/2006/main" prst="rect">
             <a:avLst/>
@@ -7731,12 +7731,12 @@
           <p:nvPr/>
         </p:nvPicPr>
         <p:blipFill>
-          <a:blip xmlns:r="http://schemas.openxmlformats.org/officeDocument/2006/relationships" xmlns:a="http://schemas.openxmlformats.org/drawingml/2006/main" r:embed="Rf081ae423c2740f5"/>
+          <a:blip xmlns:r="http://schemas.openxmlformats.org/officeDocument/2006/relationships" xmlns:a="http://schemas.openxmlformats.org/drawingml/2006/main" r:embed="R3f323e56a0f44332"/>
           <a:stretch xmlns:a="http://schemas.openxmlformats.org/drawingml/2006/main"/>
         </p:blipFill>
         <p:spPr>
           <a:xfrm xmlns:a="http://schemas.openxmlformats.org/drawingml/2006/main">
-            <a:off x="10248900" y="361950"/>
+            <a:off x="10058400" y="400050"/>
             <a:ext cx="1409700" cy="323850"/>
           </a:xfrm>
           <a:prstGeom xmlns:a="http://schemas.openxmlformats.org/drawingml/2006/main" prst="rect">
@@ -7789,8 +7789,8 @@
         </p:nvSpPr>
         <p:spPr>
           <a:xfrm xmlns:a="http://schemas.openxmlformats.org/drawingml/2006/main">
-            <a:off x="533400" y="409575"/>
-            <a:ext cx="9334500" cy="238125"/>
+            <a:off x="723900" y="447675"/>
+            <a:ext cx="9014841" cy="238125"/>
           </a:xfrm>
           <a:prstGeom xmlns:a="http://schemas.openxmlformats.org/drawingml/2006/main" prst="rect">
             <a:avLst/>
@@ -7850,8 +7850,8 @@
         </p:nvSpPr>
         <p:spPr>
           <a:xfrm xmlns:a="http://schemas.openxmlformats.org/drawingml/2006/main">
-            <a:off x="533400" y="828675"/>
-            <a:ext cx="10287000" cy="1047750"/>
+            <a:off x="723900" y="904875"/>
+            <a:ext cx="9934670" cy="1047750"/>
           </a:xfrm>
           <a:prstGeom xmlns:a="http://schemas.openxmlformats.org/drawingml/2006/main" prst="rect">
             <a:avLst/>
@@ -7938,8 +7938,8 @@
         </p:nvSpPr>
         <p:spPr>
           <a:xfrm xmlns:a="http://schemas.openxmlformats.org/drawingml/2006/main">
-            <a:off x="533400" y="2009775"/>
-            <a:ext cx="11125200" cy="762000"/>
+            <a:off x="723900" y="2105025"/>
+            <a:ext cx="10744200" cy="762000"/>
           </a:xfrm>
           <a:prstGeom xmlns:a="http://schemas.openxmlformats.org/drawingml/2006/main" prst="rect">
             <a:avLst/>
@@ -7999,8 +7999,8 @@
         </p:nvSpPr>
         <p:spPr>
           <a:xfrm xmlns:a="http://schemas.openxmlformats.org/drawingml/2006/main">
-            <a:off x="533400" y="3162300"/>
-            <a:ext cx="38100" cy="1104900"/>
+            <a:off x="723900" y="3019425"/>
+            <a:ext cx="36767" cy="1028700"/>
           </a:xfrm>
           <a:prstGeom xmlns:a="http://schemas.openxmlformats.org/drawingml/2006/main" prst="rect">
             <a:avLst/>
@@ -8029,8 +8029,8 @@
         </p:nvSpPr>
         <p:spPr>
           <a:xfrm xmlns:a="http://schemas.openxmlformats.org/drawingml/2006/main">
-            <a:off x="742950" y="3152775"/>
-            <a:ext cx="5057775" cy="428625"/>
+            <a:off x="926306" y="3009900"/>
+            <a:ext cx="4884611" cy="428625"/>
           </a:xfrm>
           <a:prstGeom xmlns:a="http://schemas.openxmlformats.org/drawingml/2006/main" prst="rect">
             <a:avLst/>
@@ -8090,8 +8090,8 @@
         </p:nvSpPr>
         <p:spPr>
           <a:xfrm xmlns:a="http://schemas.openxmlformats.org/drawingml/2006/main">
-            <a:off x="742950" y="3619500"/>
-            <a:ext cx="5038725" cy="904875"/>
+            <a:off x="926306" y="3476625"/>
+            <a:ext cx="4866132" cy="904875"/>
           </a:xfrm>
           <a:prstGeom xmlns:a="http://schemas.openxmlformats.org/drawingml/2006/main" prst="rect">
             <a:avLst/>
@@ -8178,8 +8178,8 @@
         </p:nvSpPr>
         <p:spPr>
           <a:xfrm xmlns:a="http://schemas.openxmlformats.org/drawingml/2006/main">
-            <a:off x="6362700" y="3162300"/>
-            <a:ext cx="38100" cy="1104900"/>
+            <a:off x="6353556" y="3019425"/>
+            <a:ext cx="36767" cy="1028700"/>
           </a:xfrm>
           <a:prstGeom xmlns:a="http://schemas.openxmlformats.org/drawingml/2006/main" prst="rect">
             <a:avLst/>
@@ -8208,8 +8208,8 @@
         </p:nvSpPr>
         <p:spPr>
           <a:xfrm xmlns:a="http://schemas.openxmlformats.org/drawingml/2006/main">
-            <a:off x="6572250" y="3152775"/>
-            <a:ext cx="5057775" cy="428625"/>
+            <a:off x="6555962" y="3009900"/>
+            <a:ext cx="4884611" cy="428625"/>
           </a:xfrm>
           <a:prstGeom xmlns:a="http://schemas.openxmlformats.org/drawingml/2006/main" prst="rect">
             <a:avLst/>
@@ -8269,8 +8269,8 @@
         </p:nvSpPr>
         <p:spPr>
           <a:xfrm xmlns:a="http://schemas.openxmlformats.org/drawingml/2006/main">
-            <a:off x="6572250" y="3619500"/>
-            <a:ext cx="5038725" cy="904875"/>
+            <a:off x="6555962" y="3476625"/>
+            <a:ext cx="4866132" cy="904875"/>
           </a:xfrm>
           <a:prstGeom xmlns:a="http://schemas.openxmlformats.org/drawingml/2006/main" prst="rect">
             <a:avLst/>
@@ -8357,8 +8357,8 @@
         </p:nvSpPr>
         <p:spPr>
           <a:xfrm xmlns:a="http://schemas.openxmlformats.org/drawingml/2006/main">
-            <a:off x="533400" y="4572000"/>
-            <a:ext cx="38100" cy="1104900"/>
+            <a:off x="723900" y="4610100"/>
+            <a:ext cx="36767" cy="1028700"/>
           </a:xfrm>
           <a:prstGeom xmlns:a="http://schemas.openxmlformats.org/drawingml/2006/main" prst="rect">
             <a:avLst/>
@@ -8387,8 +8387,8 @@
         </p:nvSpPr>
         <p:spPr>
           <a:xfrm xmlns:a="http://schemas.openxmlformats.org/drawingml/2006/main">
-            <a:off x="742950" y="4562475"/>
-            <a:ext cx="5057775" cy="428625"/>
+            <a:off x="926306" y="4600575"/>
+            <a:ext cx="4884611" cy="428625"/>
           </a:xfrm>
           <a:prstGeom xmlns:a="http://schemas.openxmlformats.org/drawingml/2006/main" prst="rect">
             <a:avLst/>
@@ -8448,8 +8448,8 @@
         </p:nvSpPr>
         <p:spPr>
           <a:xfrm xmlns:a="http://schemas.openxmlformats.org/drawingml/2006/main">
-            <a:off x="742950" y="5029200"/>
-            <a:ext cx="5038725" cy="904875"/>
+            <a:off x="926306" y="5067300"/>
+            <a:ext cx="4866132" cy="904875"/>
           </a:xfrm>
           <a:prstGeom xmlns:a="http://schemas.openxmlformats.org/drawingml/2006/main" prst="rect">
             <a:avLst/>
@@ -8536,8 +8536,8 @@
         </p:nvSpPr>
         <p:spPr>
           <a:xfrm xmlns:a="http://schemas.openxmlformats.org/drawingml/2006/main">
-            <a:off x="6362700" y="4572000"/>
-            <a:ext cx="38100" cy="1104900"/>
+            <a:off x="6353556" y="4610100"/>
+            <a:ext cx="36767" cy="1028700"/>
           </a:xfrm>
           <a:prstGeom xmlns:a="http://schemas.openxmlformats.org/drawingml/2006/main" prst="rect">
             <a:avLst/>
@@ -8566,8 +8566,8 @@
         </p:nvSpPr>
         <p:spPr>
           <a:xfrm xmlns:a="http://schemas.openxmlformats.org/drawingml/2006/main">
-            <a:off x="6572250" y="4562475"/>
-            <a:ext cx="5057775" cy="428625"/>
+            <a:off x="6555962" y="4600575"/>
+            <a:ext cx="4884611" cy="428625"/>
           </a:xfrm>
           <a:prstGeom xmlns:a="http://schemas.openxmlformats.org/drawingml/2006/main" prst="rect">
             <a:avLst/>
@@ -8627,8 +8627,8 @@
         </p:nvSpPr>
         <p:spPr>
           <a:xfrm xmlns:a="http://schemas.openxmlformats.org/drawingml/2006/main">
-            <a:off x="6572250" y="5029200"/>
-            <a:ext cx="5038725" cy="904875"/>
+            <a:off x="6555962" y="5067300"/>
+            <a:ext cx="4866132" cy="904875"/>
           </a:xfrm>
           <a:prstGeom xmlns:a="http://schemas.openxmlformats.org/drawingml/2006/main" prst="rect">
             <a:avLst/>
@@ -8715,8 +8715,8 @@
         </p:nvSpPr>
         <p:spPr>
           <a:xfrm xmlns:a="http://schemas.openxmlformats.org/drawingml/2006/main">
-            <a:off x="533400" y="6105525"/>
-            <a:ext cx="38100" cy="304800"/>
+            <a:off x="723900" y="6105525"/>
+            <a:ext cx="36767" cy="304800"/>
           </a:xfrm>
           <a:prstGeom xmlns:a="http://schemas.openxmlformats.org/drawingml/2006/main" prst="rect">
             <a:avLst/>
@@ -8745,8 +8745,8 @@
         </p:nvSpPr>
         <p:spPr>
           <a:xfrm xmlns:a="http://schemas.openxmlformats.org/drawingml/2006/main">
-            <a:off x="733425" y="6076950"/>
-            <a:ext cx="10858500" cy="428625"/>
+            <a:off x="917067" y="6076950"/>
+            <a:ext cx="10486644" cy="428625"/>
           </a:xfrm>
           <a:prstGeom xmlns:a="http://schemas.openxmlformats.org/drawingml/2006/main" prst="rect">
             <a:avLst/>
@@ -8806,8 +8806,8 @@
         </p:nvSpPr>
         <p:spPr>
           <a:xfrm xmlns:a="http://schemas.openxmlformats.org/drawingml/2006/main">
-            <a:off x="533400" y="6562725"/>
-            <a:ext cx="9429750" cy="190500"/>
+            <a:off x="723900" y="6562725"/>
+            <a:ext cx="9106853" cy="190500"/>
           </a:xfrm>
           <a:prstGeom xmlns:a="http://schemas.openxmlformats.org/drawingml/2006/main" prst="rect">
             <a:avLst/>
@@ -8867,8 +8867,8 @@
         </p:nvSpPr>
         <p:spPr>
           <a:xfrm xmlns:a="http://schemas.openxmlformats.org/drawingml/2006/main">
-            <a:off x="10706100" y="6562725"/>
-            <a:ext cx="952500" cy="190500"/>
+            <a:off x="10548176" y="6562725"/>
+            <a:ext cx="919925" cy="190500"/>
           </a:xfrm>
           <a:prstGeom xmlns:a="http://schemas.openxmlformats.org/drawingml/2006/main" prst="rect">
             <a:avLst/>
@@ -8921,12 +8921,12 @@
           <p:nvPr/>
         </p:nvPicPr>
         <p:blipFill>
-          <a:blip xmlns:r="http://schemas.openxmlformats.org/officeDocument/2006/relationships" xmlns:a="http://schemas.openxmlformats.org/drawingml/2006/main" r:embed="R3ae13646906042b9"/>
+          <a:blip xmlns:r="http://schemas.openxmlformats.org/officeDocument/2006/relationships" xmlns:a="http://schemas.openxmlformats.org/drawingml/2006/main" r:embed="Rc201bbffc52e4b77"/>
           <a:stretch xmlns:a="http://schemas.openxmlformats.org/drawingml/2006/main"/>
         </p:blipFill>
         <p:spPr>
           <a:xfrm xmlns:a="http://schemas.openxmlformats.org/drawingml/2006/main">
-            <a:off x="10248900" y="361950"/>
+            <a:off x="10058400" y="400050"/>
             <a:ext cx="1409700" cy="323850"/>
           </a:xfrm>
           <a:prstGeom xmlns:a="http://schemas.openxmlformats.org/drawingml/2006/main" prst="rect">
@@ -8979,8 +8979,8 @@
         </p:nvSpPr>
         <p:spPr>
           <a:xfrm xmlns:a="http://schemas.openxmlformats.org/drawingml/2006/main">
-            <a:off x="533400" y="409575"/>
-            <a:ext cx="9334500" cy="238125"/>
+            <a:off x="723900" y="447675"/>
+            <a:ext cx="9014841" cy="238125"/>
           </a:xfrm>
           <a:prstGeom xmlns:a="http://schemas.openxmlformats.org/drawingml/2006/main" prst="rect">
             <a:avLst/>
@@ -9040,8 +9040,8 @@
         </p:nvSpPr>
         <p:spPr>
           <a:xfrm xmlns:a="http://schemas.openxmlformats.org/drawingml/2006/main">
-            <a:off x="533400" y="828675"/>
-            <a:ext cx="9525000" cy="1047750"/>
+            <a:off x="723900" y="904875"/>
+            <a:ext cx="9198769" cy="1047750"/>
           </a:xfrm>
           <a:prstGeom xmlns:a="http://schemas.openxmlformats.org/drawingml/2006/main" prst="rect">
             <a:avLst/>
@@ -9128,8 +9128,8 @@
         </p:nvSpPr>
         <p:spPr>
           <a:xfrm xmlns:a="http://schemas.openxmlformats.org/drawingml/2006/main">
-            <a:off x="533400" y="2038350"/>
-            <a:ext cx="11125200" cy="466725"/>
+            <a:off x="723900" y="2133600"/>
+            <a:ext cx="10744200" cy="466725"/>
           </a:xfrm>
           <a:prstGeom xmlns:a="http://schemas.openxmlformats.org/drawingml/2006/main" prst="rect">
             <a:avLst/>
@@ -9189,8 +9189,8 @@
         </p:nvSpPr>
         <p:spPr>
           <a:xfrm xmlns:a="http://schemas.openxmlformats.org/drawingml/2006/main">
-            <a:off x="533400" y="2828925"/>
-            <a:ext cx="619125" cy="781050"/>
+            <a:off x="723900" y="2828925"/>
+            <a:ext cx="597884" cy="781050"/>
           </a:xfrm>
           <a:prstGeom xmlns:a="http://schemas.openxmlformats.org/drawingml/2006/main" prst="rect">
             <a:avLst/>
@@ -9250,8 +9250,8 @@
         </p:nvSpPr>
         <p:spPr>
           <a:xfrm xmlns:a="http://schemas.openxmlformats.org/drawingml/2006/main">
-            <a:off x="1419225" y="2876550"/>
-            <a:ext cx="10144125" cy="381000"/>
+            <a:off x="1579436" y="2876550"/>
+            <a:ext cx="9796748" cy="381000"/>
           </a:xfrm>
           <a:prstGeom xmlns:a="http://schemas.openxmlformats.org/drawingml/2006/main" prst="rect">
             <a:avLst/>
@@ -9311,8 +9311,8 @@
         </p:nvSpPr>
         <p:spPr>
           <a:xfrm xmlns:a="http://schemas.openxmlformats.org/drawingml/2006/main">
-            <a:off x="1419225" y="3305175"/>
-            <a:ext cx="10144125" cy="590550"/>
+            <a:off x="1579436" y="3305175"/>
+            <a:ext cx="9796748" cy="590550"/>
           </a:xfrm>
           <a:prstGeom xmlns:a="http://schemas.openxmlformats.org/drawingml/2006/main" prst="rect">
             <a:avLst/>
@@ -9372,8 +9372,8 @@
         </p:nvSpPr>
         <p:spPr>
           <a:xfrm xmlns:a="http://schemas.openxmlformats.org/drawingml/2006/main">
-            <a:off x="533400" y="3838575"/>
-            <a:ext cx="619125" cy="781050"/>
+            <a:off x="723900" y="3838575"/>
+            <a:ext cx="597884" cy="781050"/>
           </a:xfrm>
           <a:prstGeom xmlns:a="http://schemas.openxmlformats.org/drawingml/2006/main" prst="rect">
             <a:avLst/>
@@ -9433,8 +9433,8 @@
         </p:nvSpPr>
         <p:spPr>
           <a:xfrm xmlns:a="http://schemas.openxmlformats.org/drawingml/2006/main">
-            <a:off x="1419225" y="3886200"/>
-            <a:ext cx="10144125" cy="381000"/>
+            <a:off x="1579436" y="3886200"/>
+            <a:ext cx="9796748" cy="381000"/>
           </a:xfrm>
           <a:prstGeom xmlns:a="http://schemas.openxmlformats.org/drawingml/2006/main" prst="rect">
             <a:avLst/>
@@ -9494,8 +9494,8 @@
         </p:nvSpPr>
         <p:spPr>
           <a:xfrm xmlns:a="http://schemas.openxmlformats.org/drawingml/2006/main">
-            <a:off x="1419225" y="4314825"/>
-            <a:ext cx="10144125" cy="590550"/>
+            <a:off x="1579436" y="4314825"/>
+            <a:ext cx="9796748" cy="590550"/>
           </a:xfrm>
           <a:prstGeom xmlns:a="http://schemas.openxmlformats.org/drawingml/2006/main" prst="rect">
             <a:avLst/>
@@ -9555,8 +9555,8 @@
         </p:nvSpPr>
         <p:spPr>
           <a:xfrm xmlns:a="http://schemas.openxmlformats.org/drawingml/2006/main">
-            <a:off x="533400" y="4848225"/>
-            <a:ext cx="619125" cy="781050"/>
+            <a:off x="723900" y="4848225"/>
+            <a:ext cx="597884" cy="781050"/>
           </a:xfrm>
           <a:prstGeom xmlns:a="http://schemas.openxmlformats.org/drawingml/2006/main" prst="rect">
             <a:avLst/>
@@ -9616,8 +9616,8 @@
         </p:nvSpPr>
         <p:spPr>
           <a:xfrm xmlns:a="http://schemas.openxmlformats.org/drawingml/2006/main">
-            <a:off x="1419225" y="4895850"/>
-            <a:ext cx="10144125" cy="381000"/>
+            <a:off x="1579436" y="4895850"/>
+            <a:ext cx="9796748" cy="381000"/>
           </a:xfrm>
           <a:prstGeom xmlns:a="http://schemas.openxmlformats.org/drawingml/2006/main" prst="rect">
             <a:avLst/>
@@ -9677,8 +9677,8 @@
         </p:nvSpPr>
         <p:spPr>
           <a:xfrm xmlns:a="http://schemas.openxmlformats.org/drawingml/2006/main">
-            <a:off x="1419225" y="5324475"/>
-            <a:ext cx="10144125" cy="590550"/>
+            <a:off x="1579436" y="5324475"/>
+            <a:ext cx="9796748" cy="590550"/>
           </a:xfrm>
           <a:prstGeom xmlns:a="http://schemas.openxmlformats.org/drawingml/2006/main" prst="rect">
             <a:avLst/>
@@ -9738,8 +9738,8 @@
         </p:nvSpPr>
         <p:spPr>
           <a:xfrm xmlns:a="http://schemas.openxmlformats.org/drawingml/2006/main">
-            <a:off x="533400" y="6105525"/>
-            <a:ext cx="38100" cy="304800"/>
+            <a:off x="723900" y="6105525"/>
+            <a:ext cx="36767" cy="304800"/>
           </a:xfrm>
           <a:prstGeom xmlns:a="http://schemas.openxmlformats.org/drawingml/2006/main" prst="rect">
             <a:avLst/>
@@ -9768,8 +9768,8 @@
         </p:nvSpPr>
         <p:spPr>
           <a:xfrm xmlns:a="http://schemas.openxmlformats.org/drawingml/2006/main">
-            <a:off x="733425" y="6076950"/>
-            <a:ext cx="10858500" cy="428625"/>
+            <a:off x="917067" y="6076950"/>
+            <a:ext cx="10486644" cy="428625"/>
           </a:xfrm>
           <a:prstGeom xmlns:a="http://schemas.openxmlformats.org/drawingml/2006/main" prst="rect">
             <a:avLst/>
@@ -9829,8 +9829,8 @@
         </p:nvSpPr>
         <p:spPr>
           <a:xfrm xmlns:a="http://schemas.openxmlformats.org/drawingml/2006/main">
-            <a:off x="533400" y="6562725"/>
-            <a:ext cx="9429750" cy="190500"/>
+            <a:off x="723900" y="6562725"/>
+            <a:ext cx="9106853" cy="190500"/>
           </a:xfrm>
           <a:prstGeom xmlns:a="http://schemas.openxmlformats.org/drawingml/2006/main" prst="rect">
             <a:avLst/>
@@ -9890,8 +9890,8 @@
         </p:nvSpPr>
         <p:spPr>
           <a:xfrm xmlns:a="http://schemas.openxmlformats.org/drawingml/2006/main">
-            <a:off x="10706100" y="6562725"/>
-            <a:ext cx="952500" cy="190500"/>
+            <a:off x="10548176" y="6562725"/>
+            <a:ext cx="919925" cy="190500"/>
           </a:xfrm>
           <a:prstGeom xmlns:a="http://schemas.openxmlformats.org/drawingml/2006/main" prst="rect">
             <a:avLst/>
@@ -9944,12 +9944,12 @@
           <p:nvPr/>
         </p:nvPicPr>
         <p:blipFill>
-          <a:blip xmlns:r="http://schemas.openxmlformats.org/officeDocument/2006/relationships" xmlns:a="http://schemas.openxmlformats.org/drawingml/2006/main" r:embed="R4f200888b3544ca6"/>
+          <a:blip xmlns:r="http://schemas.openxmlformats.org/officeDocument/2006/relationships" xmlns:a="http://schemas.openxmlformats.org/drawingml/2006/main" r:embed="Rd314cb4672384797"/>
           <a:stretch xmlns:a="http://schemas.openxmlformats.org/drawingml/2006/main"/>
         </p:blipFill>
         <p:spPr>
           <a:xfrm xmlns:a="http://schemas.openxmlformats.org/drawingml/2006/main">
-            <a:off x="10248900" y="361950"/>
+            <a:off x="10058400" y="400050"/>
             <a:ext cx="1409700" cy="323850"/>
           </a:xfrm>
           <a:prstGeom xmlns:a="http://schemas.openxmlformats.org/drawingml/2006/main" prst="rect">
@@ -10002,8 +10002,8 @@
         </p:nvSpPr>
         <p:spPr>
           <a:xfrm xmlns:a="http://schemas.openxmlformats.org/drawingml/2006/main">
-            <a:off x="533400" y="409575"/>
-            <a:ext cx="9334500" cy="238125"/>
+            <a:off x="723900" y="447675"/>
+            <a:ext cx="9014841" cy="238125"/>
           </a:xfrm>
           <a:prstGeom xmlns:a="http://schemas.openxmlformats.org/drawingml/2006/main" prst="rect">
             <a:avLst/>
@@ -10063,8 +10063,8 @@
         </p:nvSpPr>
         <p:spPr>
           <a:xfrm xmlns:a="http://schemas.openxmlformats.org/drawingml/2006/main">
-            <a:off x="533400" y="828675"/>
-            <a:ext cx="6105525" cy="1476375"/>
+            <a:off x="723900" y="904875"/>
+            <a:ext cx="5896451" cy="1476375"/>
           </a:xfrm>
           <a:prstGeom xmlns:a="http://schemas.openxmlformats.org/drawingml/2006/main" prst="rect">
             <a:avLst/>
@@ -10151,8 +10151,8 @@
         </p:nvSpPr>
         <p:spPr>
           <a:xfrm xmlns:a="http://schemas.openxmlformats.org/drawingml/2006/main">
-            <a:off x="533400" y="2314575"/>
-            <a:ext cx="5400675" cy="1143000"/>
+            <a:off x="723900" y="2390775"/>
+            <a:ext cx="5215700" cy="1143000"/>
           </a:xfrm>
           <a:prstGeom xmlns:a="http://schemas.openxmlformats.org/drawingml/2006/main" prst="rect">
             <a:avLst/>
@@ -10239,8 +10239,8 @@
         </p:nvSpPr>
         <p:spPr>
           <a:xfrm xmlns:a="http://schemas.openxmlformats.org/drawingml/2006/main">
-            <a:off x="533400" y="3705225"/>
-            <a:ext cx="5372100" cy="733425"/>
+            <a:off x="723900" y="3705225"/>
+            <a:ext cx="5188077" cy="733425"/>
           </a:xfrm>
           <a:prstGeom xmlns:a="http://schemas.openxmlformats.org/drawingml/2006/main" prst="rect">
             <a:avLst/>
@@ -10300,8 +10300,8 @@
         </p:nvSpPr>
         <p:spPr>
           <a:xfrm xmlns:a="http://schemas.openxmlformats.org/drawingml/2006/main">
-            <a:off x="533400" y="4686300"/>
-            <a:ext cx="5410200" cy="666750"/>
+            <a:off x="723900" y="4638675"/>
+            <a:ext cx="5224939" cy="666750"/>
           </a:xfrm>
           <a:prstGeom xmlns:a="http://schemas.openxmlformats.org/drawingml/2006/main" prst="rect">
             <a:avLst/>
@@ -10361,8 +10361,8 @@
         </p:nvSpPr>
         <p:spPr>
           <a:xfrm xmlns:a="http://schemas.openxmlformats.org/drawingml/2006/main">
-            <a:off x="533400" y="5381625"/>
-            <a:ext cx="5410200" cy="609600"/>
+            <a:off x="723900" y="5229225"/>
+            <a:ext cx="5224939" cy="609600"/>
           </a:xfrm>
           <a:prstGeom xmlns:a="http://schemas.openxmlformats.org/drawingml/2006/main" prst="rect">
             <a:avLst/>
@@ -10415,13 +10415,13 @@
           <p:nvPr/>
         </p:nvPicPr>
         <p:blipFill>
-          <a:blip xmlns:r="http://schemas.openxmlformats.org/officeDocument/2006/relationships" xmlns:a="http://schemas.openxmlformats.org/drawingml/2006/main" r:embed="Re2efbea6cd2f4388"/>
+          <a:blip xmlns:r="http://schemas.openxmlformats.org/officeDocument/2006/relationships" xmlns:a="http://schemas.openxmlformats.org/drawingml/2006/main" r:embed="Rad63a4a9f7f545aa"/>
           <a:stretch xmlns:a="http://schemas.openxmlformats.org/drawingml/2006/main"/>
         </p:blipFill>
         <p:spPr>
           <a:xfrm xmlns:a="http://schemas.openxmlformats.org/drawingml/2006/main">
-            <a:off x="6400800" y="1760786"/>
-            <a:ext cx="5257800" cy="3717429"/>
+            <a:off x="6525768" y="1905000"/>
+            <a:ext cx="4942332" cy="3617214"/>
           </a:xfrm>
           <a:prstGeom xmlns:a="http://schemas.openxmlformats.org/drawingml/2006/main" prst="rect">
             <a:avLst/>
@@ -10444,8 +10444,8 @@
         </p:nvSpPr>
         <p:spPr>
           <a:xfrm xmlns:a="http://schemas.openxmlformats.org/drawingml/2006/main">
-            <a:off x="6400800" y="5657850"/>
-            <a:ext cx="5257800" cy="371475"/>
+            <a:off x="6525768" y="5636514"/>
+            <a:ext cx="5077778" cy="371475"/>
           </a:xfrm>
           <a:prstGeom xmlns:a="http://schemas.openxmlformats.org/drawingml/2006/main" prst="rect">
             <a:avLst/>
@@ -10505,8 +10505,8 @@
         </p:nvSpPr>
         <p:spPr>
           <a:xfrm xmlns:a="http://schemas.openxmlformats.org/drawingml/2006/main">
-            <a:off x="533400" y="6105525"/>
-            <a:ext cx="38100" cy="304800"/>
+            <a:off x="723900" y="6105525"/>
+            <a:ext cx="36767" cy="304800"/>
           </a:xfrm>
           <a:prstGeom xmlns:a="http://schemas.openxmlformats.org/drawingml/2006/main" prst="rect">
             <a:avLst/>
@@ -10535,8 +10535,8 @@
         </p:nvSpPr>
         <p:spPr>
           <a:xfrm xmlns:a="http://schemas.openxmlformats.org/drawingml/2006/main">
-            <a:off x="733425" y="6076950"/>
-            <a:ext cx="10858500" cy="428625"/>
+            <a:off x="917067" y="6076950"/>
+            <a:ext cx="10486644" cy="428625"/>
           </a:xfrm>
           <a:prstGeom xmlns:a="http://schemas.openxmlformats.org/drawingml/2006/main" prst="rect">
             <a:avLst/>
@@ -10596,8 +10596,8 @@
         </p:nvSpPr>
         <p:spPr>
           <a:xfrm xmlns:a="http://schemas.openxmlformats.org/drawingml/2006/main">
-            <a:off x="533400" y="6562725"/>
-            <a:ext cx="9429750" cy="190500"/>
+            <a:off x="723900" y="6562725"/>
+            <a:ext cx="9106853" cy="190500"/>
           </a:xfrm>
           <a:prstGeom xmlns:a="http://schemas.openxmlformats.org/drawingml/2006/main" prst="rect">
             <a:avLst/>
@@ -10657,8 +10657,8 @@
         </p:nvSpPr>
         <p:spPr>
           <a:xfrm xmlns:a="http://schemas.openxmlformats.org/drawingml/2006/main">
-            <a:off x="10706100" y="6562725"/>
-            <a:ext cx="952500" cy="190500"/>
+            <a:off x="10548176" y="6562725"/>
+            <a:ext cx="919925" cy="190500"/>
           </a:xfrm>
           <a:prstGeom xmlns:a="http://schemas.openxmlformats.org/drawingml/2006/main" prst="rect">
             <a:avLst/>
@@ -10711,12 +10711,12 @@
           <p:nvPr/>
         </p:nvPicPr>
         <p:blipFill>
-          <a:blip xmlns:r="http://schemas.openxmlformats.org/officeDocument/2006/relationships" xmlns:a="http://schemas.openxmlformats.org/drawingml/2006/main" r:embed="Ra13c32c66f9d4727"/>
+          <a:blip xmlns:r="http://schemas.openxmlformats.org/officeDocument/2006/relationships" xmlns:a="http://schemas.openxmlformats.org/drawingml/2006/main" r:embed="Rc6079849eb164038"/>
           <a:stretch xmlns:a="http://schemas.openxmlformats.org/drawingml/2006/main"/>
         </p:blipFill>
         <p:spPr>
           <a:xfrm xmlns:a="http://schemas.openxmlformats.org/drawingml/2006/main">
-            <a:off x="10248900" y="361950"/>
+            <a:off x="10058400" y="400050"/>
             <a:ext cx="1409700" cy="323850"/>
           </a:xfrm>
           <a:prstGeom xmlns:a="http://schemas.openxmlformats.org/drawingml/2006/main" prst="rect">
@@ -10769,8 +10769,8 @@
         </p:nvSpPr>
         <p:spPr>
           <a:xfrm xmlns:a="http://schemas.openxmlformats.org/drawingml/2006/main">
-            <a:off x="533400" y="409575"/>
-            <a:ext cx="9334500" cy="238125"/>
+            <a:off x="723900" y="447675"/>
+            <a:ext cx="9014841" cy="238125"/>
           </a:xfrm>
           <a:prstGeom xmlns:a="http://schemas.openxmlformats.org/drawingml/2006/main" prst="rect">
             <a:avLst/>
@@ -10830,8 +10830,8 @@
         </p:nvSpPr>
         <p:spPr>
           <a:xfrm xmlns:a="http://schemas.openxmlformats.org/drawingml/2006/main">
-            <a:off x="533400" y="828675"/>
-            <a:ext cx="5638800" cy="1762125"/>
+            <a:off x="723900" y="904875"/>
+            <a:ext cx="5445728" cy="1762125"/>
           </a:xfrm>
           <a:prstGeom xmlns:a="http://schemas.openxmlformats.org/drawingml/2006/main" prst="rect">
             <a:avLst/>
@@ -10918,8 +10918,8 @@
         </p:nvSpPr>
         <p:spPr>
           <a:xfrm xmlns:a="http://schemas.openxmlformats.org/drawingml/2006/main">
-            <a:off x="533400" y="2590800"/>
-            <a:ext cx="5172075" cy="1190625"/>
+            <a:off x="723900" y="2590800"/>
+            <a:ext cx="4994910" cy="1190625"/>
           </a:xfrm>
           <a:prstGeom xmlns:a="http://schemas.openxmlformats.org/drawingml/2006/main" prst="rect">
             <a:avLst/>
@@ -11006,8 +11006,8 @@
         </p:nvSpPr>
         <p:spPr>
           <a:xfrm xmlns:a="http://schemas.openxmlformats.org/drawingml/2006/main">
-            <a:off x="6562725" y="2209800"/>
-            <a:ext cx="2381250" cy="809625"/>
+            <a:off x="6562725" y="2133600"/>
+            <a:ext cx="2190750" cy="809625"/>
           </a:xfrm>
           <a:prstGeom xmlns:a="http://schemas.openxmlformats.org/drawingml/2006/main" prst="rect">
             <a:avLst/>
@@ -11087,14 +11087,14 @@
           <p:nvPr/>
         </p:nvPicPr>
         <p:blipFill>
-          <a:blip xmlns:r="http://schemas.openxmlformats.org/officeDocument/2006/relationships" xmlns:a="http://schemas.openxmlformats.org/drawingml/2006/main" r:embed="R19da18e30bb947d6"/>
+          <a:blip xmlns:r="http://schemas.openxmlformats.org/officeDocument/2006/relationships" xmlns:a="http://schemas.openxmlformats.org/drawingml/2006/main" r:embed="Rfb299285b68e46d5"/>
           <a:srcRect xmlns:a="http://schemas.openxmlformats.org/drawingml/2006/main" l="0" t="0" r="0" b="0"/>
           <a:stretch xmlns:a="http://schemas.openxmlformats.org/drawingml/2006/main"/>
         </p:blipFill>
         <p:spPr>
           <a:xfrm xmlns:a="http://schemas.openxmlformats.org/drawingml/2006/main">
-            <a:off x="6562725" y="3114675"/>
-            <a:ext cx="2343150" cy="2343150"/>
+            <a:off x="6562725" y="3076575"/>
+            <a:ext cx="2190750" cy="2190750"/>
           </a:xfrm>
           <a:prstGeom xmlns:a="http://schemas.openxmlformats.org/drawingml/2006/main" prst="rect">
             <a:avLst/>
@@ -11117,8 +11117,8 @@
         </p:nvSpPr>
         <p:spPr>
           <a:xfrm xmlns:a="http://schemas.openxmlformats.org/drawingml/2006/main">
-            <a:off x="6562725" y="5619750"/>
-            <a:ext cx="2400300" cy="657225"/>
+            <a:off x="6562725" y="5467350"/>
+            <a:ext cx="2190750" cy="657225"/>
           </a:xfrm>
           <a:prstGeom xmlns:a="http://schemas.openxmlformats.org/drawingml/2006/main" prst="rect">
             <a:avLst/>
@@ -11156,7 +11156,7 @@
                 <a:latin typeface="Arial"/>
                 <a:ea typeface="Arial"/>
                 <a:cs typeface="Arial"/>
-                <a:hlinkClick xmlns:r="http://schemas.openxmlformats.org/officeDocument/2006/relationships" r:id="R2167a69a8026485f"/>
+                <a:hlinkClick xmlns:r="http://schemas.openxmlformats.org/officeDocument/2006/relationships" r:id="Rd058010612294182"/>
               </a:rPr>
               <a:t>Online slides ·</a:t>
             </a:r>
@@ -11184,7 +11184,7 @@
                 <a:latin typeface="Arial"/>
                 <a:ea typeface="Arial"/>
                 <a:cs typeface="Arial"/>
-                <a:hlinkClick xmlns:r="http://schemas.openxmlformats.org/officeDocument/2006/relationships" r:id="Rd3713aa74cfb4e6a"/>
+                <a:hlinkClick xmlns:r="http://schemas.openxmlformats.org/officeDocument/2006/relationships" r:id="R643af09dd7c14d1b"/>
               </a:rPr>
               <a:t>current version</a:t>
             </a:r>
@@ -11207,8 +11207,8 @@
         </p:nvSpPr>
         <p:spPr>
           <a:xfrm xmlns:a="http://schemas.openxmlformats.org/drawingml/2006/main">
-            <a:off x="9229725" y="2209800"/>
-            <a:ext cx="2381250" cy="809625"/>
+            <a:off x="9277350" y="2133600"/>
+            <a:ext cx="2190750" cy="809625"/>
           </a:xfrm>
           <a:prstGeom xmlns:a="http://schemas.openxmlformats.org/drawingml/2006/main" prst="rect">
             <a:avLst/>
@@ -11288,14 +11288,14 @@
           <p:nvPr/>
         </p:nvPicPr>
         <p:blipFill>
-          <a:blip xmlns:r="http://schemas.openxmlformats.org/officeDocument/2006/relationships" xmlns:a="http://schemas.openxmlformats.org/drawingml/2006/main" r:embed="Rad79f1b2ad0145d9"/>
+          <a:blip xmlns:r="http://schemas.openxmlformats.org/officeDocument/2006/relationships" xmlns:a="http://schemas.openxmlformats.org/drawingml/2006/main" r:embed="R93e81eda734d4e8f"/>
           <a:srcRect xmlns:a="http://schemas.openxmlformats.org/drawingml/2006/main" l="0" t="0" r="0" b="0"/>
           <a:stretch xmlns:a="http://schemas.openxmlformats.org/drawingml/2006/main"/>
         </p:blipFill>
         <p:spPr>
           <a:xfrm xmlns:a="http://schemas.openxmlformats.org/drawingml/2006/main">
-            <a:off x="9229725" y="3114675"/>
-            <a:ext cx="2343150" cy="2343150"/>
+            <a:off x="9277350" y="3076575"/>
+            <a:ext cx="2190750" cy="2190750"/>
           </a:xfrm>
           <a:prstGeom xmlns:a="http://schemas.openxmlformats.org/drawingml/2006/main" prst="rect">
             <a:avLst/>
@@ -11318,8 +11318,8 @@
         </p:nvSpPr>
         <p:spPr>
           <a:xfrm xmlns:a="http://schemas.openxmlformats.org/drawingml/2006/main">
-            <a:off x="9229725" y="5619750"/>
-            <a:ext cx="2400300" cy="657225"/>
+            <a:off x="9277350" y="5467350"/>
+            <a:ext cx="2190750" cy="657225"/>
           </a:xfrm>
           <a:prstGeom xmlns:a="http://schemas.openxmlformats.org/drawingml/2006/main" prst="rect">
             <a:avLst/>
@@ -11357,7 +11357,7 @@
                 <a:latin typeface="Arial"/>
                 <a:ea typeface="Arial"/>
                 <a:cs typeface="Arial"/>
-                <a:hlinkClick xmlns:r="http://schemas.openxmlformats.org/officeDocument/2006/relationships" r:id="R82627b9deffa40b6"/>
+                <a:hlinkClick xmlns:r="http://schemas.openxmlformats.org/officeDocument/2006/relationships" r:id="R7dd6633eb9eb498b"/>
               </a:rPr>
               <a:t>UNESCO submission ·</a:t>
             </a:r>
@@ -11385,7 +11385,7 @@
                 <a:latin typeface="Arial"/>
                 <a:ea typeface="Arial"/>
                 <a:cs typeface="Arial"/>
-                <a:hlinkClick xmlns:r="http://schemas.openxmlformats.org/officeDocument/2006/relationships" r:id="R620ae00bc0f949b6"/>
+                <a:hlinkClick xmlns:r="http://schemas.openxmlformats.org/officeDocument/2006/relationships" r:id="R996d582141234ebf"/>
               </a:rPr>
               <a:t>studies and evidence</a:t>
             </a:r>
@@ -11408,8 +11408,8 @@
         </p:nvSpPr>
         <p:spPr>
           <a:xfrm xmlns:a="http://schemas.openxmlformats.org/drawingml/2006/main">
-            <a:off x="533400" y="4371975"/>
-            <a:ext cx="5343525" cy="781050"/>
+            <a:off x="723900" y="4276725"/>
+            <a:ext cx="5160550" cy="781050"/>
           </a:xfrm>
           <a:prstGeom xmlns:a="http://schemas.openxmlformats.org/drawingml/2006/main" prst="rect">
             <a:avLst/>
@@ -11496,8 +11496,8 @@
         </p:nvSpPr>
         <p:spPr>
           <a:xfrm xmlns:a="http://schemas.openxmlformats.org/drawingml/2006/main">
-            <a:off x="533400" y="5286375"/>
-            <a:ext cx="5267325" cy="533400"/>
+            <a:off x="723900" y="5172075"/>
+            <a:ext cx="5086921" cy="533400"/>
           </a:xfrm>
           <a:prstGeom xmlns:a="http://schemas.openxmlformats.org/drawingml/2006/main" prst="rect">
             <a:avLst/>
@@ -11535,7 +11535,7 @@
                 <a:latin typeface="Arial"/>
                 <a:ea typeface="Arial"/>
                 <a:cs typeface="Arial"/>
-                <a:hlinkClick xmlns:r="http://schemas.openxmlformats.org/officeDocument/2006/relationships" r:id="R5feee081b5594d70"/>
+                <a:hlinkClick xmlns:r="http://schemas.openxmlformats.org/officeDocument/2006/relationships" r:id="R2e12bcf3351346cf"/>
               </a:rPr>
               <a:t>tony@cocorobo.cc</a:t>
             </a:r>
@@ -11558,8 +11558,8 @@
         </p:nvSpPr>
         <p:spPr>
           <a:xfrm xmlns:a="http://schemas.openxmlformats.org/drawingml/2006/main">
-            <a:off x="533400" y="6296025"/>
-            <a:ext cx="11125200" cy="276225"/>
+            <a:off x="723900" y="6257925"/>
+            <a:ext cx="10744200" cy="276225"/>
           </a:xfrm>
           <a:prstGeom xmlns:a="http://schemas.openxmlformats.org/drawingml/2006/main" prst="rect">
             <a:avLst/>
@@ -11612,12 +11612,12 @@
           <p:nvPr/>
         </p:nvPicPr>
         <p:blipFill>
-          <a:blip xmlns:r="http://schemas.openxmlformats.org/officeDocument/2006/relationships" xmlns:a="http://schemas.openxmlformats.org/drawingml/2006/main" r:embed="R1aadeb96c00b41f2"/>
+          <a:blip xmlns:r="http://schemas.openxmlformats.org/officeDocument/2006/relationships" xmlns:a="http://schemas.openxmlformats.org/drawingml/2006/main" r:embed="R97edb7b07dc742e0"/>
           <a:stretch xmlns:a="http://schemas.openxmlformats.org/drawingml/2006/main"/>
         </p:blipFill>
         <p:spPr>
           <a:xfrm xmlns:a="http://schemas.openxmlformats.org/drawingml/2006/main">
-            <a:off x="10248900" y="361950"/>
+            <a:off x="10058400" y="400050"/>
             <a:ext cx="1409700" cy="323850"/>
           </a:xfrm>
           <a:prstGeom xmlns:a="http://schemas.openxmlformats.org/drawingml/2006/main" prst="rect">
@@ -11670,8 +11670,8 @@
         </p:nvSpPr>
         <p:spPr>
           <a:xfrm xmlns:a="http://schemas.openxmlformats.org/drawingml/2006/main">
-            <a:off x="533400" y="409575"/>
-            <a:ext cx="9334500" cy="238125"/>
+            <a:off x="723900" y="447675"/>
+            <a:ext cx="9014841" cy="238125"/>
           </a:xfrm>
           <a:prstGeom xmlns:a="http://schemas.openxmlformats.org/drawingml/2006/main" prst="rect">
             <a:avLst/>
@@ -11731,8 +11731,8 @@
         </p:nvSpPr>
         <p:spPr>
           <a:xfrm xmlns:a="http://schemas.openxmlformats.org/drawingml/2006/main">
-            <a:off x="533400" y="828675"/>
-            <a:ext cx="11125200" cy="1047750"/>
+            <a:off x="723900" y="904875"/>
+            <a:ext cx="10744200" cy="1047750"/>
           </a:xfrm>
           <a:prstGeom xmlns:a="http://schemas.openxmlformats.org/drawingml/2006/main" prst="rect">
             <a:avLst/>
@@ -11792,8 +11792,8 @@
         </p:nvSpPr>
         <p:spPr>
           <a:xfrm xmlns:a="http://schemas.openxmlformats.org/drawingml/2006/main">
-            <a:off x="533400" y="1647825"/>
-            <a:ext cx="11125200" cy="552450"/>
+            <a:off x="723900" y="1724025"/>
+            <a:ext cx="10744200" cy="552450"/>
           </a:xfrm>
           <a:prstGeom xmlns:a="http://schemas.openxmlformats.org/drawingml/2006/main" prst="rect">
             <a:avLst/>
@@ -11853,8 +11853,8 @@
         </p:nvSpPr>
         <p:spPr>
           <a:xfrm xmlns:a="http://schemas.openxmlformats.org/drawingml/2006/main">
-            <a:off x="533400" y="2257425"/>
-            <a:ext cx="10953750" cy="333375"/>
+            <a:off x="723900" y="2333625"/>
+            <a:ext cx="10578655" cy="333375"/>
           </a:xfrm>
           <a:prstGeom xmlns:a="http://schemas.openxmlformats.org/drawingml/2006/main" prst="rect">
             <a:avLst/>
@@ -11914,8 +11914,8 @@
         </p:nvSpPr>
         <p:spPr>
           <a:xfrm xmlns:a="http://schemas.openxmlformats.org/drawingml/2006/main">
-            <a:off x="533400" y="2790825"/>
-            <a:ext cx="5467350" cy="352425"/>
+            <a:off x="723900" y="2876550"/>
+            <a:ext cx="5280089" cy="352425"/>
           </a:xfrm>
           <a:prstGeom xmlns:a="http://schemas.openxmlformats.org/drawingml/2006/main" prst="rect">
             <a:avLst/>
@@ -11975,8 +11975,8 @@
         </p:nvSpPr>
         <p:spPr>
           <a:xfrm xmlns:a="http://schemas.openxmlformats.org/drawingml/2006/main">
-            <a:off x="533400" y="3143250"/>
-            <a:ext cx="5467350" cy="752475"/>
+            <a:off x="723900" y="3228975"/>
+            <a:ext cx="5280089" cy="752475"/>
           </a:xfrm>
           <a:prstGeom xmlns:a="http://schemas.openxmlformats.org/drawingml/2006/main" prst="rect">
             <a:avLst/>
@@ -12036,8 +12036,8 @@
         </p:nvSpPr>
         <p:spPr>
           <a:xfrm xmlns:a="http://schemas.openxmlformats.org/drawingml/2006/main">
-            <a:off x="533400" y="3743325"/>
-            <a:ext cx="5467350" cy="352425"/>
+            <a:off x="723900" y="3829050"/>
+            <a:ext cx="5280089" cy="352425"/>
           </a:xfrm>
           <a:prstGeom xmlns:a="http://schemas.openxmlformats.org/drawingml/2006/main" prst="rect">
             <a:avLst/>
@@ -12097,8 +12097,8 @@
         </p:nvSpPr>
         <p:spPr>
           <a:xfrm xmlns:a="http://schemas.openxmlformats.org/drawingml/2006/main">
-            <a:off x="533400" y="4095750"/>
-            <a:ext cx="5467350" cy="752475"/>
+            <a:off x="723900" y="4181475"/>
+            <a:ext cx="5280089" cy="752475"/>
           </a:xfrm>
           <a:prstGeom xmlns:a="http://schemas.openxmlformats.org/drawingml/2006/main" prst="rect">
             <a:avLst/>
@@ -12158,8 +12158,8 @@
         </p:nvSpPr>
         <p:spPr>
           <a:xfrm xmlns:a="http://schemas.openxmlformats.org/drawingml/2006/main">
-            <a:off x="533400" y="4867275"/>
-            <a:ext cx="5467350" cy="352425"/>
+            <a:off x="723900" y="4867275"/>
+            <a:ext cx="5280089" cy="352425"/>
           </a:xfrm>
           <a:prstGeom xmlns:a="http://schemas.openxmlformats.org/drawingml/2006/main" prst="rect">
             <a:avLst/>
@@ -12219,8 +12219,8 @@
         </p:nvSpPr>
         <p:spPr>
           <a:xfrm xmlns:a="http://schemas.openxmlformats.org/drawingml/2006/main">
-            <a:off x="533400" y="5219700"/>
-            <a:ext cx="5467350" cy="752475"/>
+            <a:off x="723900" y="5219700"/>
+            <a:ext cx="5280089" cy="752475"/>
           </a:xfrm>
           <a:prstGeom xmlns:a="http://schemas.openxmlformats.org/drawingml/2006/main" prst="rect">
             <a:avLst/>
@@ -12273,14 +12273,14 @@
           <p:nvPr/>
         </p:nvPicPr>
         <p:blipFill>
-          <a:blip xmlns:r="http://schemas.openxmlformats.org/officeDocument/2006/relationships" xmlns:a="http://schemas.openxmlformats.org/drawingml/2006/main" r:embed="R65ce07bab6374768"/>
+          <a:blip xmlns:r="http://schemas.openxmlformats.org/officeDocument/2006/relationships" xmlns:a="http://schemas.openxmlformats.org/drawingml/2006/main" r:embed="R5b786d68b2074caf"/>
           <a:srcRect xmlns:a="http://schemas.openxmlformats.org/drawingml/2006/main" l="0" t="2370" r="0" b="2370"/>
           <a:stretch xmlns:a="http://schemas.openxmlformats.org/drawingml/2006/main"/>
         </p:blipFill>
         <p:spPr>
           <a:xfrm xmlns:a="http://schemas.openxmlformats.org/drawingml/2006/main">
-            <a:off x="6534150" y="2867025"/>
-            <a:ext cx="5124450" cy="2733675"/>
+            <a:off x="6651117" y="2924175"/>
+            <a:ext cx="4816983" cy="2569654"/>
           </a:xfrm>
           <a:prstGeom xmlns:a="http://schemas.openxmlformats.org/drawingml/2006/main" prst="rect">
             <a:avLst/>
@@ -12303,8 +12303,8 @@
         </p:nvSpPr>
         <p:spPr>
           <a:xfrm xmlns:a="http://schemas.openxmlformats.org/drawingml/2006/main">
-            <a:off x="6534150" y="5695950"/>
-            <a:ext cx="5124450" cy="247650"/>
+            <a:off x="6651117" y="5608130"/>
+            <a:ext cx="4949000" cy="247650"/>
           </a:xfrm>
           <a:prstGeom xmlns:a="http://schemas.openxmlformats.org/drawingml/2006/main" prst="rect">
             <a:avLst/>
@@ -12364,8 +12364,8 @@
         </p:nvSpPr>
         <p:spPr>
           <a:xfrm xmlns:a="http://schemas.openxmlformats.org/drawingml/2006/main">
-            <a:off x="533400" y="6105525"/>
-            <a:ext cx="38100" cy="304800"/>
+            <a:off x="723900" y="6105525"/>
+            <a:ext cx="36767" cy="304800"/>
           </a:xfrm>
           <a:prstGeom xmlns:a="http://schemas.openxmlformats.org/drawingml/2006/main" prst="rect">
             <a:avLst/>
@@ -12394,8 +12394,8 @@
         </p:nvSpPr>
         <p:spPr>
           <a:xfrm xmlns:a="http://schemas.openxmlformats.org/drawingml/2006/main">
-            <a:off x="733425" y="6076950"/>
-            <a:ext cx="10858500" cy="428625"/>
+            <a:off x="917067" y="6076950"/>
+            <a:ext cx="10486644" cy="428625"/>
           </a:xfrm>
           <a:prstGeom xmlns:a="http://schemas.openxmlformats.org/drawingml/2006/main" prst="rect">
             <a:avLst/>
@@ -12455,8 +12455,8 @@
         </p:nvSpPr>
         <p:spPr>
           <a:xfrm xmlns:a="http://schemas.openxmlformats.org/drawingml/2006/main">
-            <a:off x="533400" y="6562725"/>
-            <a:ext cx="9429750" cy="190500"/>
+            <a:off x="723900" y="6562725"/>
+            <a:ext cx="9106853" cy="190500"/>
           </a:xfrm>
           <a:prstGeom xmlns:a="http://schemas.openxmlformats.org/drawingml/2006/main" prst="rect">
             <a:avLst/>
@@ -12516,8 +12516,8 @@
         </p:nvSpPr>
         <p:spPr>
           <a:xfrm xmlns:a="http://schemas.openxmlformats.org/drawingml/2006/main">
-            <a:off x="10706100" y="6562725"/>
-            <a:ext cx="952500" cy="190500"/>
+            <a:off x="10548176" y="6562725"/>
+            <a:ext cx="919925" cy="190500"/>
           </a:xfrm>
           <a:prstGeom xmlns:a="http://schemas.openxmlformats.org/drawingml/2006/main" prst="rect">
             <a:avLst/>
@@ -12570,12 +12570,12 @@
           <p:nvPr/>
         </p:nvPicPr>
         <p:blipFill>
-          <a:blip xmlns:r="http://schemas.openxmlformats.org/officeDocument/2006/relationships" xmlns:a="http://schemas.openxmlformats.org/drawingml/2006/main" r:embed="R020ff23c09694faf"/>
+          <a:blip xmlns:r="http://schemas.openxmlformats.org/officeDocument/2006/relationships" xmlns:a="http://schemas.openxmlformats.org/drawingml/2006/main" r:embed="R825805f21bed426a"/>
           <a:stretch xmlns:a="http://schemas.openxmlformats.org/drawingml/2006/main"/>
         </p:blipFill>
         <p:spPr>
           <a:xfrm xmlns:a="http://schemas.openxmlformats.org/drawingml/2006/main">
-            <a:off x="10248900" y="361950"/>
+            <a:off x="10058400" y="400050"/>
             <a:ext cx="1409700" cy="323850"/>
           </a:xfrm>
           <a:prstGeom xmlns:a="http://schemas.openxmlformats.org/drawingml/2006/main" prst="rect">
@@ -12628,8 +12628,8 @@
         </p:nvSpPr>
         <p:spPr>
           <a:xfrm xmlns:a="http://schemas.openxmlformats.org/drawingml/2006/main">
-            <a:off x="533400" y="409575"/>
-            <a:ext cx="9334500" cy="238125"/>
+            <a:off x="723900" y="447675"/>
+            <a:ext cx="9014841" cy="238125"/>
           </a:xfrm>
           <a:prstGeom xmlns:a="http://schemas.openxmlformats.org/drawingml/2006/main" prst="rect">
             <a:avLst/>
@@ -12689,8 +12689,8 @@
         </p:nvSpPr>
         <p:spPr>
           <a:xfrm xmlns:a="http://schemas.openxmlformats.org/drawingml/2006/main">
-            <a:off x="533400" y="828675"/>
-            <a:ext cx="11125200" cy="1047750"/>
+            <a:off x="723900" y="904875"/>
+            <a:ext cx="10744200" cy="1047750"/>
           </a:xfrm>
           <a:prstGeom xmlns:a="http://schemas.openxmlformats.org/drawingml/2006/main" prst="rect">
             <a:avLst/>
@@ -12750,8 +12750,8 @@
         </p:nvSpPr>
         <p:spPr>
           <a:xfrm xmlns:a="http://schemas.openxmlformats.org/drawingml/2006/main">
-            <a:off x="533400" y="1743075"/>
-            <a:ext cx="10668000" cy="838200"/>
+            <a:off x="723900" y="1743075"/>
+            <a:ext cx="10302621" cy="838200"/>
           </a:xfrm>
           <a:prstGeom xmlns:a="http://schemas.openxmlformats.org/drawingml/2006/main" prst="rect">
             <a:avLst/>
@@ -12811,8 +12811,8 @@
         </p:nvSpPr>
         <p:spPr>
           <a:xfrm xmlns:a="http://schemas.openxmlformats.org/drawingml/2006/main">
-            <a:off x="533400" y="2819400"/>
-            <a:ext cx="5219700" cy="28575"/>
+            <a:off x="723900" y="2819400"/>
+            <a:ext cx="5040916" cy="28575"/>
           </a:xfrm>
           <a:prstGeom xmlns:a="http://schemas.openxmlformats.org/drawingml/2006/main" prst="rect">
             <a:avLst/>
@@ -12841,8 +12841,8 @@
         </p:nvSpPr>
         <p:spPr>
           <a:xfrm xmlns:a="http://schemas.openxmlformats.org/drawingml/2006/main">
-            <a:off x="533400" y="3048000"/>
-            <a:ext cx="5105400" cy="590550"/>
+            <a:off x="723900" y="3048000"/>
+            <a:ext cx="4930521" cy="590550"/>
           </a:xfrm>
           <a:prstGeom xmlns:a="http://schemas.openxmlformats.org/drawingml/2006/main" prst="rect">
             <a:avLst/>
@@ -12902,8 +12902,8 @@
         </p:nvSpPr>
         <p:spPr>
           <a:xfrm xmlns:a="http://schemas.openxmlformats.org/drawingml/2006/main">
-            <a:off x="533400" y="3638550"/>
-            <a:ext cx="5105400" cy="1143000"/>
+            <a:off x="723900" y="3638550"/>
+            <a:ext cx="4930521" cy="1143000"/>
           </a:xfrm>
           <a:prstGeom xmlns:a="http://schemas.openxmlformats.org/drawingml/2006/main" prst="rect">
             <a:avLst/>
@@ -12963,8 +12963,8 @@
         </p:nvSpPr>
         <p:spPr>
           <a:xfrm xmlns:a="http://schemas.openxmlformats.org/drawingml/2006/main">
-            <a:off x="6296025" y="2819400"/>
-            <a:ext cx="5219700" cy="28575"/>
+            <a:off x="6289167" y="2819400"/>
+            <a:ext cx="5040916" cy="28575"/>
           </a:xfrm>
           <a:prstGeom xmlns:a="http://schemas.openxmlformats.org/drawingml/2006/main" prst="rect">
             <a:avLst/>
@@ -12993,8 +12993,8 @@
         </p:nvSpPr>
         <p:spPr>
           <a:xfrm xmlns:a="http://schemas.openxmlformats.org/drawingml/2006/main">
-            <a:off x="6296025" y="3048000"/>
-            <a:ext cx="5105400" cy="590550"/>
+            <a:off x="6289167" y="3048000"/>
+            <a:ext cx="4930521" cy="590550"/>
           </a:xfrm>
           <a:prstGeom xmlns:a="http://schemas.openxmlformats.org/drawingml/2006/main" prst="rect">
             <a:avLst/>
@@ -13054,8 +13054,8 @@
         </p:nvSpPr>
         <p:spPr>
           <a:xfrm xmlns:a="http://schemas.openxmlformats.org/drawingml/2006/main">
-            <a:off x="6296025" y="3638550"/>
-            <a:ext cx="5105400" cy="1143000"/>
+            <a:off x="6289167" y="3638550"/>
+            <a:ext cx="4930521" cy="1143000"/>
           </a:xfrm>
           <a:prstGeom xmlns:a="http://schemas.openxmlformats.org/drawingml/2006/main" prst="rect">
             <a:avLst/>
@@ -13115,8 +13115,8 @@
         </p:nvSpPr>
         <p:spPr>
           <a:xfrm xmlns:a="http://schemas.openxmlformats.org/drawingml/2006/main">
-            <a:off x="533400" y="5010150"/>
-            <a:ext cx="2914650" cy="1019175"/>
+            <a:off x="723900" y="4914900"/>
+            <a:ext cx="2814828" cy="1019175"/>
           </a:xfrm>
           <a:prstGeom xmlns:a="http://schemas.openxmlformats.org/drawingml/2006/main" prst="rect">
             <a:avLst/>
@@ -13176,8 +13176,8 @@
         </p:nvSpPr>
         <p:spPr>
           <a:xfrm xmlns:a="http://schemas.openxmlformats.org/drawingml/2006/main">
-            <a:off x="3733800" y="5314950"/>
-            <a:ext cx="7572375" cy="781050"/>
+            <a:off x="3814667" y="5219700"/>
+            <a:ext cx="7313009" cy="781050"/>
           </a:xfrm>
           <a:prstGeom xmlns:a="http://schemas.openxmlformats.org/drawingml/2006/main" prst="rect">
             <a:avLst/>
@@ -13264,8 +13264,8 @@
         </p:nvSpPr>
         <p:spPr>
           <a:xfrm xmlns:a="http://schemas.openxmlformats.org/drawingml/2006/main">
-            <a:off x="533400" y="6181725"/>
-            <a:ext cx="11125200" cy="285750"/>
+            <a:off x="723900" y="6076950"/>
+            <a:ext cx="10744200" cy="285750"/>
           </a:xfrm>
           <a:prstGeom xmlns:a="http://schemas.openxmlformats.org/drawingml/2006/main" prst="rect">
             <a:avLst/>
@@ -13325,8 +13325,8 @@
         </p:nvSpPr>
         <p:spPr>
           <a:xfrm xmlns:a="http://schemas.openxmlformats.org/drawingml/2006/main">
-            <a:off x="533400" y="6562725"/>
-            <a:ext cx="9429750" cy="190500"/>
+            <a:off x="723900" y="6562725"/>
+            <a:ext cx="9106853" cy="190500"/>
           </a:xfrm>
           <a:prstGeom xmlns:a="http://schemas.openxmlformats.org/drawingml/2006/main" prst="rect">
             <a:avLst/>
@@ -13386,8 +13386,8 @@
         </p:nvSpPr>
         <p:spPr>
           <a:xfrm xmlns:a="http://schemas.openxmlformats.org/drawingml/2006/main">
-            <a:off x="10706100" y="6562725"/>
-            <a:ext cx="952500" cy="190500"/>
+            <a:off x="10548176" y="6562725"/>
+            <a:ext cx="919925" cy="190500"/>
           </a:xfrm>
           <a:prstGeom xmlns:a="http://schemas.openxmlformats.org/drawingml/2006/main" prst="rect">
             <a:avLst/>
@@ -13440,12 +13440,12 @@
           <p:nvPr/>
         </p:nvPicPr>
         <p:blipFill>
-          <a:blip xmlns:r="http://schemas.openxmlformats.org/officeDocument/2006/relationships" xmlns:a="http://schemas.openxmlformats.org/drawingml/2006/main" r:embed="R87e10597b03946dc"/>
+          <a:blip xmlns:r="http://schemas.openxmlformats.org/officeDocument/2006/relationships" xmlns:a="http://schemas.openxmlformats.org/drawingml/2006/main" r:embed="Rd7565f86ee274eb0"/>
           <a:stretch xmlns:a="http://schemas.openxmlformats.org/drawingml/2006/main"/>
         </p:blipFill>
         <p:spPr>
           <a:xfrm xmlns:a="http://schemas.openxmlformats.org/drawingml/2006/main">
-            <a:off x="10248900" y="361950"/>
+            <a:off x="10058400" y="400050"/>
             <a:ext cx="1409700" cy="323850"/>
           </a:xfrm>
           <a:prstGeom xmlns:a="http://schemas.openxmlformats.org/drawingml/2006/main" prst="rect">
@@ -13498,8 +13498,8 @@
         </p:nvSpPr>
         <p:spPr>
           <a:xfrm xmlns:a="http://schemas.openxmlformats.org/drawingml/2006/main">
-            <a:off x="533400" y="409575"/>
-            <a:ext cx="9334500" cy="238125"/>
+            <a:off x="723900" y="447675"/>
+            <a:ext cx="9014841" cy="238125"/>
           </a:xfrm>
           <a:prstGeom xmlns:a="http://schemas.openxmlformats.org/drawingml/2006/main" prst="rect">
             <a:avLst/>
@@ -13559,8 +13559,8 @@
         </p:nvSpPr>
         <p:spPr>
           <a:xfrm xmlns:a="http://schemas.openxmlformats.org/drawingml/2006/main">
-            <a:off x="533400" y="828675"/>
-            <a:ext cx="10763250" cy="1047750"/>
+            <a:off x="723900" y="904875"/>
+            <a:ext cx="10394633" cy="1047750"/>
           </a:xfrm>
           <a:prstGeom xmlns:a="http://schemas.openxmlformats.org/drawingml/2006/main" prst="rect">
             <a:avLst/>
@@ -13647,8 +13647,8 @@
         </p:nvSpPr>
         <p:spPr>
           <a:xfrm xmlns:a="http://schemas.openxmlformats.org/drawingml/2006/main">
-            <a:off x="533400" y="2038350"/>
-            <a:ext cx="10953750" cy="466725"/>
+            <a:off x="723900" y="2114550"/>
+            <a:ext cx="10578655" cy="466725"/>
           </a:xfrm>
           <a:prstGeom xmlns:a="http://schemas.openxmlformats.org/drawingml/2006/main" prst="rect">
             <a:avLst/>
@@ -13708,8 +13708,8 @@
         </p:nvSpPr>
         <p:spPr>
           <a:xfrm xmlns:a="http://schemas.openxmlformats.org/drawingml/2006/main">
-            <a:off x="533400" y="2457450"/>
-            <a:ext cx="3810000" cy="523875"/>
+            <a:off x="723900" y="2590800"/>
+            <a:ext cx="3679508" cy="523875"/>
           </a:xfrm>
           <a:prstGeom xmlns:a="http://schemas.openxmlformats.org/drawingml/2006/main" prst="rect">
             <a:avLst/>
@@ -13769,8 +13769,8 @@
         </p:nvSpPr>
         <p:spPr>
           <a:xfrm xmlns:a="http://schemas.openxmlformats.org/drawingml/2006/main">
-            <a:off x="533400" y="5524500"/>
-            <a:ext cx="5219700" cy="457200"/>
+            <a:off x="723900" y="5447062"/>
+            <a:ext cx="5238750" cy="457200"/>
           </a:xfrm>
           <a:prstGeom xmlns:a="http://schemas.openxmlformats.org/drawingml/2006/main" prst="rect">
             <a:avLst/>
@@ -13808,7 +13808,7 @@
                 <a:latin typeface="Arial"/>
                 <a:ea typeface="Arial"/>
                 <a:cs typeface="Arial"/>
-                <a:hlinkClick xmlns:r="http://schemas.openxmlformats.org/officeDocument/2006/relationships" r:id="R906e47a8de8a433c"/>
+                <a:hlinkClick xmlns:r="http://schemas.openxmlformats.org/officeDocument/2006/relationships" r:id="Ra355dacc9ce84cbb"/>
               </a:rPr>
               <a:t>Guangdong Department of Education</a:t>
             </a:r>
@@ -13836,7 +13836,7 @@
                 <a:latin typeface="Arial"/>
                 <a:ea typeface="Arial"/>
                 <a:cs typeface="Arial"/>
-                <a:hlinkClick xmlns:r="http://schemas.openxmlformats.org/officeDocument/2006/relationships" r:id="Rf11f1b21d6db43f9"/>
+                <a:hlinkClick xmlns:r="http://schemas.openxmlformats.org/officeDocument/2006/relationships" r:id="Reebf396394684cf4"/>
               </a:rPr>
               <a:t>9 April 2025 · Trial documents</a:t>
             </a:r>
@@ -13859,8 +13859,8 @@
         </p:nvSpPr>
         <p:spPr>
           <a:xfrm xmlns:a="http://schemas.openxmlformats.org/drawingml/2006/main">
-            <a:off x="6200775" y="2724150"/>
-            <a:ext cx="5457825" cy="381000"/>
+            <a:off x="6197156" y="2724150"/>
+            <a:ext cx="5270945" cy="381000"/>
           </a:xfrm>
           <a:prstGeom xmlns:a="http://schemas.openxmlformats.org/drawingml/2006/main" prst="rect">
             <a:avLst/>
@@ -13920,8 +13920,8 @@
         </p:nvSpPr>
         <p:spPr>
           <a:xfrm xmlns:a="http://schemas.openxmlformats.org/drawingml/2006/main">
-            <a:off x="6200775" y="3105150"/>
-            <a:ext cx="5457825" cy="638175"/>
+            <a:off x="6197156" y="3105150"/>
+            <a:ext cx="5270945" cy="638175"/>
           </a:xfrm>
           <a:prstGeom xmlns:a="http://schemas.openxmlformats.org/drawingml/2006/main" prst="rect">
             <a:avLst/>
@@ -13981,8 +13981,8 @@
         </p:nvSpPr>
         <p:spPr>
           <a:xfrm xmlns:a="http://schemas.openxmlformats.org/drawingml/2006/main">
-            <a:off x="6200775" y="3781425"/>
-            <a:ext cx="5457825" cy="381000"/>
+            <a:off x="6197156" y="3781425"/>
+            <a:ext cx="5270945" cy="381000"/>
           </a:xfrm>
           <a:prstGeom xmlns:a="http://schemas.openxmlformats.org/drawingml/2006/main" prst="rect">
             <a:avLst/>
@@ -14042,8 +14042,8 @@
         </p:nvSpPr>
         <p:spPr>
           <a:xfrm xmlns:a="http://schemas.openxmlformats.org/drawingml/2006/main">
-            <a:off x="6200775" y="4162425"/>
-            <a:ext cx="5457825" cy="638175"/>
+            <a:off x="6197156" y="4162425"/>
+            <a:ext cx="5270945" cy="638175"/>
           </a:xfrm>
           <a:prstGeom xmlns:a="http://schemas.openxmlformats.org/drawingml/2006/main" prst="rect">
             <a:avLst/>
@@ -14103,8 +14103,8 @@
         </p:nvSpPr>
         <p:spPr>
           <a:xfrm xmlns:a="http://schemas.openxmlformats.org/drawingml/2006/main">
-            <a:off x="6200775" y="4838700"/>
-            <a:ext cx="5457825" cy="381000"/>
+            <a:off x="6197156" y="4838700"/>
+            <a:ext cx="5270945" cy="381000"/>
           </a:xfrm>
           <a:prstGeom xmlns:a="http://schemas.openxmlformats.org/drawingml/2006/main" prst="rect">
             <a:avLst/>
@@ -14164,8 +14164,8 @@
         </p:nvSpPr>
         <p:spPr>
           <a:xfrm xmlns:a="http://schemas.openxmlformats.org/drawingml/2006/main">
-            <a:off x="6200775" y="5219700"/>
-            <a:ext cx="5457825" cy="638175"/>
+            <a:off x="6197156" y="5219700"/>
+            <a:ext cx="5270945" cy="638175"/>
           </a:xfrm>
           <a:prstGeom xmlns:a="http://schemas.openxmlformats.org/drawingml/2006/main" prst="rect">
             <a:avLst/>
@@ -14225,8 +14225,8 @@
         </p:nvSpPr>
         <p:spPr>
           <a:xfrm xmlns:a="http://schemas.openxmlformats.org/drawingml/2006/main">
-            <a:off x="533400" y="6105525"/>
-            <a:ext cx="38100" cy="304800"/>
+            <a:off x="723900" y="6105525"/>
+            <a:ext cx="36767" cy="304800"/>
           </a:xfrm>
           <a:prstGeom xmlns:a="http://schemas.openxmlformats.org/drawingml/2006/main" prst="rect">
             <a:avLst/>
@@ -14255,8 +14255,8 @@
         </p:nvSpPr>
         <p:spPr>
           <a:xfrm xmlns:a="http://schemas.openxmlformats.org/drawingml/2006/main">
-            <a:off x="733425" y="6076950"/>
-            <a:ext cx="10858500" cy="428625"/>
+            <a:off x="917067" y="6076950"/>
+            <a:ext cx="10486644" cy="428625"/>
           </a:xfrm>
           <a:prstGeom xmlns:a="http://schemas.openxmlformats.org/drawingml/2006/main" prst="rect">
             <a:avLst/>
@@ -14316,8 +14316,8 @@
         </p:nvSpPr>
         <p:spPr>
           <a:xfrm xmlns:a="http://schemas.openxmlformats.org/drawingml/2006/main">
-            <a:off x="533400" y="6562725"/>
-            <a:ext cx="9429750" cy="190500"/>
+            <a:off x="723900" y="6562725"/>
+            <a:ext cx="9106853" cy="190500"/>
           </a:xfrm>
           <a:prstGeom xmlns:a="http://schemas.openxmlformats.org/drawingml/2006/main" prst="rect">
             <a:avLst/>
@@ -14377,8 +14377,8 @@
         </p:nvSpPr>
         <p:spPr>
           <a:xfrm xmlns:a="http://schemas.openxmlformats.org/drawingml/2006/main">
-            <a:off x="10706100" y="6562725"/>
-            <a:ext cx="952500" cy="190500"/>
+            <a:off x="10548176" y="6562725"/>
+            <a:ext cx="919925" cy="190500"/>
           </a:xfrm>
           <a:prstGeom xmlns:a="http://schemas.openxmlformats.org/drawingml/2006/main" prst="rect">
             <a:avLst/>
@@ -14431,13 +14431,13 @@
           <p:nvPr/>
         </p:nvPicPr>
         <p:blipFill>
-          <a:blip xmlns:r="http://schemas.openxmlformats.org/officeDocument/2006/relationships" xmlns:a="http://schemas.openxmlformats.org/drawingml/2006/main" r:embed="R4d95481098864f29"/>
+          <a:blip xmlns:r="http://schemas.openxmlformats.org/officeDocument/2006/relationships" xmlns:a="http://schemas.openxmlformats.org/drawingml/2006/main" r:embed="R8ab79aa702db4de4"/>
           <a:stretch xmlns:a="http://schemas.openxmlformats.org/drawingml/2006/main"/>
         </p:blipFill>
         <p:spPr>
           <a:xfrm xmlns:a="http://schemas.openxmlformats.org/drawingml/2006/main">
-            <a:off x="533400" y="3114675"/>
-            <a:ext cx="5219700" cy="2217778"/>
+            <a:off x="723900" y="3228975"/>
+            <a:ext cx="4906518" cy="2084737"/>
           </a:xfrm>
           <a:prstGeom xmlns:a="http://schemas.openxmlformats.org/drawingml/2006/main" prst="rect">
             <a:avLst/>
@@ -14453,12 +14453,12 @@
           <p:nvPr/>
         </p:nvPicPr>
         <p:blipFill>
-          <a:blip xmlns:r="http://schemas.openxmlformats.org/officeDocument/2006/relationships" xmlns:a="http://schemas.openxmlformats.org/drawingml/2006/main" r:embed="R7b55d202c019425d"/>
+          <a:blip xmlns:r="http://schemas.openxmlformats.org/officeDocument/2006/relationships" xmlns:a="http://schemas.openxmlformats.org/drawingml/2006/main" r:embed="R3d81a5bb6c434c76"/>
           <a:stretch xmlns:a="http://schemas.openxmlformats.org/drawingml/2006/main"/>
         </p:blipFill>
         <p:spPr>
           <a:xfrm xmlns:a="http://schemas.openxmlformats.org/drawingml/2006/main">
-            <a:off x="10248900" y="361950"/>
+            <a:off x="10058400" y="400050"/>
             <a:ext cx="1409700" cy="323850"/>
           </a:xfrm>
           <a:prstGeom xmlns:a="http://schemas.openxmlformats.org/drawingml/2006/main" prst="rect">
@@ -14511,8 +14511,8 @@
         </p:nvSpPr>
         <p:spPr>
           <a:xfrm xmlns:a="http://schemas.openxmlformats.org/drawingml/2006/main">
-            <a:off x="533400" y="409575"/>
-            <a:ext cx="9334500" cy="238125"/>
+            <a:off x="723900" y="447675"/>
+            <a:ext cx="9014841" cy="238125"/>
           </a:xfrm>
           <a:prstGeom xmlns:a="http://schemas.openxmlformats.org/drawingml/2006/main" prst="rect">
             <a:avLst/>
@@ -14572,8 +14572,8 @@
         </p:nvSpPr>
         <p:spPr>
           <a:xfrm xmlns:a="http://schemas.openxmlformats.org/drawingml/2006/main">
-            <a:off x="533400" y="828675"/>
-            <a:ext cx="5619750" cy="1047750"/>
+            <a:off x="723900" y="904875"/>
+            <a:ext cx="5427250" cy="1047750"/>
           </a:xfrm>
           <a:prstGeom xmlns:a="http://schemas.openxmlformats.org/drawingml/2006/main" prst="rect">
             <a:avLst/>
@@ -14660,8 +14660,8 @@
         </p:nvSpPr>
         <p:spPr>
           <a:xfrm xmlns:a="http://schemas.openxmlformats.org/drawingml/2006/main">
-            <a:off x="533400" y="2705100"/>
-            <a:ext cx="5248275" cy="457200"/>
+            <a:off x="723900" y="2705100"/>
+            <a:ext cx="5068538" cy="457200"/>
           </a:xfrm>
           <a:prstGeom xmlns:a="http://schemas.openxmlformats.org/drawingml/2006/main" prst="rect">
             <a:avLst/>
@@ -14721,8 +14721,8 @@
         </p:nvSpPr>
         <p:spPr>
           <a:xfrm xmlns:a="http://schemas.openxmlformats.org/drawingml/2006/main">
-            <a:off x="533400" y="3162300"/>
-            <a:ext cx="5248275" cy="1009650"/>
+            <a:off x="723900" y="3162300"/>
+            <a:ext cx="5068538" cy="1009650"/>
           </a:xfrm>
           <a:prstGeom xmlns:a="http://schemas.openxmlformats.org/drawingml/2006/main" prst="rect">
             <a:avLst/>
@@ -14782,8 +14782,8 @@
         </p:nvSpPr>
         <p:spPr>
           <a:xfrm xmlns:a="http://schemas.openxmlformats.org/drawingml/2006/main">
-            <a:off x="533400" y="4333875"/>
-            <a:ext cx="5248275" cy="457200"/>
+            <a:off x="723900" y="4333875"/>
+            <a:ext cx="5068538" cy="457200"/>
           </a:xfrm>
           <a:prstGeom xmlns:a="http://schemas.openxmlformats.org/drawingml/2006/main" prst="rect">
             <a:avLst/>
@@ -14843,8 +14843,8 @@
         </p:nvSpPr>
         <p:spPr>
           <a:xfrm xmlns:a="http://schemas.openxmlformats.org/drawingml/2006/main">
-            <a:off x="533400" y="4791075"/>
-            <a:ext cx="5248275" cy="904875"/>
+            <a:off x="723900" y="4791075"/>
+            <a:ext cx="5068538" cy="904875"/>
           </a:xfrm>
           <a:prstGeom xmlns:a="http://schemas.openxmlformats.org/drawingml/2006/main" prst="rect">
             <a:avLst/>
@@ -14897,13 +14897,13 @@
           <p:nvPr/>
         </p:nvPicPr>
         <p:blipFill>
-          <a:blip xmlns:r="http://schemas.openxmlformats.org/officeDocument/2006/relationships" xmlns:a="http://schemas.openxmlformats.org/drawingml/2006/main" r:embed="R26c62129d2644e23"/>
+          <a:blip xmlns:r="http://schemas.openxmlformats.org/officeDocument/2006/relationships" xmlns:a="http://schemas.openxmlformats.org/drawingml/2006/main" r:embed="Rd53c3ae54bcc415a"/>
           <a:stretch xmlns:a="http://schemas.openxmlformats.org/drawingml/2006/main"/>
         </p:blipFill>
         <p:spPr>
           <a:xfrm xmlns:a="http://schemas.openxmlformats.org/drawingml/2006/main">
-            <a:off x="6343650" y="1704975"/>
-            <a:ext cx="5314950" cy="1913382"/>
+            <a:off x="6472047" y="1819275"/>
+            <a:ext cx="4996053" cy="1798606"/>
           </a:xfrm>
           <a:prstGeom xmlns:a="http://schemas.openxmlformats.org/drawingml/2006/main" prst="rect">
             <a:avLst/>
@@ -14919,7 +14919,7 @@
           <p:nvPr/>
         </p:nvPicPr>
         <p:blipFill>
-          <a:blip xmlns:r="http://schemas.openxmlformats.org/officeDocument/2006/relationships" xmlns:a="http://schemas.openxmlformats.org/drawingml/2006/main" r:embed="Rb1ec88c31eea41f6"/>
+          <a:blip xmlns:r="http://schemas.openxmlformats.org/officeDocument/2006/relationships" xmlns:a="http://schemas.openxmlformats.org/drawingml/2006/main" r:embed="R3fec63ef6b8b4775"/>
           <a:srcRect xmlns:a="http://schemas.openxmlformats.org/drawingml/2006/main" l="0" t="21741" r="0" b="21741"/>
           <a:stretch xmlns:a="http://schemas.openxmlformats.org/drawingml/2006/main">
             <a:fillRect l="0" t="0" r="0" b="0"/>
@@ -14927,8 +14927,8 @@
         </p:blipFill>
         <p:spPr>
           <a:xfrm xmlns:a="http://schemas.openxmlformats.org/drawingml/2006/main">
-            <a:off x="6343650" y="3800475"/>
-            <a:ext cx="5314950" cy="1685925"/>
+            <a:off x="6472047" y="3867150"/>
+            <a:ext cx="4996053" cy="1584770"/>
           </a:xfrm>
           <a:prstGeom xmlns:a="http://schemas.openxmlformats.org/drawingml/2006/main" prst="rect">
             <a:avLst/>
@@ -14951,8 +14951,8 @@
         </p:nvSpPr>
         <p:spPr>
           <a:xfrm xmlns:a="http://schemas.openxmlformats.org/drawingml/2006/main">
-            <a:off x="6343650" y="5619750"/>
-            <a:ext cx="5314950" cy="276225"/>
+            <a:off x="6472047" y="5566220"/>
+            <a:ext cx="5132927" cy="276225"/>
           </a:xfrm>
           <a:prstGeom xmlns:a="http://schemas.openxmlformats.org/drawingml/2006/main" prst="rect">
             <a:avLst/>
@@ -15012,8 +15012,8 @@
         </p:nvSpPr>
         <p:spPr>
           <a:xfrm xmlns:a="http://schemas.openxmlformats.org/drawingml/2006/main">
-            <a:off x="533400" y="6105525"/>
-            <a:ext cx="38100" cy="304800"/>
+            <a:off x="723900" y="6105525"/>
+            <a:ext cx="36767" cy="304800"/>
           </a:xfrm>
           <a:prstGeom xmlns:a="http://schemas.openxmlformats.org/drawingml/2006/main" prst="rect">
             <a:avLst/>
@@ -15042,8 +15042,8 @@
         </p:nvSpPr>
         <p:spPr>
           <a:xfrm xmlns:a="http://schemas.openxmlformats.org/drawingml/2006/main">
-            <a:off x="733425" y="6076950"/>
-            <a:ext cx="10858500" cy="428625"/>
+            <a:off x="917067" y="6076950"/>
+            <a:ext cx="10486644" cy="428625"/>
           </a:xfrm>
           <a:prstGeom xmlns:a="http://schemas.openxmlformats.org/drawingml/2006/main" prst="rect">
             <a:avLst/>
@@ -15103,8 +15103,8 @@
         </p:nvSpPr>
         <p:spPr>
           <a:xfrm xmlns:a="http://schemas.openxmlformats.org/drawingml/2006/main">
-            <a:off x="533400" y="6562725"/>
-            <a:ext cx="9429750" cy="190500"/>
+            <a:off x="723900" y="6562725"/>
+            <a:ext cx="9106853" cy="190500"/>
           </a:xfrm>
           <a:prstGeom xmlns:a="http://schemas.openxmlformats.org/drawingml/2006/main" prst="rect">
             <a:avLst/>
@@ -15164,8 +15164,8 @@
         </p:nvSpPr>
         <p:spPr>
           <a:xfrm xmlns:a="http://schemas.openxmlformats.org/drawingml/2006/main">
-            <a:off x="10706100" y="6562725"/>
-            <a:ext cx="952500" cy="190500"/>
+            <a:off x="10548176" y="6562725"/>
+            <a:ext cx="919925" cy="190500"/>
           </a:xfrm>
           <a:prstGeom xmlns:a="http://schemas.openxmlformats.org/drawingml/2006/main" prst="rect">
             <a:avLst/>
@@ -15218,12 +15218,12 @@
           <p:nvPr/>
         </p:nvPicPr>
         <p:blipFill>
-          <a:blip xmlns:r="http://schemas.openxmlformats.org/officeDocument/2006/relationships" xmlns:a="http://schemas.openxmlformats.org/drawingml/2006/main" r:embed="R9b21d00f4e694956"/>
+          <a:blip xmlns:r="http://schemas.openxmlformats.org/officeDocument/2006/relationships" xmlns:a="http://schemas.openxmlformats.org/drawingml/2006/main" r:embed="R0c63f230e1064e77"/>
           <a:stretch xmlns:a="http://schemas.openxmlformats.org/drawingml/2006/main"/>
         </p:blipFill>
         <p:spPr>
           <a:xfrm xmlns:a="http://schemas.openxmlformats.org/drawingml/2006/main">
-            <a:off x="10248900" y="361950"/>
+            <a:off x="10058400" y="400050"/>
             <a:ext cx="1409700" cy="323850"/>
           </a:xfrm>
           <a:prstGeom xmlns:a="http://schemas.openxmlformats.org/drawingml/2006/main" prst="rect">
@@ -15276,8 +15276,8 @@
         </p:nvSpPr>
         <p:spPr>
           <a:xfrm xmlns:a="http://schemas.openxmlformats.org/drawingml/2006/main">
-            <a:off x="533400" y="409575"/>
-            <a:ext cx="9334500" cy="238125"/>
+            <a:off x="723900" y="447675"/>
+            <a:ext cx="9014841" cy="238125"/>
           </a:xfrm>
           <a:prstGeom xmlns:a="http://schemas.openxmlformats.org/drawingml/2006/main" prst="rect">
             <a:avLst/>
@@ -15337,8 +15337,8 @@
         </p:nvSpPr>
         <p:spPr>
           <a:xfrm xmlns:a="http://schemas.openxmlformats.org/drawingml/2006/main">
-            <a:off x="533400" y="828675"/>
-            <a:ext cx="11125200" cy="1047750"/>
+            <a:off x="723900" y="904875"/>
+            <a:ext cx="10744200" cy="1047750"/>
           </a:xfrm>
           <a:prstGeom xmlns:a="http://schemas.openxmlformats.org/drawingml/2006/main" prst="rect">
             <a:avLst/>
@@ -15398,8 +15398,8 @@
         </p:nvSpPr>
         <p:spPr>
           <a:xfrm xmlns:a="http://schemas.openxmlformats.org/drawingml/2006/main">
-            <a:off x="533400" y="2143125"/>
-            <a:ext cx="4591050" cy="495300"/>
+            <a:off x="723900" y="2143125"/>
+            <a:ext cx="4433792" cy="495300"/>
           </a:xfrm>
           <a:prstGeom xmlns:a="http://schemas.openxmlformats.org/drawingml/2006/main" prst="rect">
             <a:avLst/>
@@ -15459,8 +15459,8 @@
         </p:nvSpPr>
         <p:spPr>
           <a:xfrm xmlns:a="http://schemas.openxmlformats.org/drawingml/2006/main">
-            <a:off x="533400" y="2638425"/>
-            <a:ext cx="4591050" cy="971550"/>
+            <a:off x="723900" y="2638425"/>
+            <a:ext cx="4433792" cy="971550"/>
           </a:xfrm>
           <a:prstGeom xmlns:a="http://schemas.openxmlformats.org/drawingml/2006/main" prst="rect">
             <a:avLst/>
@@ -15520,8 +15520,8 @@
         </p:nvSpPr>
         <p:spPr>
           <a:xfrm xmlns:a="http://schemas.openxmlformats.org/drawingml/2006/main">
-            <a:off x="533400" y="3800475"/>
-            <a:ext cx="4591050" cy="457200"/>
+            <a:off x="723900" y="3800475"/>
+            <a:ext cx="4433792" cy="457200"/>
           </a:xfrm>
           <a:prstGeom xmlns:a="http://schemas.openxmlformats.org/drawingml/2006/main" prst="rect">
             <a:avLst/>
@@ -15581,8 +15581,8 @@
         </p:nvSpPr>
         <p:spPr>
           <a:xfrm xmlns:a="http://schemas.openxmlformats.org/drawingml/2006/main">
-            <a:off x="533400" y="4257675"/>
-            <a:ext cx="4591050" cy="933450"/>
+            <a:off x="723900" y="4257675"/>
+            <a:ext cx="4433792" cy="933450"/>
           </a:xfrm>
           <a:prstGeom xmlns:a="http://schemas.openxmlformats.org/drawingml/2006/main" prst="rect">
             <a:avLst/>
@@ -15635,7 +15635,7 @@
           <p:nvPr/>
         </p:nvPicPr>
         <p:blipFill>
-          <a:blip xmlns:r="http://schemas.openxmlformats.org/officeDocument/2006/relationships" xmlns:a="http://schemas.openxmlformats.org/drawingml/2006/main" r:embed="R032bc2a3b73948ef"/>
+          <a:blip xmlns:r="http://schemas.openxmlformats.org/officeDocument/2006/relationships" xmlns:a="http://schemas.openxmlformats.org/drawingml/2006/main" r:embed="R5f772bcc4649421f"/>
           <a:srcRect xmlns:a="http://schemas.openxmlformats.org/drawingml/2006/main" l="0" t="7532" r="0" b="7532"/>
           <a:stretch xmlns:a="http://schemas.openxmlformats.org/drawingml/2006/main">
             <a:fillRect l="0" t="0" r="0" b="0"/>
@@ -15643,8 +15643,8 @@
         </p:blipFill>
         <p:spPr>
           <a:xfrm xmlns:a="http://schemas.openxmlformats.org/drawingml/2006/main">
-            <a:off x="5514975" y="1943100"/>
-            <a:ext cx="6143625" cy="3476625"/>
+            <a:off x="5534882" y="2057400"/>
+            <a:ext cx="5775008" cy="3268028"/>
           </a:xfrm>
           <a:prstGeom xmlns:a="http://schemas.openxmlformats.org/drawingml/2006/main" prst="rect">
             <a:avLst/>
@@ -15667,8 +15667,8 @@
         </p:nvSpPr>
         <p:spPr>
           <a:xfrm xmlns:a="http://schemas.openxmlformats.org/drawingml/2006/main">
-            <a:off x="5514975" y="5467350"/>
-            <a:ext cx="6143625" cy="257175"/>
+            <a:off x="5534882" y="5439728"/>
+            <a:ext cx="5933218" cy="257175"/>
           </a:xfrm>
           <a:prstGeom xmlns:a="http://schemas.openxmlformats.org/drawingml/2006/main" prst="rect">
             <a:avLst/>
@@ -15728,8 +15728,8 @@
         </p:nvSpPr>
         <p:spPr>
           <a:xfrm xmlns:a="http://schemas.openxmlformats.org/drawingml/2006/main">
-            <a:off x="533400" y="5724525"/>
-            <a:ext cx="11125200" cy="276225"/>
+            <a:off x="723900" y="5619750"/>
+            <a:ext cx="10744200" cy="276225"/>
           </a:xfrm>
           <a:prstGeom xmlns:a="http://schemas.openxmlformats.org/drawingml/2006/main" prst="rect">
             <a:avLst/>
@@ -15789,8 +15789,8 @@
         </p:nvSpPr>
         <p:spPr>
           <a:xfrm xmlns:a="http://schemas.openxmlformats.org/drawingml/2006/main">
-            <a:off x="533400" y="6105525"/>
-            <a:ext cx="38100" cy="304800"/>
+            <a:off x="723900" y="6105525"/>
+            <a:ext cx="36767" cy="304800"/>
           </a:xfrm>
           <a:prstGeom xmlns:a="http://schemas.openxmlformats.org/drawingml/2006/main" prst="rect">
             <a:avLst/>
@@ -15819,8 +15819,8 @@
         </p:nvSpPr>
         <p:spPr>
           <a:xfrm xmlns:a="http://schemas.openxmlformats.org/drawingml/2006/main">
-            <a:off x="733425" y="6076950"/>
-            <a:ext cx="10858500" cy="428625"/>
+            <a:off x="917067" y="6076950"/>
+            <a:ext cx="10486644" cy="428625"/>
           </a:xfrm>
           <a:prstGeom xmlns:a="http://schemas.openxmlformats.org/drawingml/2006/main" prst="rect">
             <a:avLst/>
@@ -15880,8 +15880,8 @@
         </p:nvSpPr>
         <p:spPr>
           <a:xfrm xmlns:a="http://schemas.openxmlformats.org/drawingml/2006/main">
-            <a:off x="533400" y="6562725"/>
-            <a:ext cx="9429750" cy="190500"/>
+            <a:off x="723900" y="6562725"/>
+            <a:ext cx="9106853" cy="190500"/>
           </a:xfrm>
           <a:prstGeom xmlns:a="http://schemas.openxmlformats.org/drawingml/2006/main" prst="rect">
             <a:avLst/>
@@ -15941,8 +15941,8 @@
         </p:nvSpPr>
         <p:spPr>
           <a:xfrm xmlns:a="http://schemas.openxmlformats.org/drawingml/2006/main">
-            <a:off x="10706100" y="6562725"/>
-            <a:ext cx="952500" cy="190500"/>
+            <a:off x="10548176" y="6562725"/>
+            <a:ext cx="919925" cy="190500"/>
           </a:xfrm>
           <a:prstGeom xmlns:a="http://schemas.openxmlformats.org/drawingml/2006/main" prst="rect">
             <a:avLst/>
@@ -15995,12 +15995,12 @@
           <p:nvPr/>
         </p:nvPicPr>
         <p:blipFill>
-          <a:blip xmlns:r="http://schemas.openxmlformats.org/officeDocument/2006/relationships" xmlns:a="http://schemas.openxmlformats.org/drawingml/2006/main" r:embed="R86d01d910f5c4a14"/>
+          <a:blip xmlns:r="http://schemas.openxmlformats.org/officeDocument/2006/relationships" xmlns:a="http://schemas.openxmlformats.org/drawingml/2006/main" r:embed="R8939c08f73ba4625"/>
           <a:stretch xmlns:a="http://schemas.openxmlformats.org/drawingml/2006/main"/>
         </p:blipFill>
         <p:spPr>
           <a:xfrm xmlns:a="http://schemas.openxmlformats.org/drawingml/2006/main">
-            <a:off x="10248900" y="361950"/>
+            <a:off x="10058400" y="400050"/>
             <a:ext cx="1409700" cy="323850"/>
           </a:xfrm>
           <a:prstGeom xmlns:a="http://schemas.openxmlformats.org/drawingml/2006/main" prst="rect">
@@ -16053,8 +16053,8 @@
         </p:nvSpPr>
         <p:spPr>
           <a:xfrm xmlns:a="http://schemas.openxmlformats.org/drawingml/2006/main">
-            <a:off x="533400" y="409575"/>
-            <a:ext cx="9334500" cy="238125"/>
+            <a:off x="723900" y="447675"/>
+            <a:ext cx="9014841" cy="238125"/>
           </a:xfrm>
           <a:prstGeom xmlns:a="http://schemas.openxmlformats.org/drawingml/2006/main" prst="rect">
             <a:avLst/>
@@ -16114,8 +16114,8 @@
         </p:nvSpPr>
         <p:spPr>
           <a:xfrm xmlns:a="http://schemas.openxmlformats.org/drawingml/2006/main">
-            <a:off x="533400" y="828675"/>
-            <a:ext cx="11125200" cy="1047750"/>
+            <a:off x="723900" y="904875"/>
+            <a:ext cx="10744200" cy="1047750"/>
           </a:xfrm>
           <a:prstGeom xmlns:a="http://schemas.openxmlformats.org/drawingml/2006/main" prst="rect">
             <a:avLst/>
@@ -16175,8 +16175,8 @@
         </p:nvSpPr>
         <p:spPr>
           <a:xfrm xmlns:a="http://schemas.openxmlformats.org/drawingml/2006/main">
-            <a:off x="6715125" y="2209800"/>
-            <a:ext cx="4943475" cy="457200"/>
+            <a:off x="6693884" y="2209800"/>
+            <a:ext cx="4774216" cy="457200"/>
           </a:xfrm>
           <a:prstGeom xmlns:a="http://schemas.openxmlformats.org/drawingml/2006/main" prst="rect">
             <a:avLst/>
@@ -16236,8 +16236,8 @@
         </p:nvSpPr>
         <p:spPr>
           <a:xfrm xmlns:a="http://schemas.openxmlformats.org/drawingml/2006/main">
-            <a:off x="6715125" y="2667000"/>
-            <a:ext cx="4943475" cy="1143000"/>
+            <a:off x="6693884" y="2667000"/>
+            <a:ext cx="4774216" cy="1143000"/>
           </a:xfrm>
           <a:prstGeom xmlns:a="http://schemas.openxmlformats.org/drawingml/2006/main" prst="rect">
             <a:avLst/>
@@ -16297,8 +16297,8 @@
         </p:nvSpPr>
         <p:spPr>
           <a:xfrm xmlns:a="http://schemas.openxmlformats.org/drawingml/2006/main">
-            <a:off x="6715125" y="4019550"/>
-            <a:ext cx="4943475" cy="457200"/>
+            <a:off x="6693884" y="4019550"/>
+            <a:ext cx="4774216" cy="457200"/>
           </a:xfrm>
           <a:prstGeom xmlns:a="http://schemas.openxmlformats.org/drawingml/2006/main" prst="rect">
             <a:avLst/>
@@ -16358,8 +16358,8 @@
         </p:nvSpPr>
         <p:spPr>
           <a:xfrm xmlns:a="http://schemas.openxmlformats.org/drawingml/2006/main">
-            <a:off x="6715125" y="4476750"/>
-            <a:ext cx="4943475" cy="1047750"/>
+            <a:off x="6693884" y="4476750"/>
+            <a:ext cx="4774216" cy="1047750"/>
           </a:xfrm>
           <a:prstGeom xmlns:a="http://schemas.openxmlformats.org/drawingml/2006/main" prst="rect">
             <a:avLst/>
@@ -16412,7 +16412,7 @@
           <p:nvPr/>
         </p:nvPicPr>
         <p:blipFill>
-          <a:blip xmlns:r="http://schemas.openxmlformats.org/officeDocument/2006/relationships" xmlns:a="http://schemas.openxmlformats.org/drawingml/2006/main" r:embed="R2452421f80bf4328"/>
+          <a:blip xmlns:r="http://schemas.openxmlformats.org/officeDocument/2006/relationships" xmlns:a="http://schemas.openxmlformats.org/drawingml/2006/main" r:embed="Rf1bfd9626b16448d"/>
           <a:srcRect xmlns:a="http://schemas.openxmlformats.org/drawingml/2006/main" l="4136" t="0" r="4136" b="0"/>
           <a:stretch xmlns:a="http://schemas.openxmlformats.org/drawingml/2006/main">
             <a:fillRect l="0" t="0" r="0" b="0"/>
@@ -16420,8 +16420,8 @@
         </p:blipFill>
         <p:spPr>
           <a:xfrm xmlns:a="http://schemas.openxmlformats.org/drawingml/2006/main">
-            <a:off x="533400" y="2105025"/>
-            <a:ext cx="5762625" cy="3533775"/>
+            <a:off x="723900" y="2181225"/>
+            <a:ext cx="5330476" cy="3268790"/>
           </a:xfrm>
           <a:prstGeom xmlns:a="http://schemas.openxmlformats.org/drawingml/2006/main" prst="rect">
             <a:avLst/>
@@ -16444,8 +16444,8 @@
         </p:nvSpPr>
         <p:spPr>
           <a:xfrm xmlns:a="http://schemas.openxmlformats.org/drawingml/2006/main">
-            <a:off x="533400" y="5724525"/>
-            <a:ext cx="5762625" cy="257175"/>
+            <a:off x="723900" y="5564314"/>
+            <a:ext cx="5565267" cy="257175"/>
           </a:xfrm>
           <a:prstGeom xmlns:a="http://schemas.openxmlformats.org/drawingml/2006/main" prst="rect">
             <a:avLst/>
@@ -16505,8 +16505,8 @@
         </p:nvSpPr>
         <p:spPr>
           <a:xfrm xmlns:a="http://schemas.openxmlformats.org/drawingml/2006/main">
-            <a:off x="533400" y="6105525"/>
-            <a:ext cx="38100" cy="304800"/>
+            <a:off x="723900" y="6105525"/>
+            <a:ext cx="36767" cy="304800"/>
           </a:xfrm>
           <a:prstGeom xmlns:a="http://schemas.openxmlformats.org/drawingml/2006/main" prst="rect">
             <a:avLst/>
@@ -16535,8 +16535,8 @@
         </p:nvSpPr>
         <p:spPr>
           <a:xfrm xmlns:a="http://schemas.openxmlformats.org/drawingml/2006/main">
-            <a:off x="733425" y="6076950"/>
-            <a:ext cx="10858500" cy="428625"/>
+            <a:off x="917067" y="6076950"/>
+            <a:ext cx="10486644" cy="428625"/>
           </a:xfrm>
           <a:prstGeom xmlns:a="http://schemas.openxmlformats.org/drawingml/2006/main" prst="rect">
             <a:avLst/>
@@ -16596,8 +16596,8 @@
         </p:nvSpPr>
         <p:spPr>
           <a:xfrm xmlns:a="http://schemas.openxmlformats.org/drawingml/2006/main">
-            <a:off x="533400" y="6562725"/>
-            <a:ext cx="9429750" cy="190500"/>
+            <a:off x="723900" y="6562725"/>
+            <a:ext cx="9106853" cy="190500"/>
           </a:xfrm>
           <a:prstGeom xmlns:a="http://schemas.openxmlformats.org/drawingml/2006/main" prst="rect">
             <a:avLst/>
@@ -16657,8 +16657,8 @@
         </p:nvSpPr>
         <p:spPr>
           <a:xfrm xmlns:a="http://schemas.openxmlformats.org/drawingml/2006/main">
-            <a:off x="10706100" y="6562725"/>
-            <a:ext cx="952500" cy="190500"/>
+            <a:off x="10548176" y="6562725"/>
+            <a:ext cx="919925" cy="190500"/>
           </a:xfrm>
           <a:prstGeom xmlns:a="http://schemas.openxmlformats.org/drawingml/2006/main" prst="rect">
             <a:avLst/>
@@ -16711,12 +16711,12 @@
           <p:nvPr/>
         </p:nvPicPr>
         <p:blipFill>
-          <a:blip xmlns:r="http://schemas.openxmlformats.org/officeDocument/2006/relationships" xmlns:a="http://schemas.openxmlformats.org/drawingml/2006/main" r:embed="Rea1059d26e9f4ecc"/>
+          <a:blip xmlns:r="http://schemas.openxmlformats.org/officeDocument/2006/relationships" xmlns:a="http://schemas.openxmlformats.org/drawingml/2006/main" r:embed="R34e583cffe6c4e0c"/>
           <a:stretch xmlns:a="http://schemas.openxmlformats.org/drawingml/2006/main"/>
         </p:blipFill>
         <p:spPr>
           <a:xfrm xmlns:a="http://schemas.openxmlformats.org/drawingml/2006/main">
-            <a:off x="10248900" y="361950"/>
+            <a:off x="10058400" y="400050"/>
             <a:ext cx="1409700" cy="323850"/>
           </a:xfrm>
           <a:prstGeom xmlns:a="http://schemas.openxmlformats.org/drawingml/2006/main" prst="rect">
@@ -16769,8 +16769,8 @@
         </p:nvSpPr>
         <p:spPr>
           <a:xfrm xmlns:a="http://schemas.openxmlformats.org/drawingml/2006/main">
-            <a:off x="533400" y="409575"/>
-            <a:ext cx="9334500" cy="238125"/>
+            <a:off x="723900" y="447675"/>
+            <a:ext cx="9014841" cy="238125"/>
           </a:xfrm>
           <a:prstGeom xmlns:a="http://schemas.openxmlformats.org/drawingml/2006/main" prst="rect">
             <a:avLst/>
@@ -16830,8 +16830,8 @@
         </p:nvSpPr>
         <p:spPr>
           <a:xfrm xmlns:a="http://schemas.openxmlformats.org/drawingml/2006/main">
-            <a:off x="533400" y="828675"/>
-            <a:ext cx="11125200" cy="1047750"/>
+            <a:off x="723900" y="904875"/>
+            <a:ext cx="10744200" cy="1047750"/>
           </a:xfrm>
           <a:prstGeom xmlns:a="http://schemas.openxmlformats.org/drawingml/2006/main" prst="rect">
             <a:avLst/>
@@ -16891,8 +16891,8 @@
         </p:nvSpPr>
         <p:spPr>
           <a:xfrm xmlns:a="http://schemas.openxmlformats.org/drawingml/2006/main">
-            <a:off x="533400" y="2066925"/>
-            <a:ext cx="5524500" cy="361950"/>
+            <a:off x="723900" y="2066925"/>
+            <a:ext cx="5335334" cy="361950"/>
           </a:xfrm>
           <a:prstGeom xmlns:a="http://schemas.openxmlformats.org/drawingml/2006/main" prst="rect">
             <a:avLst/>
@@ -16952,8 +16952,8 @@
         </p:nvSpPr>
         <p:spPr>
           <a:xfrm xmlns:a="http://schemas.openxmlformats.org/drawingml/2006/main">
-            <a:off x="533400" y="2428875"/>
-            <a:ext cx="5524500" cy="476250"/>
+            <a:off x="723900" y="2428875"/>
+            <a:ext cx="5335334" cy="476250"/>
           </a:xfrm>
           <a:prstGeom xmlns:a="http://schemas.openxmlformats.org/drawingml/2006/main" prst="rect">
             <a:avLst/>
@@ -17013,8 +17013,8 @@
         </p:nvSpPr>
         <p:spPr>
           <a:xfrm xmlns:a="http://schemas.openxmlformats.org/drawingml/2006/main">
-            <a:off x="533400" y="2933700"/>
-            <a:ext cx="5524500" cy="361950"/>
+            <a:off x="723900" y="2933700"/>
+            <a:ext cx="5335334" cy="361950"/>
           </a:xfrm>
           <a:prstGeom xmlns:a="http://schemas.openxmlformats.org/drawingml/2006/main" prst="rect">
             <a:avLst/>
@@ -17074,8 +17074,8 @@
         </p:nvSpPr>
         <p:spPr>
           <a:xfrm xmlns:a="http://schemas.openxmlformats.org/drawingml/2006/main">
-            <a:off x="533400" y="3295650"/>
-            <a:ext cx="5524500" cy="476250"/>
+            <a:off x="723900" y="3295650"/>
+            <a:ext cx="5335334" cy="476250"/>
           </a:xfrm>
           <a:prstGeom xmlns:a="http://schemas.openxmlformats.org/drawingml/2006/main" prst="rect">
             <a:avLst/>
@@ -17135,8 +17135,8 @@
         </p:nvSpPr>
         <p:spPr>
           <a:xfrm xmlns:a="http://schemas.openxmlformats.org/drawingml/2006/main">
-            <a:off x="533400" y="3800475"/>
-            <a:ext cx="5524500" cy="361950"/>
+            <a:off x="723900" y="3800475"/>
+            <a:ext cx="5335334" cy="361950"/>
           </a:xfrm>
           <a:prstGeom xmlns:a="http://schemas.openxmlformats.org/drawingml/2006/main" prst="rect">
             <a:avLst/>
@@ -17196,8 +17196,8 @@
         </p:nvSpPr>
         <p:spPr>
           <a:xfrm xmlns:a="http://schemas.openxmlformats.org/drawingml/2006/main">
-            <a:off x="533400" y="4162425"/>
-            <a:ext cx="5524500" cy="476250"/>
+            <a:off x="723900" y="4162425"/>
+            <a:ext cx="5335334" cy="476250"/>
           </a:xfrm>
           <a:prstGeom xmlns:a="http://schemas.openxmlformats.org/drawingml/2006/main" prst="rect">
             <a:avLst/>
@@ -17257,8 +17257,8 @@
         </p:nvSpPr>
         <p:spPr>
           <a:xfrm xmlns:a="http://schemas.openxmlformats.org/drawingml/2006/main">
-            <a:off x="533400" y="4667250"/>
-            <a:ext cx="5524500" cy="361950"/>
+            <a:off x="723900" y="4667250"/>
+            <a:ext cx="5335334" cy="361950"/>
           </a:xfrm>
           <a:prstGeom xmlns:a="http://schemas.openxmlformats.org/drawingml/2006/main" prst="rect">
             <a:avLst/>
@@ -17318,8 +17318,8 @@
         </p:nvSpPr>
         <p:spPr>
           <a:xfrm xmlns:a="http://schemas.openxmlformats.org/drawingml/2006/main">
-            <a:off x="533400" y="5029200"/>
-            <a:ext cx="5524500" cy="476250"/>
+            <a:off x="723900" y="5029200"/>
+            <a:ext cx="5335334" cy="476250"/>
           </a:xfrm>
           <a:prstGeom xmlns:a="http://schemas.openxmlformats.org/drawingml/2006/main" prst="rect">
             <a:avLst/>
@@ -17372,14 +17372,14 @@
           <p:nvPr/>
         </p:nvPicPr>
         <p:blipFill>
-          <a:blip xmlns:r="http://schemas.openxmlformats.org/officeDocument/2006/relationships" xmlns:a="http://schemas.openxmlformats.org/drawingml/2006/main" r:embed="Rd8c4762881ee458e"/>
+          <a:blip xmlns:r="http://schemas.openxmlformats.org/officeDocument/2006/relationships" xmlns:a="http://schemas.openxmlformats.org/drawingml/2006/main" r:embed="R785335dcf5804677"/>
           <a:srcRect xmlns:a="http://schemas.openxmlformats.org/drawingml/2006/main" l="0" t="0" r="0" b="0"/>
           <a:stretch xmlns:a="http://schemas.openxmlformats.org/drawingml/2006/main"/>
         </p:blipFill>
         <p:spPr>
           <a:xfrm xmlns:a="http://schemas.openxmlformats.org/drawingml/2006/main">
-            <a:off x="6363582" y="2266950"/>
-            <a:ext cx="5246511" cy="2724150"/>
+            <a:off x="6445187" y="2390775"/>
+            <a:ext cx="5022914" cy="2560701"/>
           </a:xfrm>
           <a:prstGeom xmlns:a="http://schemas.openxmlformats.org/drawingml/2006/main" prst="rect">
             <a:avLst/>
@@ -17402,8 +17402,8 @@
         </p:nvSpPr>
         <p:spPr>
           <a:xfrm xmlns:a="http://schemas.openxmlformats.org/drawingml/2006/main">
-            <a:off x="6315075" y="5133975"/>
-            <a:ext cx="5343525" cy="333375"/>
+            <a:off x="6445187" y="5065776"/>
+            <a:ext cx="5160550" cy="333375"/>
           </a:xfrm>
           <a:prstGeom xmlns:a="http://schemas.openxmlformats.org/drawingml/2006/main" prst="rect">
             <a:avLst/>
@@ -17463,8 +17463,8 @@
         </p:nvSpPr>
         <p:spPr>
           <a:xfrm xmlns:a="http://schemas.openxmlformats.org/drawingml/2006/main">
-            <a:off x="533400" y="5591175"/>
-            <a:ext cx="11125200" cy="342900"/>
+            <a:off x="723900" y="5543550"/>
+            <a:ext cx="10744200" cy="342900"/>
           </a:xfrm>
           <a:prstGeom xmlns:a="http://schemas.openxmlformats.org/drawingml/2006/main" prst="rect">
             <a:avLst/>
@@ -17524,8 +17524,8 @@
         </p:nvSpPr>
         <p:spPr>
           <a:xfrm xmlns:a="http://schemas.openxmlformats.org/drawingml/2006/main">
-            <a:off x="533400" y="6105525"/>
-            <a:ext cx="38100" cy="304800"/>
+            <a:off x="723900" y="6105525"/>
+            <a:ext cx="36767" cy="304800"/>
           </a:xfrm>
           <a:prstGeom xmlns:a="http://schemas.openxmlformats.org/drawingml/2006/main" prst="rect">
             <a:avLst/>
@@ -17554,8 +17554,8 @@
         </p:nvSpPr>
         <p:spPr>
           <a:xfrm xmlns:a="http://schemas.openxmlformats.org/drawingml/2006/main">
-            <a:off x="733425" y="6076950"/>
-            <a:ext cx="10858500" cy="428625"/>
+            <a:off x="917067" y="6076950"/>
+            <a:ext cx="10486644" cy="428625"/>
           </a:xfrm>
           <a:prstGeom xmlns:a="http://schemas.openxmlformats.org/drawingml/2006/main" prst="rect">
             <a:avLst/>
@@ -17615,8 +17615,8 @@
         </p:nvSpPr>
         <p:spPr>
           <a:xfrm xmlns:a="http://schemas.openxmlformats.org/drawingml/2006/main">
-            <a:off x="533400" y="6562725"/>
-            <a:ext cx="9429750" cy="190500"/>
+            <a:off x="723900" y="6562725"/>
+            <a:ext cx="9106853" cy="190500"/>
           </a:xfrm>
           <a:prstGeom xmlns:a="http://schemas.openxmlformats.org/drawingml/2006/main" prst="rect">
             <a:avLst/>
@@ -17676,8 +17676,8 @@
         </p:nvSpPr>
         <p:spPr>
           <a:xfrm xmlns:a="http://schemas.openxmlformats.org/drawingml/2006/main">
-            <a:off x="10706100" y="6562725"/>
-            <a:ext cx="952500" cy="190500"/>
+            <a:off x="10548176" y="6562725"/>
+            <a:ext cx="919925" cy="190500"/>
           </a:xfrm>
           <a:prstGeom xmlns:a="http://schemas.openxmlformats.org/drawingml/2006/main" prst="rect">
             <a:avLst/>
@@ -17730,12 +17730,12 @@
           <p:nvPr/>
         </p:nvPicPr>
         <p:blipFill>
-          <a:blip xmlns:r="http://schemas.openxmlformats.org/officeDocument/2006/relationships" xmlns:a="http://schemas.openxmlformats.org/drawingml/2006/main" r:embed="Rb6aef2ea135b4fd0"/>
+          <a:blip xmlns:r="http://schemas.openxmlformats.org/officeDocument/2006/relationships" xmlns:a="http://schemas.openxmlformats.org/drawingml/2006/main" r:embed="R3c1a94d1780b4cde"/>
           <a:stretch xmlns:a="http://schemas.openxmlformats.org/drawingml/2006/main"/>
         </p:blipFill>
         <p:spPr>
           <a:xfrm xmlns:a="http://schemas.openxmlformats.org/drawingml/2006/main">
-            <a:off x="10248900" y="361950"/>
+            <a:off x="10058400" y="400050"/>
             <a:ext cx="1409700" cy="323850"/>
           </a:xfrm>
           <a:prstGeom xmlns:a="http://schemas.openxmlformats.org/drawingml/2006/main" prst="rect">
@@ -17788,8 +17788,8 @@
         </p:nvSpPr>
         <p:spPr>
           <a:xfrm xmlns:a="http://schemas.openxmlformats.org/drawingml/2006/main">
-            <a:off x="533400" y="409575"/>
-            <a:ext cx="9334500" cy="238125"/>
+            <a:off x="723900" y="447675"/>
+            <a:ext cx="9014841" cy="238125"/>
           </a:xfrm>
           <a:prstGeom xmlns:a="http://schemas.openxmlformats.org/drawingml/2006/main" prst="rect">
             <a:avLst/>
@@ -17849,8 +17849,8 @@
         </p:nvSpPr>
         <p:spPr>
           <a:xfrm xmlns:a="http://schemas.openxmlformats.org/drawingml/2006/main">
-            <a:off x="533400" y="828675"/>
-            <a:ext cx="5953125" cy="1381125"/>
+            <a:off x="723900" y="904875"/>
+            <a:ext cx="5749290" cy="1381125"/>
           </a:xfrm>
           <a:prstGeom xmlns:a="http://schemas.openxmlformats.org/drawingml/2006/main" prst="rect">
             <a:avLst/>
@@ -17937,8 +17937,8 @@
         </p:nvSpPr>
         <p:spPr>
           <a:xfrm xmlns:a="http://schemas.openxmlformats.org/drawingml/2006/main">
-            <a:off x="533400" y="2276475"/>
-            <a:ext cx="5419725" cy="981075"/>
+            <a:off x="723900" y="2333625"/>
+            <a:ext cx="5234083" cy="981075"/>
           </a:xfrm>
           <a:prstGeom xmlns:a="http://schemas.openxmlformats.org/drawingml/2006/main" prst="rect">
             <a:avLst/>
@@ -17991,7 +17991,7 @@
           <p:nvPr/>
         </p:nvPicPr>
         <p:blipFill>
-          <a:blip xmlns:r="http://schemas.openxmlformats.org/officeDocument/2006/relationships" xmlns:a="http://schemas.openxmlformats.org/drawingml/2006/main" r:embed="R328de2adb8ba4d4e"/>
+          <a:blip xmlns:r="http://schemas.openxmlformats.org/officeDocument/2006/relationships" xmlns:a="http://schemas.openxmlformats.org/drawingml/2006/main" r:embed="R683fc1262f884234"/>
           <a:srcRect xmlns:a="http://schemas.openxmlformats.org/drawingml/2006/main" l="0" t="15816" r="0" b="15816"/>
           <a:stretch xmlns:a="http://schemas.openxmlformats.org/drawingml/2006/main">
             <a:fillRect l="0" t="0" r="0" b="0"/>
@@ -17999,8 +17999,8 @@
         </p:blipFill>
         <p:spPr>
           <a:xfrm xmlns:a="http://schemas.openxmlformats.org/drawingml/2006/main">
-            <a:off x="533400" y="3533775"/>
-            <a:ext cx="5419725" cy="2085975"/>
+            <a:off x="723900" y="3533775"/>
+            <a:ext cx="5094542" cy="1960817"/>
           </a:xfrm>
           <a:prstGeom xmlns:a="http://schemas.openxmlformats.org/drawingml/2006/main" prst="rect">
             <a:avLst/>
@@ -18023,8 +18023,8 @@
         </p:nvSpPr>
         <p:spPr>
           <a:xfrm xmlns:a="http://schemas.openxmlformats.org/drawingml/2006/main">
-            <a:off x="533400" y="5724525"/>
-            <a:ext cx="5419725" cy="247650"/>
+            <a:off x="723900" y="5608892"/>
+            <a:ext cx="5234083" cy="247650"/>
           </a:xfrm>
           <a:prstGeom xmlns:a="http://schemas.openxmlformats.org/drawingml/2006/main" prst="rect">
             <a:avLst/>
@@ -18084,8 +18084,8 @@
         </p:nvSpPr>
         <p:spPr>
           <a:xfrm xmlns:a="http://schemas.openxmlformats.org/drawingml/2006/main">
-            <a:off x="6562725" y="2314575"/>
-            <a:ext cx="5095875" cy="400050"/>
+            <a:off x="6546723" y="2314575"/>
+            <a:ext cx="4921377" cy="400050"/>
           </a:xfrm>
           <a:prstGeom xmlns:a="http://schemas.openxmlformats.org/drawingml/2006/main" prst="rect">
             <a:avLst/>
@@ -18145,8 +18145,8 @@
         </p:nvSpPr>
         <p:spPr>
           <a:xfrm xmlns:a="http://schemas.openxmlformats.org/drawingml/2006/main">
-            <a:off x="6562725" y="2714625"/>
-            <a:ext cx="5095875" cy="723900"/>
+            <a:off x="6546723" y="2714625"/>
+            <a:ext cx="4921377" cy="723900"/>
           </a:xfrm>
           <a:prstGeom xmlns:a="http://schemas.openxmlformats.org/drawingml/2006/main" prst="rect">
             <a:avLst/>
@@ -18206,8 +18206,8 @@
         </p:nvSpPr>
         <p:spPr>
           <a:xfrm xmlns:a="http://schemas.openxmlformats.org/drawingml/2006/main">
-            <a:off x="6562725" y="3495675"/>
-            <a:ext cx="5095875" cy="400050"/>
+            <a:off x="6546723" y="3495675"/>
+            <a:ext cx="4921377" cy="400050"/>
           </a:xfrm>
           <a:prstGeom xmlns:a="http://schemas.openxmlformats.org/drawingml/2006/main" prst="rect">
             <a:avLst/>
@@ -18267,8 +18267,8 @@
         </p:nvSpPr>
         <p:spPr>
           <a:xfrm xmlns:a="http://schemas.openxmlformats.org/drawingml/2006/main">
-            <a:off x="6562725" y="3895725"/>
-            <a:ext cx="5095875" cy="723900"/>
+            <a:off x="6546723" y="3895725"/>
+            <a:ext cx="4921377" cy="723900"/>
           </a:xfrm>
           <a:prstGeom xmlns:a="http://schemas.openxmlformats.org/drawingml/2006/main" prst="rect">
             <a:avLst/>
@@ -18328,8 +18328,8 @@
         </p:nvSpPr>
         <p:spPr>
           <a:xfrm xmlns:a="http://schemas.openxmlformats.org/drawingml/2006/main">
-            <a:off x="6562725" y="4676775"/>
-            <a:ext cx="5095875" cy="400050"/>
+            <a:off x="6546723" y="4676775"/>
+            <a:ext cx="4921377" cy="400050"/>
           </a:xfrm>
           <a:prstGeom xmlns:a="http://schemas.openxmlformats.org/drawingml/2006/main" prst="rect">
             <a:avLst/>
@@ -18389,8 +18389,8 @@
         </p:nvSpPr>
         <p:spPr>
           <a:xfrm xmlns:a="http://schemas.openxmlformats.org/drawingml/2006/main">
-            <a:off x="6562725" y="5076825"/>
-            <a:ext cx="5095875" cy="723900"/>
+            <a:off x="6546723" y="5076825"/>
+            <a:ext cx="4921377" cy="723900"/>
           </a:xfrm>
           <a:prstGeom xmlns:a="http://schemas.openxmlformats.org/drawingml/2006/main" prst="rect">
             <a:avLst/>
@@ -18450,8 +18450,8 @@
         </p:nvSpPr>
         <p:spPr>
           <a:xfrm xmlns:a="http://schemas.openxmlformats.org/drawingml/2006/main">
-            <a:off x="533400" y="6105525"/>
-            <a:ext cx="38100" cy="304800"/>
+            <a:off x="723900" y="6105525"/>
+            <a:ext cx="36767" cy="304800"/>
           </a:xfrm>
           <a:prstGeom xmlns:a="http://schemas.openxmlformats.org/drawingml/2006/main" prst="rect">
             <a:avLst/>
@@ -18480,8 +18480,8 @@
         </p:nvSpPr>
         <p:spPr>
           <a:xfrm xmlns:a="http://schemas.openxmlformats.org/drawingml/2006/main">
-            <a:off x="733425" y="6076950"/>
-            <a:ext cx="10858500" cy="428625"/>
+            <a:off x="917067" y="6076950"/>
+            <a:ext cx="10486644" cy="428625"/>
           </a:xfrm>
           <a:prstGeom xmlns:a="http://schemas.openxmlformats.org/drawingml/2006/main" prst="rect">
             <a:avLst/>
@@ -18541,8 +18541,8 @@
         </p:nvSpPr>
         <p:spPr>
           <a:xfrm xmlns:a="http://schemas.openxmlformats.org/drawingml/2006/main">
-            <a:off x="533400" y="6562725"/>
-            <a:ext cx="9429750" cy="190500"/>
+            <a:off x="723900" y="6562725"/>
+            <a:ext cx="9106853" cy="190500"/>
           </a:xfrm>
           <a:prstGeom xmlns:a="http://schemas.openxmlformats.org/drawingml/2006/main" prst="rect">
             <a:avLst/>
@@ -18602,8 +18602,8 @@
         </p:nvSpPr>
         <p:spPr>
           <a:xfrm xmlns:a="http://schemas.openxmlformats.org/drawingml/2006/main">
-            <a:off x="10706100" y="6562725"/>
-            <a:ext cx="952500" cy="190500"/>
+            <a:off x="10548176" y="6562725"/>
+            <a:ext cx="919925" cy="190500"/>
           </a:xfrm>
           <a:prstGeom xmlns:a="http://schemas.openxmlformats.org/drawingml/2006/main" prst="rect">
             <a:avLst/>
@@ -18656,12 +18656,12 @@
           <p:nvPr/>
         </p:nvPicPr>
         <p:blipFill>
-          <a:blip xmlns:r="http://schemas.openxmlformats.org/officeDocument/2006/relationships" xmlns:a="http://schemas.openxmlformats.org/drawingml/2006/main" r:embed="Rca3dd967b837468c"/>
+          <a:blip xmlns:r="http://schemas.openxmlformats.org/officeDocument/2006/relationships" xmlns:a="http://schemas.openxmlformats.org/drawingml/2006/main" r:embed="R31e4bcbb28cd446b"/>
           <a:stretch xmlns:a="http://schemas.openxmlformats.org/drawingml/2006/main"/>
         </p:blipFill>
         <p:spPr>
           <a:xfrm xmlns:a="http://schemas.openxmlformats.org/drawingml/2006/main">
-            <a:off x="10248900" y="361950"/>
+            <a:off x="10058400" y="400050"/>
             <a:ext cx="1409700" cy="323850"/>
           </a:xfrm>
           <a:prstGeom xmlns:a="http://schemas.openxmlformats.org/drawingml/2006/main" prst="rect">

</xml_diff>